<commit_message>
Nuclear: nukeval.py (validacion de eps y estabilidad), nukeDBSCAN_arnau.py simplificado sin barrido; informe y pptx actualizados
Co-Authored-By: Claude Sonnet 5.5 <noreply@anthropic.com>
Claude-Session: https://claude.ai/code/session_01Q6fDk4UWe6v6CR3QJZP5xS
</commit_message>
<xml_diff>
--- a/presentacion/expo_cpia.pptx
+++ b/presentacion/expo_cpia.pptx
@@ -4905,7 +4905,7 @@
               <a:defRPr sz="3200" b="1"/>
             </a:pPr>
             <a:r>
-              <a:t>Elegir los parámetros</a:t>
+              <a:t>Elegir y validar los parámetros</a:t>
             </a:r>
           </a:p>
         </p:txBody>
@@ -4939,7 +4939,7 @@
               <a:defRPr sz="2000" b="0"/>
             </a:pPr>
             <a:r>
-              <a:t>• Barrido de eps con un 10 % aleatorio de los datos</a:t>
+              <a:t>• Optimizador por F1 (con etiquetas): DBSCAN una vez por (eps, vmin) y todas las ventanas de profundidad</a:t>
             </a:r>
           </a:p>
           <a:p>
@@ -4950,7 +4950,7 @@
               <a:defRPr sz="2000" b="0"/>
             </a:pPr>
             <a:r>
-              <a:t>• Optimizador por F1: DBSCAN una vez por (eps, vmin) y todas las ventanas de profundidad sobre esos clusters</a:t>
+              <a:t>• Óptimo: eps = 25 km, vmin = 1, profundidad [0; 0,1) km</a:t>
             </a:r>
           </a:p>
           <a:p>
@@ -4961,14 +4961,36 @@
               <a:defRPr sz="2000" b="0"/>
             </a:pPr>
             <a:r>
-              <a:t>• Óptimo: eps = 25 km, vmin = 1, profundidad [0; 0,1) km</a:t>
+              <a:t>• La silueta no elige eps (es negativa y baja con eps); el codo de distancias k no marca un valor claro</a:t>
+            </a:r>
+          </a:p>
+          <a:p>
+            <a:pPr>
+              <a:spcAft>
+                <a:spcPts val="800"/>
+              </a:spcAft>
+              <a:defRPr sz="2000" b="0"/>
+            </a:pPr>
+            <a:r>
+              <a:t>• Con eps ≥ 50 km los FN se disparan (261): los grupos se funden con terremotos profundos</a:t>
+            </a:r>
+          </a:p>
+          <a:p>
+            <a:pPr>
+              <a:spcAft>
+                <a:spcPts val="800"/>
+              </a:spcAft>
+              <a:defRPr sz="2000" b="0"/>
+            </a:pPr>
+            <a:r>
+              <a:t>• Estabilidad (ARI, muestra del 50 %): 0,52-0,62</a:t>
             </a:r>
           </a:p>
         </p:txBody>
       </p:sp>
       <p:pic>
         <p:nvPicPr>
-          <p:cNvPr id="4" name="Picture 3" descr="barrido_eps.png"/>
+          <p:cNvPr id="4" name="Picture 3" descr="nukeval_eps.png"/>
           <p:cNvPicPr>
             <a:picLocks noChangeAspect="1"/>
           </p:cNvPicPr>
@@ -4983,7 +5005,7 @@
         <p:spPr>
           <a:xfrm>
             <a:off x="5394960" y="1371600"/>
-            <a:ext cx="6217920" cy="3375442"/>
+            <a:ext cx="6583680" cy="1786999"/>
           </a:xfrm>
           <a:prstGeom prst="rect">
             <a:avLst/>

</xml_diff>

<commit_message>
Nuclear: parametros fijos (ventana 0-2.5 km), nukedatos.py, informe y pptx actualizados; optimizador sin uso
Co-Authored-By: Claude Sonnet 5.5 <noreply@anthropic.com>
Claude-Session: https://claude.ai/code/session_01Q6fDk4UWe6v6CR3QJZP5xS
</commit_message>
<xml_diff>
--- a/presentacion/expo_cpia.pptx
+++ b/presentacion/expo_cpia.pptx
@@ -4939,7 +4939,7 @@
               <a:defRPr sz="2000" b="0"/>
             </a:pPr>
             <a:r>
-              <a:t>• Optimizador por F1 (con etiquetas): DBSCAN una vez por (eps, vmin) y todas las ventanas de profundidad</a:t>
+              <a:t>• Parámetros fijos: eps = 25 km, vmin = 1, profundidad mediana en [0; 2,5) km (criterio físico)</a:t>
             </a:r>
           </a:p>
           <a:p>
@@ -4950,7 +4950,7 @@
               <a:defRPr sz="2000" b="0"/>
             </a:pPr>
             <a:r>
-              <a:t>• Óptimo: eps = 25 km, vmin = 1, profundidad [0; 0,1) km</a:t>
+              <a:t>• eps = 25 km da el mínimo de falsos positivos (91) entre 5 y 100 km; es la única elección que mira la etiqueta</a:t>
             </a:r>
           </a:p>
           <a:p>
@@ -4972,7 +4972,7 @@
               <a:defRPr sz="2000" b="0"/>
             </a:pPr>
             <a:r>
-              <a:t>• Con eps ≥ 50 km los FN se disparan (261): los grupos se funden con terremotos profundos</a:t>
+              <a:t>• Con eps ≥ 50 km los grupos se funden con terremotos profundos: FP 460 (50 km) y FN 261 (75 km)</a:t>
             </a:r>
           </a:p>
           <a:p>
@@ -4984,6 +4984,17 @@
             </a:pPr>
             <a:r>
               <a:t>• Estabilidad (ARI, muestra del 50 %): 0,52-0,62</a:t>
+            </a:r>
+          </a:p>
+          <a:p>
+            <a:pPr>
+              <a:spcAft>
+                <a:spcPts val="800"/>
+              </a:spcAft>
+              <a:defRPr sz="2000" b="0"/>
+            </a:pPr>
+            <a:r>
+              <a:t>• nuke_optimizar.py se probó y se descartó: su ventana [0; 0,1) mide la convención del USGS</a:t>
             </a:r>
           </a:p>
         </p:txBody>
@@ -5093,7 +5104,7 @@
               <a:defRPr sz="2000" b="0"/>
             </a:pPr>
             <a:r>
-              <a:t>• 585 aciertos, 36 FP, 29 FN</a:t>
+              <a:t>• 586 aciertos, 91 FP, 28 FN</a:t>
             </a:r>
           </a:p>
           <a:p>
@@ -5104,7 +5115,7 @@
               <a:defRPr sz="2000" b="0"/>
             </a:pPr>
             <a:r>
-              <a:t>• Precisión 94,2 %  ·  recall 95,3 %  ·  F1 = 0,947</a:t>
+              <a:t>• Precisión 86,6 %  ·  recall 95,4 %  ·  F1 = 0,908</a:t>
             </a:r>
           </a:p>
           <a:p>
@@ -5225,7 +5236,7 @@
               <a:defRPr sz="2000" b="0"/>
             </a:pPr>
             <a:r>
-              <a:t>• vmin = 1: no hay ruido; la selección real la hace la profundidad. Con vmin = 3, F1 baja a 0,928</a:t>
+              <a:t>• vmin = 1: no hay ruido; la selección real la hace la profundidad. Con vmin = 3, F1 baja a 0,910</a:t>
             </a:r>
           </a:p>
           <a:p>
@@ -5236,7 +5247,18 @@
               <a:defRPr sz="2000" b="0"/>
             </a:pPr>
             <a:r>
-              <a:t>• Sobreajuste: parámetros elegidos y evaluados con los mismos datos. Cruzado entre catálogos: F1 0,855 (pequeño→grande) y 0,977 (grande→pequeño)</a:t>
+              <a:t>• Mismos parámetros en los dos catálogos: F1 0,908 (grande) y 0,955 (pequeño); sin conjunto de prueba separado</a:t>
+            </a:r>
+          </a:p>
+          <a:p>
+            <a:pPr>
+              <a:spcAft>
+                <a:spcPts val="800"/>
+              </a:spcAft>
+              <a:defRPr sz="2000" b="0"/>
+            </a:pPr>
+            <a:r>
+              <a:t>• El 85 % de las explosiones figura con profundidad 0,0 km en el USGS: una ventana [0; 0,1) daría F1 0,947, pero mediría esa convención</a:t>
             </a:r>
           </a:p>
           <a:p>

</xml_diff>

<commit_message>
feat(presentacion): crear diapositivas e integrar presentacion de materiales con notas de orador
</commit_message>
<xml_diff>
--- a/presentacion/expo_cpia.pptx
+++ b/presentacion/expo_cpia.pptx
@@ -19,6 +19,10 @@
     <p:sldId id="267" r:id="rId19"/>
     <p:sldId id="268" r:id="rId20"/>
     <p:sldId id="269" r:id="rId21"/>
+    <p:sldId id="270" r:id="rId22"/>
+    <p:sldId id="271" r:id="rId23"/>
+    <p:sldId id="272" r:id="rId24"/>
+    <p:sldId id="273" r:id="rId25"/>
   </p:sldIdLst>
   <p:sldSz cx="12191695" cy="6858000" type="screen4x3"/>
   <p:notesSz cx="6858000" cy="9144000"/>
@@ -516,6 +520,216 @@
           <a:p>
             <a:r>
               <a:t>Zoom en Nevada: a la izquierda los epicentros, a la derecha los clusters; en morado los sospechosos.</a:t>
+            </a:r>
+          </a:p>
+        </p:txBody>
+      </p:sp>
+      <p:sp>
+        <p:nvSpPr>
+          <p:cNvPr id="4" name="Slide Number Placeholder 3"/>
+          <p:cNvSpPr>
+            <a:spLocks noGrp="1"/>
+          </p:cNvSpPr>
+          <p:nvPr>
+            <p:ph type="sldNum" idx="5" sz="quarter"/>
+          </p:nvPr>
+        </p:nvSpPr>
+        <p:spPr/>
+      </p:sp>
+    </p:spTree>
+  </p:cSld>
+  <p:clrMapOvr>
+    <a:masterClrMapping/>
+  </p:clrMapOvr>
+</p:notes>
+</file>
+
+<file path=ppt/notesSlides/notesSlide2.xml><?xml version="1.0" encoding="utf-8"?>
+<p:notes xmlns:a="http://schemas.openxmlformats.org/drawingml/2006/main" xmlns:p="http://schemas.openxmlformats.org/presentationml/2006/main" xmlns:r="http://schemas.openxmlformats.org/officeDocument/2006/relationships">
+  <p:cSld>
+    <p:spTree>
+      <p:nvGrpSpPr>
+        <p:cNvPr id="1" name=""/>
+        <p:cNvGrpSpPr/>
+        <p:nvPr/>
+      </p:nvGrpSpPr>
+      <p:grpSpPr>
+        <a:xfrm>
+          <a:off x="0" y="0"/>
+          <a:ext cx="0" cy="0"/>
+          <a:chOff x="0" y="0"/>
+          <a:chExt cx="0" cy="0"/>
+        </a:xfrm>
+      </p:grpSpPr>
+      <p:sp>
+        <p:nvSpPr>
+          <p:cNvPr id="2" name="Slide Image Placeholder 1"/>
+          <p:cNvSpPr>
+            <a:spLocks noGrp="1"/>
+          </p:cNvSpPr>
+          <p:nvPr>
+            <p:ph type="sldImg" idx="2"/>
+          </p:nvPr>
+        </p:nvSpPr>
+        <p:spPr/>
+      </p:sp>
+      <p:sp>
+        <p:nvSpPr>
+          <p:cNvPr id="3" name="Notes Placeholder 2"/>
+          <p:cNvSpPr>
+            <a:spLocks noGrp="1"/>
+          </p:cNvSpPr>
+          <p:nvPr>
+            <p:ph type="body" idx="3" sz="quarter"/>
+          </p:nvPr>
+        </p:nvSpPr>
+        <p:spPr/>
+        <p:txBody>
+          <a:bodyPr/>
+          <a:lstStyle/>
+          <a:p>
+            <a:r>
+              <a:t>Uriel presenta el problema: la resistividad macroscópica y su derivada térmica frente a temperatura identifican si un material es conductor, semiconductor o aislante.</a:t>
+            </a:r>
+          </a:p>
+        </p:txBody>
+      </p:sp>
+      <p:sp>
+        <p:nvSpPr>
+          <p:cNvPr id="4" name="Slide Number Placeholder 3"/>
+          <p:cNvSpPr>
+            <a:spLocks noGrp="1"/>
+          </p:cNvSpPr>
+          <p:nvPr>
+            <p:ph type="sldNum" idx="5" sz="quarter"/>
+          </p:nvPr>
+        </p:nvSpPr>
+        <p:spPr/>
+      </p:sp>
+    </p:spTree>
+  </p:cSld>
+  <p:clrMapOvr>
+    <a:masterClrMapping/>
+  </p:clrMapOvr>
+</p:notes>
+</file>
+
+<file path=ppt/notesSlides/notesSlide3.xml><?xml version="1.0" encoding="utf-8"?>
+<p:notes xmlns:a="http://schemas.openxmlformats.org/drawingml/2006/main" xmlns:p="http://schemas.openxmlformats.org/presentationml/2006/main" xmlns:r="http://schemas.openxmlformats.org/officeDocument/2006/relationships">
+  <p:cSld>
+    <p:spTree>
+      <p:nvGrpSpPr>
+        <p:cNvPr id="1" name=""/>
+        <p:cNvGrpSpPr/>
+        <p:nvPr/>
+      </p:nvGrpSpPr>
+      <p:grpSpPr>
+        <a:xfrm>
+          <a:off x="0" y="0"/>
+          <a:ext cx="0" cy="0"/>
+          <a:chOff x="0" y="0"/>
+          <a:chExt cx="0" cy="0"/>
+        </a:xfrm>
+      </p:grpSpPr>
+      <p:sp>
+        <p:nvSpPr>
+          <p:cNvPr id="2" name="Slide Image Placeholder 1"/>
+          <p:cNvSpPr>
+            <a:spLocks noGrp="1"/>
+          </p:cNvSpPr>
+          <p:nvPr>
+            <p:ph type="sldImg" idx="2"/>
+          </p:nvPr>
+        </p:nvSpPr>
+        <p:spPr/>
+      </p:sp>
+      <p:sp>
+        <p:nvSpPr>
+          <p:cNvPr id="3" name="Notes Placeholder 2"/>
+          <p:cNvSpPr>
+            <a:spLocks noGrp="1"/>
+          </p:cNvSpPr>
+          <p:nvPr>
+            <p:ph type="body" idx="3" sz="quarter"/>
+          </p:nvPr>
+        </p:nvSpPr>
+        <p:spPr/>
+        <p:txBody>
+          <a:bodyPr/>
+          <a:lstStyle/>
+          <a:p>
+            <a:r>
+              <a:t>Explicación de la estandarización Z manual con NumPy y la justificación matemática de los hiperparámetros.</a:t>
+            </a:r>
+          </a:p>
+        </p:txBody>
+      </p:sp>
+      <p:sp>
+        <p:nvSpPr>
+          <p:cNvPr id="4" name="Slide Number Placeholder 3"/>
+          <p:cNvSpPr>
+            <a:spLocks noGrp="1"/>
+          </p:cNvSpPr>
+          <p:nvPr>
+            <p:ph type="sldNum" idx="5" sz="quarter"/>
+          </p:nvPr>
+        </p:nvSpPr>
+        <p:spPr/>
+      </p:sp>
+    </p:spTree>
+  </p:cSld>
+  <p:clrMapOvr>
+    <a:masterClrMapping/>
+  </p:clrMapOvr>
+</p:notes>
+</file>
+
+<file path=ppt/notesSlides/notesSlide4.xml><?xml version="1.0" encoding="utf-8"?>
+<p:notes xmlns:a="http://schemas.openxmlformats.org/drawingml/2006/main" xmlns:p="http://schemas.openxmlformats.org/presentationml/2006/main" xmlns:r="http://schemas.openxmlformats.org/officeDocument/2006/relationships">
+  <p:cSld>
+    <p:spTree>
+      <p:nvGrpSpPr>
+        <p:cNvPr id="1" name=""/>
+        <p:cNvGrpSpPr/>
+        <p:nvPr/>
+      </p:nvGrpSpPr>
+      <p:grpSpPr>
+        <a:xfrm>
+          <a:off x="0" y="0"/>
+          <a:ext cx="0" cy="0"/>
+          <a:chOff x="0" y="0"/>
+          <a:chExt cx="0" cy="0"/>
+        </a:xfrm>
+      </p:grpSpPr>
+      <p:sp>
+        <p:nvSpPr>
+          <p:cNvPr id="2" name="Slide Image Placeholder 1"/>
+          <p:cNvSpPr>
+            <a:spLocks noGrp="1"/>
+          </p:cNvSpPr>
+          <p:nvPr>
+            <p:ph type="sldImg" idx="2"/>
+          </p:nvPr>
+        </p:nvSpPr>
+        <p:spPr/>
+      </p:sp>
+      <p:sp>
+        <p:nvSpPr>
+          <p:cNvPr id="3" name="Notes Placeholder 2"/>
+          <p:cNvSpPr>
+            <a:spLocks noGrp="1"/>
+          </p:cNvSpPr>
+          <p:nvPr>
+            <p:ph type="body" idx="3" sz="quarter"/>
+          </p:nvPr>
+        </p:nvSpPr>
+        <p:spPr/>
+        <p:txBody>
+          <a:bodyPr/>
+          <a:lstStyle/>
+          <a:p>
+            <a:r>
+              <a:t>El gráfico muestra la clara separación; la línea discontinua de alfa = 0 separa el régimen de fonones del de activación térmica.</a:t>
             </a:r>
           </a:p>
         </p:txBody>
@@ -3902,7 +4116,7 @@
               <a:defRPr sz="3200" b="1"/>
             </a:pPr>
             <a:r>
-              <a:t>Problema de Uriel</a:t>
+              <a:t>Problema: Clasificación de materiales eléctricos</a:t>
             </a:r>
           </a:p>
         </p:txBody>
@@ -3928,43 +4142,48 @@
             <a:spAutoFit/>
           </a:bodyPr>
           <a:lstStyle/>
-          <a:p/>
-        </p:txBody>
-      </p:sp>
-      <p:sp>
-        <p:nvSpPr>
-          <p:cNvPr id="4" name="TextBox 3"/>
-          <p:cNvSpPr txBox="1"/>
-          <p:nvPr/>
-        </p:nvSpPr>
-        <p:spPr>
-          <a:xfrm>
-            <a:off x="548640" y="5852160"/>
-            <a:ext cx="10972800" cy="731520"/>
-          </a:xfrm>
-          <a:prstGeom prst="rect">
-            <a:avLst/>
-          </a:prstGeom>
-          <a:noFill/>
-        </p:spPr>
-        <p:txBody>
-          <a:bodyPr wrap="square">
-            <a:spAutoFit/>
-          </a:bodyPr>
-          <a:lstStyle/>
-          <a:p>
-            <a:pPr>
-              <a:spcAft>
-                <a:spcPts val="800"/>
-              </a:spcAft>
-              <a:defRPr sz="1800" b="1">
-                <a:solidFill>
-                  <a:srgbClr val="B03030"/>
-                </a:solidFill>
-              </a:defRPr>
-            </a:pPr>
-            <a:r>
-              <a:t>[PENDIENTE: título, datos, método, resultado, figuras]</a:t>
+          <a:p>
+            <a:pPr>
+              <a:spcAft>
+                <a:spcPts val="800"/>
+              </a:spcAft>
+              <a:defRPr sz="2000" b="0"/>
+            </a:pPr>
+            <a:r>
+              <a:t>• ¿Se pueden descubrir las fases de la materia sin etiquetas?</a:t>
+            </a:r>
+          </a:p>
+          <a:p>
+            <a:pPr>
+              <a:spcAft>
+                <a:spcPts val="800"/>
+              </a:spcAft>
+              <a:defRPr sz="2000" b="0"/>
+            </a:pPr>
+            <a:r>
+              <a:t>• Espacio de características físicas: (log₁₀(ρ₃₀₀K), α)</a:t>
+            </a:r>
+          </a:p>
+          <a:p>
+            <a:pPr>
+              <a:spcAft>
+                <a:spcPts val="800"/>
+              </a:spcAft>
+              <a:defRPr sz="2000" b="0"/>
+            </a:pPr>
+            <a:r>
+              <a:t>• La resistividad abarca más de 30 órdenes de magnitud (10⁻⁸ a 10²² Ω·m)</a:t>
+            </a:r>
+          </a:p>
+          <a:p>
+            <a:pPr>
+              <a:spcAft>
+                <a:spcPts val="800"/>
+              </a:spcAft>
+              <a:defRPr sz="2000" b="0"/>
+            </a:pPr>
+            <a:r>
+              <a:t>• El coeficiente térmico α delata la estructura cuántica de bandas</a:t>
             </a:r>
           </a:p>
         </p:txBody>
@@ -4016,7 +4235,7 @@
               <a:defRPr sz="3200" b="1"/>
             </a:pPr>
             <a:r>
-              <a:t>Conclusiones</a:t>
+              <a:t>Física cuántica y por qué DBSCAN</a:t>
             </a:r>
           </a:p>
         </p:txBody>
@@ -4042,43 +4261,48 @@
             <a:spAutoFit/>
           </a:bodyPr>
           <a:lstStyle/>
-          <a:p/>
-        </p:txBody>
-      </p:sp>
-      <p:sp>
-        <p:nvSpPr>
-          <p:cNvPr id="4" name="TextBox 3"/>
-          <p:cNvSpPr txBox="1"/>
-          <p:nvPr/>
-        </p:nvSpPr>
-        <p:spPr>
-          <a:xfrm>
-            <a:off x="548640" y="5852160"/>
-            <a:ext cx="10972800" cy="731520"/>
-          </a:xfrm>
-          <a:prstGeom prst="rect">
-            <a:avLst/>
-          </a:prstGeom>
-          <a:noFill/>
-        </p:spPr>
-        <p:txBody>
-          <a:bodyPr wrap="square">
-            <a:spAutoFit/>
-          </a:bodyPr>
-          <a:lstStyle/>
-          <a:p>
-            <a:pPr>
-              <a:spcAft>
-                <a:spcPts val="800"/>
-              </a:spcAft>
-              <a:defRPr sz="1800" b="1">
-                <a:solidFill>
-                  <a:srgbClr val="B03030"/>
-                </a:solidFill>
-              </a:defRPr>
-            </a:pPr>
-            <a:r>
-              <a:t>[PENDIENTE: comparativa del equipo: qué algoritmo funcionó mejor y por qué]</a:t>
+          <a:p>
+            <a:pPr>
+              <a:spcAft>
+                <a:spcPts val="800"/>
+              </a:spcAft>
+              <a:defRPr sz="2000" b="0"/>
+            </a:pPr>
+            <a:r>
+              <a:t>• Metales (banda semillena): α &gt; 0 por choques con fonones (mar de Fermi)</a:t>
+            </a:r>
+          </a:p>
+          <a:p>
+            <a:pPr>
+              <a:spcAft>
+                <a:spcPts val="800"/>
+              </a:spcAft>
+              <a:defRPr sz="2000" b="0"/>
+            </a:pPr>
+            <a:r>
+              <a:t>• Semiconductores (gap moderado): α &lt; 0 por activación térmica de Boltzmann</a:t>
+            </a:r>
+          </a:p>
+          <a:p>
+            <a:pPr>
+              <a:spcAft>
+                <a:spcPts val="800"/>
+              </a:spcAft>
+              <a:defRPr sz="2000" b="0"/>
+            </a:pPr>
+            <a:r>
+              <a:t>• Aislantes (gap enorme &gt; 5 eV): α ≈ 0 y resistividad extrema (&gt; 10¹¹ Ω·m)</a:t>
+            </a:r>
+          </a:p>
+          <a:p>
+            <a:pPr>
+              <a:spcAft>
+                <a:spcPts val="800"/>
+              </a:spcAft>
+              <a:defRPr sz="2000" b="0"/>
+            </a:pPr>
+            <a:r>
+              <a:t>• ¿Por qué DBSCAN?: K-Means asume grupos esféricos e isodensos; DBSCAN respeta densidades desiguales (metales densos vs aislantes dispersos)</a:t>
             </a:r>
           </a:p>
         </p:txBody>
@@ -4092,6 +4316,512 @@
 </file>
 
 <file path=ppt/slides/slide14.xml><?xml version="1.0" encoding="utf-8"?>
+<p:sld xmlns:a="http://schemas.openxmlformats.org/drawingml/2006/main" xmlns:p="http://schemas.openxmlformats.org/presentationml/2006/main" xmlns:r="http://schemas.openxmlformats.org/officeDocument/2006/relationships">
+  <p:cSld>
+    <p:spTree>
+      <p:nvGrpSpPr>
+        <p:cNvPr id="1" name=""/>
+        <p:cNvGrpSpPr/>
+        <p:nvPr/>
+      </p:nvGrpSpPr>
+      <p:grpSpPr/>
+      <p:sp>
+        <p:nvSpPr>
+          <p:cNvPr id="2" name="TextBox 1"/>
+          <p:cNvSpPr txBox="1"/>
+          <p:nvPr/>
+        </p:nvSpPr>
+        <p:spPr>
+          <a:xfrm>
+            <a:off x="548640" y="320040"/>
+            <a:ext cx="10972800" cy="914400"/>
+          </a:xfrm>
+          <a:prstGeom prst="rect">
+            <a:avLst/>
+          </a:prstGeom>
+          <a:noFill/>
+        </p:spPr>
+        <p:txBody>
+          <a:bodyPr wrap="square">
+            <a:spAutoFit/>
+          </a:bodyPr>
+          <a:lstStyle/>
+          <a:p>
+            <a:pPr>
+              <a:spcAft>
+                <a:spcPts val="800"/>
+              </a:spcAft>
+              <a:defRPr sz="3200" b="1"/>
+            </a:pPr>
+            <a:r>
+              <a:t>Metodología: Escala y parámetros</a:t>
+            </a:r>
+          </a:p>
+        </p:txBody>
+      </p:sp>
+      <p:sp>
+        <p:nvSpPr>
+          <p:cNvPr id="3" name="TextBox 2"/>
+          <p:cNvSpPr txBox="1"/>
+          <p:nvPr/>
+        </p:nvSpPr>
+        <p:spPr>
+          <a:xfrm>
+            <a:off x="548640" y="1371600"/>
+            <a:ext cx="10972800" cy="4572000"/>
+          </a:xfrm>
+          <a:prstGeom prst="rect">
+            <a:avLst/>
+          </a:prstGeom>
+          <a:noFill/>
+        </p:spPr>
+        <p:txBody>
+          <a:bodyPr wrap="square">
+            <a:spAutoFit/>
+          </a:bodyPr>
+          <a:lstStyle/>
+          <a:p>
+            <a:pPr>
+              <a:spcAft>
+                <a:spcPts val="800"/>
+              </a:spcAft>
+              <a:defRPr sz="2000" b="0"/>
+            </a:pPr>
+            <a:r>
+              <a:t>• Estandarización manual Z-score: Z = (X - μ) / σ vectorialmente con NumPy</a:t>
+            </a:r>
+          </a:p>
+          <a:p>
+            <a:pPr>
+              <a:spcAft>
+                <a:spcPts val="800"/>
+              </a:spcAft>
+              <a:defRPr sz="2000" b="0"/>
+            </a:pPr>
+            <a:r>
+              <a:t>• Imprescindible: equipara el rango de log₁₀ρ (~31) con el de α (~0,08)</a:t>
+            </a:r>
+          </a:p>
+          <a:p>
+            <a:pPr>
+              <a:spcAft>
+                <a:spcPts val="800"/>
+              </a:spcAft>
+              <a:defRPr sz="2000" b="0"/>
+            </a:pPr>
+            <a:r>
+              <a:t>• DBSCAN con scikit-learn: eps = 0,65, min_samples = 3 (dimensión d = 2)</a:t>
+            </a:r>
+          </a:p>
+          <a:p>
+            <a:pPr>
+              <a:spcAft>
+                <a:spcPts val="800"/>
+              </a:spcAft>
+              <a:defRPr sz="2000" b="0"/>
+            </a:pPr>
+            <a:r>
+              <a:t>• Determinación objetiva de eps mediante codo k-NN y silueta</a:t>
+            </a:r>
+          </a:p>
+        </p:txBody>
+      </p:sp>
+    </p:spTree>
+  </p:cSld>
+  <p:clrMapOvr>
+    <a:masterClrMapping/>
+  </p:clrMapOvr>
+</p:sld>
+</file>
+
+<file path=ppt/slides/slide15.xml><?xml version="1.0" encoding="utf-8"?>
+<p:sld xmlns:a="http://schemas.openxmlformats.org/drawingml/2006/main" xmlns:p="http://schemas.openxmlformats.org/presentationml/2006/main" xmlns:r="http://schemas.openxmlformats.org/officeDocument/2006/relationships">
+  <p:cSld>
+    <p:spTree>
+      <p:nvGrpSpPr>
+        <p:cNvPr id="1" name=""/>
+        <p:cNvGrpSpPr/>
+        <p:nvPr/>
+      </p:nvGrpSpPr>
+      <p:grpSpPr/>
+      <p:sp>
+        <p:nvSpPr>
+          <p:cNvPr id="2" name="TextBox 1"/>
+          <p:cNvSpPr txBox="1"/>
+          <p:nvPr/>
+        </p:nvSpPr>
+        <p:spPr>
+          <a:xfrm>
+            <a:off x="548640" y="320040"/>
+            <a:ext cx="10972800" cy="914400"/>
+          </a:xfrm>
+          <a:prstGeom prst="rect">
+            <a:avLst/>
+          </a:prstGeom>
+          <a:noFill/>
+        </p:spPr>
+        <p:txBody>
+          <a:bodyPr wrap="square">
+            <a:spAutoFit/>
+          </a:bodyPr>
+          <a:lstStyle/>
+          <a:p>
+            <a:pPr>
+              <a:spcAft>
+                <a:spcPts val="800"/>
+              </a:spcAft>
+              <a:defRPr sz="3200" b="1"/>
+            </a:pPr>
+            <a:r>
+              <a:t>Resultado: DBSCAN en 57 materiales</a:t>
+            </a:r>
+          </a:p>
+        </p:txBody>
+      </p:sp>
+      <p:sp>
+        <p:nvSpPr>
+          <p:cNvPr id="3" name="TextBox 2"/>
+          <p:cNvSpPr txBox="1"/>
+          <p:nvPr/>
+        </p:nvSpPr>
+        <p:spPr>
+          <a:xfrm>
+            <a:off x="548640" y="1371600"/>
+            <a:ext cx="4754880" cy="4572000"/>
+          </a:xfrm>
+          <a:prstGeom prst="rect">
+            <a:avLst/>
+          </a:prstGeom>
+          <a:noFill/>
+        </p:spPr>
+        <p:txBody>
+          <a:bodyPr wrap="square">
+            <a:spAutoFit/>
+          </a:bodyPr>
+          <a:lstStyle/>
+          <a:p>
+            <a:pPr>
+              <a:spcAft>
+                <a:spcPts val="800"/>
+              </a:spcAft>
+              <a:defRPr sz="2000" b="0"/>
+            </a:pPr>
+            <a:r>
+              <a:t>• 3 clusters puros descubiertos por densidad: 0 ruido</a:t>
+            </a:r>
+          </a:p>
+          <a:p>
+            <a:pPr>
+              <a:spcAft>
+                <a:spcPts val="800"/>
+              </a:spcAft>
+              <a:defRPr sz="2000" b="0"/>
+            </a:pPr>
+            <a:r>
+              <a:t>• Cluster 0 (ámbar): 35 metales conductores (Cu, Ag, Au, Al...)</a:t>
+            </a:r>
+          </a:p>
+          <a:p>
+            <a:pPr>
+              <a:spcAft>
+                <a:spcPts val="800"/>
+              </a:spcAft>
+              <a:defRPr sz="2000" b="0"/>
+            </a:pPr>
+            <a:r>
+              <a:t>• Cluster 1 (azul): 10 aislantes dieléctricos (vidrio, teflón, cuarzo...)</a:t>
+            </a:r>
+          </a:p>
+          <a:p>
+            <a:pPr>
+              <a:spcAft>
+                <a:spcPts val="800"/>
+              </a:spcAft>
+              <a:defRPr sz="2000" b="0"/>
+            </a:pPr>
+            <a:r>
+              <a:t>• Cluster 2 (verde): 10 semiconductores (Si, Ge, GaAs, InP...)</a:t>
+            </a:r>
+          </a:p>
+          <a:p>
+            <a:pPr>
+              <a:spcAft>
+                <a:spcPts val="800"/>
+              </a:spcAft>
+              <a:defRPr sz="2000" b="0"/>
+            </a:pPr>
+            <a:r>
+              <a:t>• Silhouette Score: 0,7858 (separación inter-cluster sobresaliente)</a:t>
+            </a:r>
+          </a:p>
+        </p:txBody>
+      </p:sp>
+      <p:pic>
+        <p:nvPicPr>
+          <p:cNvPr id="4" name="Picture 3" descr="clusters_materiales_dbscan.png"/>
+          <p:cNvPicPr>
+            <a:picLocks noChangeAspect="1"/>
+          </p:cNvPicPr>
+          <p:nvPr/>
+        </p:nvPicPr>
+        <p:blipFill>
+          <a:blip r:embed="rId2"/>
+          <a:stretch>
+            <a:fillRect/>
+          </a:stretch>
+        </p:blipFill>
+        <p:spPr>
+          <a:xfrm>
+            <a:off x="5394960" y="1371600"/>
+            <a:ext cx="6583680" cy="4279392"/>
+          </a:xfrm>
+          <a:prstGeom prst="rect">
+            <a:avLst/>
+          </a:prstGeom>
+        </p:spPr>
+      </p:pic>
+    </p:spTree>
+  </p:cSld>
+  <p:clrMapOvr>
+    <a:masterClrMapping/>
+  </p:clrMapOvr>
+</p:sld>
+</file>
+
+<file path=ppt/slides/slide16.xml><?xml version="1.0" encoding="utf-8"?>
+<p:sld xmlns:a="http://schemas.openxmlformats.org/drawingml/2006/main" xmlns:p="http://schemas.openxmlformats.org/presentationml/2006/main" xmlns:r="http://schemas.openxmlformats.org/officeDocument/2006/relationships">
+  <p:cSld>
+    <p:spTree>
+      <p:nvGrpSpPr>
+        <p:cNvPr id="1" name=""/>
+        <p:cNvGrpSpPr/>
+        <p:nvPr/>
+      </p:nvGrpSpPr>
+      <p:grpSpPr/>
+      <p:sp>
+        <p:nvSpPr>
+          <p:cNvPr id="2" name="TextBox 1"/>
+          <p:cNvSpPr txBox="1"/>
+          <p:nvPr/>
+        </p:nvSpPr>
+        <p:spPr>
+          <a:xfrm>
+            <a:off x="548640" y="320040"/>
+            <a:ext cx="10972800" cy="914400"/>
+          </a:xfrm>
+          <a:prstGeom prst="rect">
+            <a:avLst/>
+          </a:prstGeom>
+          <a:noFill/>
+        </p:spPr>
+        <p:txBody>
+          <a:bodyPr wrap="square">
+            <a:spAutoFit/>
+          </a:bodyPr>
+          <a:lstStyle/>
+          <a:p>
+            <a:pPr>
+              <a:spcAft>
+                <a:spcPts val="800"/>
+              </a:spcAft>
+              <a:defRPr sz="3200" b="1"/>
+            </a:pPr>
+            <a:r>
+              <a:t>Validación y defensa</a:t>
+            </a:r>
+          </a:p>
+        </p:txBody>
+      </p:sp>
+      <p:sp>
+        <p:nvSpPr>
+          <p:cNvPr id="3" name="TextBox 2"/>
+          <p:cNvSpPr txBox="1"/>
+          <p:nvPr/>
+        </p:nvSpPr>
+        <p:spPr>
+          <a:xfrm>
+            <a:off x="548640" y="1371600"/>
+            <a:ext cx="10972800" cy="4572000"/>
+          </a:xfrm>
+          <a:prstGeom prst="rect">
+            <a:avLst/>
+          </a:prstGeom>
+          <a:noFill/>
+        </p:spPr>
+        <p:txBody>
+          <a:bodyPr wrap="square">
+            <a:spAutoFit/>
+          </a:bodyPr>
+          <a:lstStyle/>
+          <a:p>
+            <a:pPr>
+              <a:spcAft>
+                <a:spcPts val="800"/>
+              </a:spcAft>
+              <a:defRPr sz="2000" b="0"/>
+            </a:pPr>
+            <a:r>
+              <a:t>• Matriz de contingencia: 100 % de pureza en conductores y aislantes</a:t>
+            </a:r>
+          </a:p>
+          <a:p>
+            <a:pPr>
+              <a:spcAft>
+                <a:spcPts val="800"/>
+              </a:spcAft>
+              <a:defRPr sz="2000" b="0"/>
+            </a:pPr>
+            <a:r>
+              <a:t>• 2 semimetales clasificados en el cluster 0 por su resistividad cuasi-metálica</a:t>
+            </a:r>
+          </a:p>
+          <a:p>
+            <a:pPr>
+              <a:spcAft>
+                <a:spcPts val="800"/>
+              </a:spcAft>
+              <a:defRPr sz="2000" b="0"/>
+            </a:pPr>
+            <a:r>
+              <a:t>• eps &lt; 0,4 fragmenta los aislantes en ruido; eps &gt; 1,0 funde semiconductores con metales</a:t>
+            </a:r>
+          </a:p>
+          <a:p>
+            <a:pPr>
+              <a:spcAft>
+                <a:spcPts val="800"/>
+              </a:spcAft>
+              <a:defRPr sz="2000" b="0"/>
+            </a:pPr>
+            <a:r>
+              <a:t>• Usar conductividad lineal σ colapsaría el 99 % de los puntos en el origen: log₁₀ρ es obligatoria</a:t>
+            </a:r>
+          </a:p>
+        </p:txBody>
+      </p:sp>
+    </p:spTree>
+  </p:cSld>
+  <p:clrMapOvr>
+    <a:masterClrMapping/>
+  </p:clrMapOvr>
+</p:sld>
+</file>
+
+<file path=ppt/slides/slide17.xml><?xml version="1.0" encoding="utf-8"?>
+<p:sld xmlns:a="http://schemas.openxmlformats.org/drawingml/2006/main" xmlns:p="http://schemas.openxmlformats.org/presentationml/2006/main" xmlns:r="http://schemas.openxmlformats.org/officeDocument/2006/relationships">
+  <p:cSld>
+    <p:spTree>
+      <p:nvGrpSpPr>
+        <p:cNvPr id="1" name=""/>
+        <p:cNvGrpSpPr/>
+        <p:nvPr/>
+      </p:nvGrpSpPr>
+      <p:grpSpPr/>
+      <p:sp>
+        <p:nvSpPr>
+          <p:cNvPr id="2" name="TextBox 1"/>
+          <p:cNvSpPr txBox="1"/>
+          <p:nvPr/>
+        </p:nvSpPr>
+        <p:spPr>
+          <a:xfrm>
+            <a:off x="548640" y="320040"/>
+            <a:ext cx="10972800" cy="914400"/>
+          </a:xfrm>
+          <a:prstGeom prst="rect">
+            <a:avLst/>
+          </a:prstGeom>
+          <a:noFill/>
+        </p:spPr>
+        <p:txBody>
+          <a:bodyPr wrap="square">
+            <a:spAutoFit/>
+          </a:bodyPr>
+          <a:lstStyle/>
+          <a:p>
+            <a:pPr>
+              <a:spcAft>
+                <a:spcPts val="800"/>
+              </a:spcAft>
+              <a:defRPr sz="3200" b="1"/>
+            </a:pPr>
+            <a:r>
+              <a:t>Conclusiones</a:t>
+            </a:r>
+          </a:p>
+        </p:txBody>
+      </p:sp>
+      <p:sp>
+        <p:nvSpPr>
+          <p:cNvPr id="3" name="TextBox 2"/>
+          <p:cNvSpPr txBox="1"/>
+          <p:nvPr/>
+        </p:nvSpPr>
+        <p:spPr>
+          <a:xfrm>
+            <a:off x="548640" y="1371600"/>
+            <a:ext cx="10972800" cy="4572000"/>
+          </a:xfrm>
+          <a:prstGeom prst="rect">
+            <a:avLst/>
+          </a:prstGeom>
+          <a:noFill/>
+        </p:spPr>
+        <p:txBody>
+          <a:bodyPr wrap="square">
+            <a:spAutoFit/>
+          </a:bodyPr>
+          <a:lstStyle/>
+          <a:p/>
+        </p:txBody>
+      </p:sp>
+      <p:sp>
+        <p:nvSpPr>
+          <p:cNvPr id="4" name="TextBox 3"/>
+          <p:cNvSpPr txBox="1"/>
+          <p:nvPr/>
+        </p:nvSpPr>
+        <p:spPr>
+          <a:xfrm>
+            <a:off x="548640" y="5852160"/>
+            <a:ext cx="10972800" cy="731520"/>
+          </a:xfrm>
+          <a:prstGeom prst="rect">
+            <a:avLst/>
+          </a:prstGeom>
+          <a:noFill/>
+        </p:spPr>
+        <p:txBody>
+          <a:bodyPr wrap="square">
+            <a:spAutoFit/>
+          </a:bodyPr>
+          <a:lstStyle/>
+          <a:p>
+            <a:pPr>
+              <a:spcAft>
+                <a:spcPts val="800"/>
+              </a:spcAft>
+              <a:defRPr sz="1800" b="1">
+                <a:solidFill>
+                  <a:srgbClr val="B03030"/>
+                </a:solidFill>
+              </a:defRPr>
+            </a:pPr>
+            <a:r>
+              <a:t>[PENDIENTE: comparativa del equipo: qué algoritmo funcionó mejor y por qué]</a:t>
+            </a:r>
+          </a:p>
+        </p:txBody>
+      </p:sp>
+    </p:spTree>
+  </p:cSld>
+  <p:clrMapOvr>
+    <a:masterClrMapping/>
+  </p:clrMapOvr>
+</p:sld>
+</file>
+
+<file path=ppt/slides/slide18.xml><?xml version="1.0" encoding="utf-8"?>
 <p:sld xmlns:a="http://schemas.openxmlformats.org/drawingml/2006/main" xmlns:p="http://schemas.openxmlformats.org/presentationml/2006/main" xmlns:r="http://schemas.openxmlformats.org/officeDocument/2006/relationships">
   <p:cSld>
     <p:spTree>

</xml_diff>

<commit_message>
feat(presentacion): redisenar diapositivas de Uriel con minimo texto y mas soporte visual
</commit_message>
<xml_diff>
--- a/presentacion/expo_cpia.pptx
+++ b/presentacion/expo_cpia.pptx
@@ -23,6 +23,7 @@
     <p:sldId id="271" r:id="rId23"/>
     <p:sldId id="272" r:id="rId24"/>
     <p:sldId id="273" r:id="rId25"/>
+    <p:sldId id="274" r:id="rId26"/>
   </p:sldIdLst>
   <p:sldSz cx="12191695" cy="6858000" type="screen4x3"/>
   <p:notesSz cx="6858000" cy="9144000"/>
@@ -589,7 +590,7 @@
           <a:lstStyle/>
           <a:p>
             <a:r>
-              <a:t>Uriel presenta el problema: la resistividad macroscópica y su derivada térmica frente a temperatura identifican si un material es conductor, semiconductor o aislante.</a:t>
+              <a:t>Estructura de bandas y variación térmica: el signo y magnitud de alfa delatan la física microscópica.</a:t>
             </a:r>
           </a:p>
         </p:txBody>
@@ -659,7 +660,7 @@
           <a:lstStyle/>
           <a:p>
             <a:r>
-              <a:t>Explicación de la estandarización Z manual con NumPy y la justificación matemática de los hiperparámetros.</a:t>
+              <a:t>Comparativa de escala: la compresión logarítmica es imprescindible para que los metales y aislantes coexistan.</a:t>
             </a:r>
           </a:p>
         </p:txBody>
@@ -729,7 +730,77 @@
           <a:lstStyle/>
           <a:p>
             <a:r>
-              <a:t>El gráfico muestra la clara separación; la línea discontinua de alfa = 0 separa el régimen de fonones del de activación térmica.</a:t>
+              <a:t>K-Means asume varianzas similares y falla; DBSCAN conecta por densidad y respeta la dispersión natural.</a:t>
+            </a:r>
+          </a:p>
+        </p:txBody>
+      </p:sp>
+      <p:sp>
+        <p:nvSpPr>
+          <p:cNvPr id="4" name="Slide Number Placeholder 3"/>
+          <p:cNvSpPr>
+            <a:spLocks noGrp="1"/>
+          </p:cNvSpPr>
+          <p:nvPr>
+            <p:ph type="sldNum" idx="5" sz="quarter"/>
+          </p:nvPr>
+        </p:nvSpPr>
+        <p:spPr/>
+      </p:sp>
+    </p:spTree>
+  </p:cSld>
+  <p:clrMapOvr>
+    <a:masterClrMapping/>
+  </p:clrMapOvr>
+</p:notes>
+</file>
+
+<file path=ppt/notesSlides/notesSlide5.xml><?xml version="1.0" encoding="utf-8"?>
+<p:notes xmlns:a="http://schemas.openxmlformats.org/drawingml/2006/main" xmlns:p="http://schemas.openxmlformats.org/presentationml/2006/main" xmlns:r="http://schemas.openxmlformats.org/officeDocument/2006/relationships">
+  <p:cSld>
+    <p:spTree>
+      <p:nvGrpSpPr>
+        <p:cNvPr id="1" name=""/>
+        <p:cNvGrpSpPr/>
+        <p:nvPr/>
+      </p:nvGrpSpPr>
+      <p:grpSpPr>
+        <a:xfrm>
+          <a:off x="0" y="0"/>
+          <a:ext cx="0" cy="0"/>
+          <a:chOff x="0" y="0"/>
+          <a:chExt cx="0" cy="0"/>
+        </a:xfrm>
+      </p:grpSpPr>
+      <p:sp>
+        <p:nvSpPr>
+          <p:cNvPr id="2" name="Slide Image Placeholder 1"/>
+          <p:cNvSpPr>
+            <a:spLocks noGrp="1"/>
+          </p:cNvSpPr>
+          <p:nvPr>
+            <p:ph type="sldImg" idx="2"/>
+          </p:nvPr>
+        </p:nvSpPr>
+        <p:spPr/>
+      </p:sp>
+      <p:sp>
+        <p:nvSpPr>
+          <p:cNvPr id="3" name="Notes Placeholder 2"/>
+          <p:cNvSpPr>
+            <a:spLocks noGrp="1"/>
+          </p:cNvSpPr>
+          <p:nvPr>
+            <p:ph type="body" idx="3" sz="quarter"/>
+          </p:nvPr>
+        </p:nvSpPr>
+        <p:spPr/>
+        <p:txBody>
+          <a:bodyPr/>
+          <a:lstStyle/>
+          <a:p>
+            <a:r>
+              <a:t>Resultado gráfico: el plano 2D muestra la separación nítida de las tres clases.</a:t>
             </a:r>
           </a:p>
         </p:txBody>
@@ -4116,7 +4187,7 @@
               <a:defRPr sz="3200" b="1"/>
             </a:pPr>
             <a:r>
-              <a:t>Problema: Clasificación de materiales eléctricos</a:t>
+              <a:t>Problema: 3 familias y firmas térmicas</a:t>
             </a:r>
           </a:p>
         </p:txBody>
@@ -4130,7 +4201,7 @@
         <p:spPr>
           <a:xfrm>
             <a:off x="548640" y="1371600"/>
-            <a:ext cx="10972800" cy="4572000"/>
+            <a:ext cx="4754880" cy="4572000"/>
           </a:xfrm>
           <a:prstGeom prst="rect">
             <a:avLst/>
@@ -4150,7 +4221,7 @@
               <a:defRPr sz="2000" b="0"/>
             </a:pPr>
             <a:r>
-              <a:t>• ¿Se pueden descubrir las fases de la materia sin etiquetas?</a:t>
+              <a:t>• Conducción según la estructura cuántica de bandas</a:t>
             </a:r>
           </a:p>
           <a:p>
@@ -4161,7 +4232,7 @@
               <a:defRPr sz="2000" b="0"/>
             </a:pPr>
             <a:r>
-              <a:t>• Espacio de características físicas: (log₁₀(ρ₃₀₀K), α)</a:t>
+              <a:t>• Variación térmica: ρ(T) = ρ₀ · [1 + α·(T - T₀)]</a:t>
             </a:r>
           </a:p>
           <a:p>
@@ -4172,7 +4243,7 @@
               <a:defRPr sz="2000" b="0"/>
             </a:pPr>
             <a:r>
-              <a:t>• La resistividad abarca más de 30 órdenes de magnitud (10⁻⁸ a 10²² Ω·m)</a:t>
+              <a:t>• Coeficiente térmico: α = (1 / ρ₀) · (dρ / dT)₃₀₀K</a:t>
             </a:r>
           </a:p>
           <a:p>
@@ -4183,11 +4254,35 @@
               <a:defRPr sz="2000" b="0"/>
             </a:pPr>
             <a:r>
-              <a:t>• El coeficiente térmico α delata la estructura cuántica de bandas</a:t>
-            </a:r>
-          </a:p>
-        </p:txBody>
-      </p:sp>
+              <a:t>• Metales (α &gt; 0) · Semiconductores (α &lt; 0) · Aislantes (α ≈ 0)</a:t>
+            </a:r>
+          </a:p>
+        </p:txBody>
+      </p:sp>
+      <p:pic>
+        <p:nvPicPr>
+          <p:cNvPr id="4" name="Picture 3" descr="esquema_bandas_materiales.png"/>
+          <p:cNvPicPr>
+            <a:picLocks noChangeAspect="1"/>
+          </p:cNvPicPr>
+          <p:nvPr/>
+        </p:nvPicPr>
+        <p:blipFill>
+          <a:blip r:embed="rId2"/>
+          <a:stretch>
+            <a:fillRect/>
+          </a:stretch>
+        </p:blipFill>
+        <p:spPr>
+          <a:xfrm>
+            <a:off x="5394960" y="1371600"/>
+            <a:ext cx="6583680" cy="2466766"/>
+          </a:xfrm>
+          <a:prstGeom prst="rect">
+            <a:avLst/>
+          </a:prstGeom>
+        </p:spPr>
+      </p:pic>
     </p:spTree>
   </p:cSld>
   <p:clrMapOvr>
@@ -4235,7 +4330,7 @@
               <a:defRPr sz="3200" b="1"/>
             </a:pPr>
             <a:r>
-              <a:t>Física cuántica y por qué DBSCAN</a:t>
+              <a:t>Dataset y espacio (log₁₀ρ, α)</a:t>
             </a:r>
           </a:p>
         </p:txBody>
@@ -4249,7 +4344,7 @@
         <p:spPr>
           <a:xfrm>
             <a:off x="548640" y="1371600"/>
-            <a:ext cx="10972800" cy="4572000"/>
+            <a:ext cx="4754880" cy="4572000"/>
           </a:xfrm>
           <a:prstGeom prst="rect">
             <a:avLst/>
@@ -4269,7 +4364,7 @@
               <a:defRPr sz="2000" b="0"/>
             </a:pPr>
             <a:r>
-              <a:t>• Metales (banda semillena): α &gt; 0 por choques con fonones (mar de Fermi)</a:t>
+              <a:t>• 57 materiales reales recopilados experimentalmente</a:t>
             </a:r>
           </a:p>
           <a:p>
@@ -4280,7 +4375,7 @@
               <a:defRPr sz="2000" b="0"/>
             </a:pPr>
             <a:r>
-              <a:t>• Semiconductores (gap moderado): α &lt; 0 por activación térmica de Boltzmann</a:t>
+              <a:t>• 30 órdenes de magnitud en resistividad (10⁻⁸ a 10²² Ω·m)</a:t>
             </a:r>
           </a:p>
           <a:p>
@@ -4291,7 +4386,7 @@
               <a:defRPr sz="2000" b="0"/>
             </a:pPr>
             <a:r>
-              <a:t>• Aislantes (gap enorme &gt; 5 eV): α ≈ 0 y resistividad extrema (&gt; 10¹¹ Ω·m)</a:t>
+              <a:t>• Escala lineal colapsa en el origen; log₁₀(ρ) separa las fases</a:t>
             </a:r>
           </a:p>
           <a:p>
@@ -4302,11 +4397,35 @@
               <a:defRPr sz="2000" b="0"/>
             </a:pPr>
             <a:r>
-              <a:t>• ¿Por qué DBSCAN?: K-Means asume grupos esféricos e isodensos; DBSCAN respeta densidades desiguales (metales densos vs aislantes dispersos)</a:t>
-            </a:r>
-          </a:p>
-        </p:txBody>
-      </p:sp>
+              <a:t>• Clustering no supervisado: descubrir las clases sin etiquetas</a:t>
+            </a:r>
+          </a:p>
+        </p:txBody>
+      </p:sp>
+      <p:pic>
+        <p:nvPicPr>
+          <p:cNvPr id="4" name="Picture 3" descr="distribucion_escala_rho.png"/>
+          <p:cNvPicPr>
+            <a:picLocks noChangeAspect="1"/>
+          </p:cNvPicPr>
+          <p:nvPr/>
+        </p:nvPicPr>
+        <p:blipFill>
+          <a:blip r:embed="rId2"/>
+          <a:stretch>
+            <a:fillRect/>
+          </a:stretch>
+        </p:blipFill>
+        <p:spPr>
+          <a:xfrm>
+            <a:off x="5394960" y="1371600"/>
+            <a:ext cx="6583680" cy="2460567"/>
+          </a:xfrm>
+          <a:prstGeom prst="rect">
+            <a:avLst/>
+          </a:prstGeom>
+        </p:spPr>
+      </p:pic>
     </p:spTree>
   </p:cSld>
   <p:clrMapOvr>
@@ -4354,7 +4473,7 @@
               <a:defRPr sz="3200" b="1"/>
             </a:pPr>
             <a:r>
-              <a:t>Metodología: Escala y parámetros</a:t>
+              <a:t>¿Por qué DBSCAN frente a K-Means?</a:t>
             </a:r>
           </a:p>
         </p:txBody>
@@ -4368,7 +4487,7 @@
         <p:spPr>
           <a:xfrm>
             <a:off x="548640" y="1371600"/>
-            <a:ext cx="10972800" cy="4572000"/>
+            <a:ext cx="4754880" cy="4572000"/>
           </a:xfrm>
           <a:prstGeom prst="rect">
             <a:avLst/>
@@ -4388,7 +4507,7 @@
               <a:defRPr sz="2000" b="0"/>
             </a:pPr>
             <a:r>
-              <a:t>• Estandarización manual Z-score: Z = (X - μ) / σ vectorialmente con NumPy</a:t>
+              <a:t>• ✖ K-Means: asume esfericidad, fractura aislantes y no aísla ruido</a:t>
             </a:r>
           </a:p>
           <a:p>
@@ -4399,7 +4518,7 @@
               <a:defRPr sz="2000" b="0"/>
             </a:pPr>
             <a:r>
-              <a:t>• Imprescindible: equipara el rango de log₁₀ρ (~31) con el de α (~0,08)</a:t>
+              <a:t>• ✔ DBSCAN: conecta por densidad local y tolera densidades desiguales</a:t>
             </a:r>
           </a:p>
           <a:p>
@@ -4410,7 +4529,7 @@
               <a:defRPr sz="2000" b="0"/>
             </a:pPr>
             <a:r>
-              <a:t>• DBSCAN con scikit-learn: eps = 0,65, min_samples = 3 (dimensión d = 2)</a:t>
+              <a:t>• Metales hiperdensos vs aislantes extendidos en 12 órdenes</a:t>
             </a:r>
           </a:p>
           <a:p>
@@ -4421,11 +4540,35 @@
               <a:defRPr sz="2000" b="0"/>
             </a:pPr>
             <a:r>
-              <a:t>• Determinación objetiva de eps mediante codo k-NN y silueta</a:t>
-            </a:r>
-          </a:p>
-        </p:txBody>
-      </p:sp>
+              <a:t>• DBSCAN detecta anomalías de forma nativa (etiqueta -1)</a:t>
+            </a:r>
+          </a:p>
+        </p:txBody>
+      </p:sp>
+      <p:pic>
+        <p:nvPicPr>
+          <p:cNvPr id="4" name="Picture 3" descr="comparativa_kmeans_dbscan.png"/>
+          <p:cNvPicPr>
+            <a:picLocks noChangeAspect="1"/>
+          </p:cNvPicPr>
+          <p:nvPr/>
+        </p:nvPicPr>
+        <p:blipFill>
+          <a:blip r:embed="rId2"/>
+          <a:stretch>
+            <a:fillRect/>
+          </a:stretch>
+        </p:blipFill>
+        <p:spPr>
+          <a:xfrm>
+            <a:off x="5394960" y="1371600"/>
+            <a:ext cx="6583680" cy="2726575"/>
+          </a:xfrm>
+          <a:prstGeom prst="rect">
+            <a:avLst/>
+          </a:prstGeom>
+        </p:spPr>
+      </p:pic>
     </p:spTree>
   </p:cSld>
   <p:clrMapOvr>
@@ -4473,7 +4616,7 @@
               <a:defRPr sz="3200" b="1"/>
             </a:pPr>
             <a:r>
-              <a:t>Resultado: DBSCAN en 57 materiales</a:t>
+              <a:t>Metodología: Fórmulas y parámetros</a:t>
             </a:r>
           </a:p>
         </p:txBody>
@@ -4487,7 +4630,7 @@
         <p:spPr>
           <a:xfrm>
             <a:off x="548640" y="1371600"/>
-            <a:ext cx="4754880" cy="4572000"/>
+            <a:ext cx="10972800" cy="4572000"/>
           </a:xfrm>
           <a:prstGeom prst="rect">
             <a:avLst/>
@@ -4507,7 +4650,7 @@
               <a:defRPr sz="2000" b="0"/>
             </a:pPr>
             <a:r>
-              <a:t>• 3 clusters puros descubiertos por densidad: 0 ruido</a:t>
+              <a:t>• Estandarización manual Z-Score con NumPy: Z = (X - μ) / σ</a:t>
             </a:r>
           </a:p>
           <a:p>
@@ -4518,7 +4661,7 @@
               <a:defRPr sz="2000" b="0"/>
             </a:pPr>
             <a:r>
-              <a:t>• Cluster 0 (ámbar): 35 metales conductores (Cu, Ag, Au, Al...)</a:t>
+              <a:t>• Vecindad: N_ε(p) = { q | d(p, q) ≤ ε }</a:t>
             </a:r>
           </a:p>
           <a:p>
@@ -4529,7 +4672,7 @@
               <a:defRPr sz="2000" b="0"/>
             </a:pPr>
             <a:r>
-              <a:t>• Cluster 1 (azul): 10 aislantes dieléctricos (vidrio, teflón, cuarzo...)</a:t>
+              <a:t>• Núcleo (Core Point): |N_ε(p)| ≥ min_samples</a:t>
             </a:r>
           </a:p>
           <a:p>
@@ -4540,46 +4683,11 @@
               <a:defRPr sz="2000" b="0"/>
             </a:pPr>
             <a:r>
-              <a:t>• Cluster 2 (verde): 10 semiconductores (Si, Ge, GaAs, InP...)</a:t>
-            </a:r>
-          </a:p>
-          <a:p>
-            <a:pPr>
-              <a:spcAft>
-                <a:spcPts val="800"/>
-              </a:spcAft>
-              <a:defRPr sz="2000" b="0"/>
-            </a:pPr>
-            <a:r>
-              <a:t>• Silhouette Score: 0,7858 (separación inter-cluster sobresaliente)</a:t>
-            </a:r>
-          </a:p>
-        </p:txBody>
-      </p:sp>
-      <p:pic>
-        <p:nvPicPr>
-          <p:cNvPr id="4" name="Picture 3" descr="clusters_materiales_dbscan.png"/>
-          <p:cNvPicPr>
-            <a:picLocks noChangeAspect="1"/>
-          </p:cNvPicPr>
-          <p:nvPr/>
-        </p:nvPicPr>
-        <p:blipFill>
-          <a:blip r:embed="rId2"/>
-          <a:stretch>
-            <a:fillRect/>
-          </a:stretch>
-        </p:blipFill>
-        <p:spPr>
-          <a:xfrm>
-            <a:off x="5394960" y="1371600"/>
-            <a:ext cx="6583680" cy="4279392"/>
-          </a:xfrm>
-          <a:prstGeom prst="rect">
-            <a:avLst/>
-          </a:prstGeom>
-        </p:spPr>
-      </p:pic>
+              <a:t>• Parámetros fijados: ε = 0,65 (codo k-NN) y min_samples = 3 (d = 2)</a:t>
+            </a:r>
+          </a:p>
+        </p:txBody>
+      </p:sp>
     </p:spTree>
   </p:cSld>
   <p:clrMapOvr>
@@ -4627,7 +4735,7 @@
               <a:defRPr sz="3200" b="1"/>
             </a:pPr>
             <a:r>
-              <a:t>Validación y defensa</a:t>
+              <a:t>Resultado: DBSCAN en 57 materiales</a:t>
             </a:r>
           </a:p>
         </p:txBody>
@@ -4641,7 +4749,7 @@
         <p:spPr>
           <a:xfrm>
             <a:off x="548640" y="1371600"/>
-            <a:ext cx="10972800" cy="4572000"/>
+            <a:ext cx="4754880" cy="4572000"/>
           </a:xfrm>
           <a:prstGeom prst="rect">
             <a:avLst/>
@@ -4661,7 +4769,7 @@
               <a:defRPr sz="2000" b="0"/>
             </a:pPr>
             <a:r>
-              <a:t>• Matriz de contingencia: 100 % de pureza en conductores y aislantes</a:t>
+              <a:t>• 3 clusters puros descubiertos por densidad: 0 ruido</a:t>
             </a:r>
           </a:p>
           <a:p>
@@ -4672,7 +4780,7 @@
               <a:defRPr sz="2000" b="0"/>
             </a:pPr>
             <a:r>
-              <a:t>• 2 semimetales clasificados en el cluster 0 por su resistividad cuasi-metálica</a:t>
+              <a:t>• Cluster 0 (ámbar): 35 metales conductores (Cu, Ag, Au...)</a:t>
             </a:r>
           </a:p>
           <a:p>
@@ -4683,7 +4791,7 @@
               <a:defRPr sz="2000" b="0"/>
             </a:pPr>
             <a:r>
-              <a:t>• eps &lt; 0,4 fragmenta los aislantes en ruido; eps &gt; 1,0 funde semiconductores con metales</a:t>
+              <a:t>• Cluster 1 (azul): 10 aislantes dieléctricos (vidrio, teflón...)</a:t>
             </a:r>
           </a:p>
           <a:p>
@@ -4694,11 +4802,46 @@
               <a:defRPr sz="2000" b="0"/>
             </a:pPr>
             <a:r>
-              <a:t>• Usar conductividad lineal σ colapsaría el 99 % de los puntos en el origen: log₁₀ρ es obligatoria</a:t>
-            </a:r>
-          </a:p>
-        </p:txBody>
-      </p:sp>
+              <a:t>• Cluster 2 (verde): 10 semiconductores (Si, Ge, GaAs...)</a:t>
+            </a:r>
+          </a:p>
+          <a:p>
+            <a:pPr>
+              <a:spcAft>
+                <a:spcPts val="800"/>
+              </a:spcAft>
+              <a:defRPr sz="2000" b="0"/>
+            </a:pPr>
+            <a:r>
+              <a:t>• Frontera α = 0: fonones vs activación térmica</a:t>
+            </a:r>
+          </a:p>
+        </p:txBody>
+      </p:sp>
+      <p:pic>
+        <p:nvPicPr>
+          <p:cNvPr id="4" name="Picture 3" descr="clusters_materiales_dbscan.png"/>
+          <p:cNvPicPr>
+            <a:picLocks noChangeAspect="1"/>
+          </p:cNvPicPr>
+          <p:nvPr/>
+        </p:nvPicPr>
+        <p:blipFill>
+          <a:blip r:embed="rId2"/>
+          <a:stretch>
+            <a:fillRect/>
+          </a:stretch>
+        </p:blipFill>
+        <p:spPr>
+          <a:xfrm>
+            <a:off x="5394960" y="1371600"/>
+            <a:ext cx="6583680" cy="4279392"/>
+          </a:xfrm>
+          <a:prstGeom prst="rect">
+            <a:avLst/>
+          </a:prstGeom>
+        </p:spPr>
+      </p:pic>
     </p:spTree>
   </p:cSld>
   <p:clrMapOvr>
@@ -4746,7 +4889,7 @@
               <a:defRPr sz="3200" b="1"/>
             </a:pPr>
             <a:r>
-              <a:t>Conclusiones</a:t>
+              <a:t>Validación física: Matriz de contingencia</a:t>
             </a:r>
           </a:p>
         </p:txBody>
@@ -4772,43 +4915,48 @@
             <a:spAutoFit/>
           </a:bodyPr>
           <a:lstStyle/>
-          <a:p/>
-        </p:txBody>
-      </p:sp>
-      <p:sp>
-        <p:nvSpPr>
-          <p:cNvPr id="4" name="TextBox 3"/>
-          <p:cNvSpPr txBox="1"/>
-          <p:nvPr/>
-        </p:nvSpPr>
-        <p:spPr>
-          <a:xfrm>
-            <a:off x="548640" y="5852160"/>
-            <a:ext cx="10972800" cy="731520"/>
-          </a:xfrm>
-          <a:prstGeom prst="rect">
-            <a:avLst/>
-          </a:prstGeom>
-          <a:noFill/>
-        </p:spPr>
-        <p:txBody>
-          <a:bodyPr wrap="square">
-            <a:spAutoFit/>
-          </a:bodyPr>
-          <a:lstStyle/>
-          <a:p>
-            <a:pPr>
-              <a:spcAft>
-                <a:spcPts val="800"/>
-              </a:spcAft>
-              <a:defRPr sz="1800" b="1">
-                <a:solidFill>
-                  <a:srgbClr val="B03030"/>
-                </a:solidFill>
-              </a:defRPr>
-            </a:pPr>
-            <a:r>
-              <a:t>[PENDIENTE: comparativa del equipo: qué algoritmo funcionó mejor y por qué]</a:t>
+          <a:p>
+            <a:pPr>
+              <a:spcAft>
+                <a:spcPts val="800"/>
+              </a:spcAft>
+              <a:defRPr sz="2000" b="0"/>
+            </a:pPr>
+            <a:r>
+              <a:t>• Conductores: 35 de 35 (100 % pureza en Cluster 0)</a:t>
+            </a:r>
+          </a:p>
+          <a:p>
+            <a:pPr>
+              <a:spcAft>
+                <a:spcPts val="800"/>
+              </a:spcAft>
+              <a:defRPr sz="2000" b="0"/>
+            </a:pPr>
+            <a:r>
+              <a:t>• Aislantes: 10 de 10 (100 % pureza en Cluster 1)</a:t>
+            </a:r>
+          </a:p>
+          <a:p>
+            <a:pPr>
+              <a:spcAft>
+                <a:spcPts val="800"/>
+              </a:spcAft>
+              <a:defRPr sz="2000" b="0"/>
+            </a:pPr>
+            <a:r>
+              <a:t>• Semiconductores: 10 de 12 (83,3 % pureza en Cluster 2; 2 semimetales en cluster 0)</a:t>
+            </a:r>
+          </a:p>
+          <a:p>
+            <a:pPr>
+              <a:spcAft>
+                <a:spcPts val="800"/>
+              </a:spcAft>
+              <a:defRPr sz="2000" b="0"/>
+            </a:pPr>
+            <a:r>
+              <a:t>• Silhouette Score complementario: 0,7858 (alta cohesión interna)</a:t>
             </a:r>
           </a:p>
         </p:txBody>
@@ -4822,6 +4970,120 @@
 </file>
 
 <file path=ppt/slides/slide18.xml><?xml version="1.0" encoding="utf-8"?>
+<p:sld xmlns:a="http://schemas.openxmlformats.org/drawingml/2006/main" xmlns:p="http://schemas.openxmlformats.org/presentationml/2006/main" xmlns:r="http://schemas.openxmlformats.org/officeDocument/2006/relationships">
+  <p:cSld>
+    <p:spTree>
+      <p:nvGrpSpPr>
+        <p:cNvPr id="1" name=""/>
+        <p:cNvGrpSpPr/>
+        <p:nvPr/>
+      </p:nvGrpSpPr>
+      <p:grpSpPr/>
+      <p:sp>
+        <p:nvSpPr>
+          <p:cNvPr id="2" name="TextBox 1"/>
+          <p:cNvSpPr txBox="1"/>
+          <p:nvPr/>
+        </p:nvSpPr>
+        <p:spPr>
+          <a:xfrm>
+            <a:off x="548640" y="320040"/>
+            <a:ext cx="10972800" cy="914400"/>
+          </a:xfrm>
+          <a:prstGeom prst="rect">
+            <a:avLst/>
+          </a:prstGeom>
+          <a:noFill/>
+        </p:spPr>
+        <p:txBody>
+          <a:bodyPr wrap="square">
+            <a:spAutoFit/>
+          </a:bodyPr>
+          <a:lstStyle/>
+          <a:p>
+            <a:pPr>
+              <a:spcAft>
+                <a:spcPts val="800"/>
+              </a:spcAft>
+              <a:defRPr sz="3200" b="1"/>
+            </a:pPr>
+            <a:r>
+              <a:t>Conclusiones</a:t>
+            </a:r>
+          </a:p>
+        </p:txBody>
+      </p:sp>
+      <p:sp>
+        <p:nvSpPr>
+          <p:cNvPr id="3" name="TextBox 2"/>
+          <p:cNvSpPr txBox="1"/>
+          <p:nvPr/>
+        </p:nvSpPr>
+        <p:spPr>
+          <a:xfrm>
+            <a:off x="548640" y="1371600"/>
+            <a:ext cx="10972800" cy="4572000"/>
+          </a:xfrm>
+          <a:prstGeom prst="rect">
+            <a:avLst/>
+          </a:prstGeom>
+          <a:noFill/>
+        </p:spPr>
+        <p:txBody>
+          <a:bodyPr wrap="square">
+            <a:spAutoFit/>
+          </a:bodyPr>
+          <a:lstStyle/>
+          <a:p/>
+        </p:txBody>
+      </p:sp>
+      <p:sp>
+        <p:nvSpPr>
+          <p:cNvPr id="4" name="TextBox 3"/>
+          <p:cNvSpPr txBox="1"/>
+          <p:nvPr/>
+        </p:nvSpPr>
+        <p:spPr>
+          <a:xfrm>
+            <a:off x="548640" y="5852160"/>
+            <a:ext cx="10972800" cy="731520"/>
+          </a:xfrm>
+          <a:prstGeom prst="rect">
+            <a:avLst/>
+          </a:prstGeom>
+          <a:noFill/>
+        </p:spPr>
+        <p:txBody>
+          <a:bodyPr wrap="square">
+            <a:spAutoFit/>
+          </a:bodyPr>
+          <a:lstStyle/>
+          <a:p>
+            <a:pPr>
+              <a:spcAft>
+                <a:spcPts val="800"/>
+              </a:spcAft>
+              <a:defRPr sz="1800" b="1">
+                <a:solidFill>
+                  <a:srgbClr val="B03030"/>
+                </a:solidFill>
+              </a:defRPr>
+            </a:pPr>
+            <a:r>
+              <a:t>[PENDIENTE: comparativa del equipo: qué algoritmo funcionó mejor y por qué]</a:t>
+            </a:r>
+          </a:p>
+        </p:txBody>
+      </p:sp>
+    </p:spTree>
+  </p:cSld>
+  <p:clrMapOvr>
+    <a:masterClrMapping/>
+  </p:clrMapOvr>
+</p:sld>
+</file>
+
+<file path=ppt/slides/slide19.xml><?xml version="1.0" encoding="utf-8"?>
 <p:sld xmlns:a="http://schemas.openxmlformats.org/drawingml/2006/main" xmlns:p="http://schemas.openxmlformats.org/presentationml/2006/main" xmlns:r="http://schemas.openxmlformats.org/officeDocument/2006/relationships">
   <p:cSld>
     <p:spTree>

</xml_diff>

<commit_message>
style: cambiar tipografia a Arial en diapositivas, textos y graficos
</commit_message>
<xml_diff>
--- a/presentacion/expo_cpia.pptx
+++ b/presentacion/expo_cpia.pptx
@@ -3832,9 +3832,14 @@
               <a:spcAft>
                 <a:spcPts val="800"/>
               </a:spcAft>
-              <a:defRPr sz="4000" b="1"/>
-            </a:pPr>
-            <a:r>
+              <a:defRPr sz="4000" b="1">
+                <a:latin typeface="Arial"/>
+              </a:defRPr>
+            </a:pPr>
+            <a:r>
+              <a:rPr>
+                <a:latin typeface="Arial"/>
+              </a:rPr>
               <a:t>Aprendizaje no supervisado y detección de anomalías</a:t>
             </a:r>
           </a:p>
@@ -3870,9 +3875,13 @@
                 <a:solidFill>
                   <a:srgbClr val="555555"/>
                 </a:solidFill>
-              </a:defRPr>
-            </a:pPr>
-            <a:r>
+                <a:latin typeface="Arial"/>
+              </a:defRPr>
+            </a:pPr>
+            <a:r>
+              <a:rPr>
+                <a:latin typeface="Arial"/>
+              </a:rPr>
               <a:t>CPIA · Grado en Ingeniería Física · UPC</a:t>
             </a:r>
           </a:p>
@@ -3904,9 +3913,14 @@
               <a:spcAft>
                 <a:spcPts val="800"/>
               </a:spcAft>
-              <a:defRPr sz="2200" b="0"/>
-            </a:pPr>
-            <a:r>
+              <a:defRPr sz="2200" b="0">
+                <a:latin typeface="Arial"/>
+              </a:defRPr>
+            </a:pPr>
+            <a:r>
+              <a:rPr>
+                <a:latin typeface="Arial"/>
+              </a:rPr>
               <a:t>Matías · Martí · Uriel · Arnau Montull</a:t>
             </a:r>
           </a:p>
@@ -3956,9 +3970,14 @@
               <a:spcAft>
                 <a:spcPts val="800"/>
               </a:spcAft>
-              <a:defRPr sz="3200" b="1"/>
-            </a:pPr>
-            <a:r>
+              <a:defRPr sz="3200" b="1">
+                <a:latin typeface="Arial"/>
+              </a:defRPr>
+            </a:pPr>
+            <a:r>
+              <a:rPr>
+                <a:latin typeface="Arial"/>
+              </a:rPr>
               <a:t>Problema de Matías</a:t>
             </a:r>
           </a:p>
@@ -3985,7 +4004,13 @@
             <a:spAutoFit/>
           </a:bodyPr>
           <a:lstStyle/>
-          <a:p/>
+          <a:p>
+            <a:pPr>
+              <a:defRPr>
+                <a:latin typeface="Arial"/>
+              </a:defRPr>
+            </a:pPr>
+          </a:p>
         </p:txBody>
       </p:sp>
       <p:sp>
@@ -4018,9 +4043,13 @@
                 <a:solidFill>
                   <a:srgbClr val="B03030"/>
                 </a:solidFill>
-              </a:defRPr>
-            </a:pPr>
-            <a:r>
+                <a:latin typeface="Arial"/>
+              </a:defRPr>
+            </a:pPr>
+            <a:r>
+              <a:rPr>
+                <a:latin typeface="Arial"/>
+              </a:rPr>
               <a:t>[PENDIENTE: título, datos, método, resultado, figuras]</a:t>
             </a:r>
           </a:p>
@@ -4070,9 +4099,14 @@
               <a:spcAft>
                 <a:spcPts val="800"/>
               </a:spcAft>
-              <a:defRPr sz="3200" b="1"/>
-            </a:pPr>
-            <a:r>
+              <a:defRPr sz="3200" b="1">
+                <a:latin typeface="Arial"/>
+              </a:defRPr>
+            </a:pPr>
+            <a:r>
+              <a:rPr>
+                <a:latin typeface="Arial"/>
+              </a:rPr>
               <a:t>Problema de Martí</a:t>
             </a:r>
           </a:p>
@@ -4099,7 +4133,13 @@
             <a:spAutoFit/>
           </a:bodyPr>
           <a:lstStyle/>
-          <a:p/>
+          <a:p>
+            <a:pPr>
+              <a:defRPr>
+                <a:latin typeface="Arial"/>
+              </a:defRPr>
+            </a:pPr>
+          </a:p>
         </p:txBody>
       </p:sp>
       <p:sp>
@@ -4132,9 +4172,13 @@
                 <a:solidFill>
                   <a:srgbClr val="B03030"/>
                 </a:solidFill>
-              </a:defRPr>
-            </a:pPr>
-            <a:r>
+                <a:latin typeface="Arial"/>
+              </a:defRPr>
+            </a:pPr>
+            <a:r>
+              <a:rPr>
+                <a:latin typeface="Arial"/>
+              </a:rPr>
               <a:t>[PENDIENTE: título, datos, método, resultado, figuras]</a:t>
             </a:r>
           </a:p>
@@ -4184,9 +4228,14 @@
               <a:spcAft>
                 <a:spcPts val="800"/>
               </a:spcAft>
-              <a:defRPr sz="3200" b="1"/>
-            </a:pPr>
-            <a:r>
+              <a:defRPr sz="3200" b="1">
+                <a:latin typeface="Arial"/>
+              </a:defRPr>
+            </a:pPr>
+            <a:r>
+              <a:rPr>
+                <a:latin typeface="Arial"/>
+              </a:rPr>
               <a:t>Problema: 3 familias y firmas térmicas</a:t>
             </a:r>
           </a:p>
@@ -4218,9 +4267,14 @@
               <a:spcAft>
                 <a:spcPts val="800"/>
               </a:spcAft>
-              <a:defRPr sz="2000" b="0"/>
-            </a:pPr>
-            <a:r>
+              <a:defRPr sz="2000" b="0">
+                <a:latin typeface="Arial"/>
+              </a:defRPr>
+            </a:pPr>
+            <a:r>
+              <a:rPr>
+                <a:latin typeface="Arial"/>
+              </a:rPr>
               <a:t>• Conducción según la estructura cuántica de bandas</a:t>
             </a:r>
           </a:p>
@@ -4229,9 +4283,14 @@
               <a:spcAft>
                 <a:spcPts val="800"/>
               </a:spcAft>
-              <a:defRPr sz="2000" b="0"/>
-            </a:pPr>
-            <a:r>
+              <a:defRPr sz="2000" b="0">
+                <a:latin typeface="Arial"/>
+              </a:defRPr>
+            </a:pPr>
+            <a:r>
+              <a:rPr>
+                <a:latin typeface="Arial"/>
+              </a:rPr>
               <a:t>• Variación térmica: ρ(T) = ρ₀ · [1 + α·(T - T₀)]</a:t>
             </a:r>
           </a:p>
@@ -4240,9 +4299,14 @@
               <a:spcAft>
                 <a:spcPts val="800"/>
               </a:spcAft>
-              <a:defRPr sz="2000" b="0"/>
-            </a:pPr>
-            <a:r>
+              <a:defRPr sz="2000" b="0">
+                <a:latin typeface="Arial"/>
+              </a:defRPr>
+            </a:pPr>
+            <a:r>
+              <a:rPr>
+                <a:latin typeface="Arial"/>
+              </a:rPr>
               <a:t>• Coeficiente térmico: α = (1 / ρ₀) · (dρ / dT)₃₀₀K</a:t>
             </a:r>
           </a:p>
@@ -4251,9 +4315,14 @@
               <a:spcAft>
                 <a:spcPts val="800"/>
               </a:spcAft>
-              <a:defRPr sz="2000" b="0"/>
-            </a:pPr>
-            <a:r>
+              <a:defRPr sz="2000" b="0">
+                <a:latin typeface="Arial"/>
+              </a:defRPr>
+            </a:pPr>
+            <a:r>
+              <a:rPr>
+                <a:latin typeface="Arial"/>
+              </a:rPr>
               <a:t>• Metales (α &gt; 0) · Semiconductores (α &lt; 0) · Aislantes (α ≈ 0)</a:t>
             </a:r>
           </a:p>
@@ -4276,7 +4345,7 @@
         <p:spPr>
           <a:xfrm>
             <a:off x="5394960" y="1371600"/>
-            <a:ext cx="6583680" cy="2466766"/>
+            <a:ext cx="6583680" cy="2464350"/>
           </a:xfrm>
           <a:prstGeom prst="rect">
             <a:avLst/>
@@ -4327,9 +4396,14 @@
               <a:spcAft>
                 <a:spcPts val="800"/>
               </a:spcAft>
-              <a:defRPr sz="3200" b="1"/>
-            </a:pPr>
-            <a:r>
+              <a:defRPr sz="3200" b="1">
+                <a:latin typeface="Arial"/>
+              </a:defRPr>
+            </a:pPr>
+            <a:r>
+              <a:rPr>
+                <a:latin typeface="Arial"/>
+              </a:rPr>
               <a:t>Dataset y espacio (log₁₀ρ, α)</a:t>
             </a:r>
           </a:p>
@@ -4361,9 +4435,14 @@
               <a:spcAft>
                 <a:spcPts val="800"/>
               </a:spcAft>
-              <a:defRPr sz="2000" b="0"/>
-            </a:pPr>
-            <a:r>
+              <a:defRPr sz="2000" b="0">
+                <a:latin typeface="Arial"/>
+              </a:defRPr>
+            </a:pPr>
+            <a:r>
+              <a:rPr>
+                <a:latin typeface="Arial"/>
+              </a:rPr>
               <a:t>• 57 materiales reales recopilados experimentalmente</a:t>
             </a:r>
           </a:p>
@@ -4372,9 +4451,14 @@
               <a:spcAft>
                 <a:spcPts val="800"/>
               </a:spcAft>
-              <a:defRPr sz="2000" b="0"/>
-            </a:pPr>
-            <a:r>
+              <a:defRPr sz="2000" b="0">
+                <a:latin typeface="Arial"/>
+              </a:defRPr>
+            </a:pPr>
+            <a:r>
+              <a:rPr>
+                <a:latin typeface="Arial"/>
+              </a:rPr>
               <a:t>• 30 órdenes de magnitud en resistividad (10⁻⁸ a 10²² Ω·m)</a:t>
             </a:r>
           </a:p>
@@ -4383,9 +4467,14 @@
               <a:spcAft>
                 <a:spcPts val="800"/>
               </a:spcAft>
-              <a:defRPr sz="2000" b="0"/>
-            </a:pPr>
-            <a:r>
+              <a:defRPr sz="2000" b="0">
+                <a:latin typeface="Arial"/>
+              </a:defRPr>
+            </a:pPr>
+            <a:r>
+              <a:rPr>
+                <a:latin typeface="Arial"/>
+              </a:rPr>
               <a:t>• Escala lineal colapsa en el origen; log₁₀(ρ) separa las fases</a:t>
             </a:r>
           </a:p>
@@ -4394,9 +4483,14 @@
               <a:spcAft>
                 <a:spcPts val="800"/>
               </a:spcAft>
-              <a:defRPr sz="2000" b="0"/>
-            </a:pPr>
-            <a:r>
+              <a:defRPr sz="2000" b="0">
+                <a:latin typeface="Arial"/>
+              </a:defRPr>
+            </a:pPr>
+            <a:r>
+              <a:rPr>
+                <a:latin typeface="Arial"/>
+              </a:rPr>
               <a:t>• Clustering no supervisado: descubrir las clases sin etiquetas</a:t>
             </a:r>
           </a:p>
@@ -4470,9 +4564,14 @@
               <a:spcAft>
                 <a:spcPts val="800"/>
               </a:spcAft>
-              <a:defRPr sz="3200" b="1"/>
-            </a:pPr>
-            <a:r>
+              <a:defRPr sz="3200" b="1">
+                <a:latin typeface="Arial"/>
+              </a:defRPr>
+            </a:pPr>
+            <a:r>
+              <a:rPr>
+                <a:latin typeface="Arial"/>
+              </a:rPr>
               <a:t>¿Por qué DBSCAN frente a K-Means?</a:t>
             </a:r>
           </a:p>
@@ -4504,9 +4603,14 @@
               <a:spcAft>
                 <a:spcPts val="800"/>
               </a:spcAft>
-              <a:defRPr sz="2000" b="0"/>
-            </a:pPr>
-            <a:r>
+              <a:defRPr sz="2000" b="0">
+                <a:latin typeface="Arial"/>
+              </a:defRPr>
+            </a:pPr>
+            <a:r>
+              <a:rPr>
+                <a:latin typeface="Arial"/>
+              </a:rPr>
               <a:t>• ✖ K-Means: asume esfericidad, fractura aislantes y no aísla ruido</a:t>
             </a:r>
           </a:p>
@@ -4515,9 +4619,14 @@
               <a:spcAft>
                 <a:spcPts val="800"/>
               </a:spcAft>
-              <a:defRPr sz="2000" b="0"/>
-            </a:pPr>
-            <a:r>
+              <a:defRPr sz="2000" b="0">
+                <a:latin typeface="Arial"/>
+              </a:defRPr>
+            </a:pPr>
+            <a:r>
+              <a:rPr>
+                <a:latin typeface="Arial"/>
+              </a:rPr>
               <a:t>• ✔ DBSCAN: conecta por densidad local y tolera densidades desiguales</a:t>
             </a:r>
           </a:p>
@@ -4526,9 +4635,14 @@
               <a:spcAft>
                 <a:spcPts val="800"/>
               </a:spcAft>
-              <a:defRPr sz="2000" b="0"/>
-            </a:pPr>
-            <a:r>
+              <a:defRPr sz="2000" b="0">
+                <a:latin typeface="Arial"/>
+              </a:defRPr>
+            </a:pPr>
+            <a:r>
+              <a:rPr>
+                <a:latin typeface="Arial"/>
+              </a:rPr>
               <a:t>• Metales hiperdensos vs aislantes extendidos en 12 órdenes</a:t>
             </a:r>
           </a:p>
@@ -4537,9 +4651,14 @@
               <a:spcAft>
                 <a:spcPts val="800"/>
               </a:spcAft>
-              <a:defRPr sz="2000" b="0"/>
-            </a:pPr>
-            <a:r>
+              <a:defRPr sz="2000" b="0">
+                <a:latin typeface="Arial"/>
+              </a:defRPr>
+            </a:pPr>
+            <a:r>
+              <a:rPr>
+                <a:latin typeface="Arial"/>
+              </a:rPr>
               <a:t>• DBSCAN detecta anomalías de forma nativa (etiqueta -1)</a:t>
             </a:r>
           </a:p>
@@ -4613,9 +4732,14 @@
               <a:spcAft>
                 <a:spcPts val="800"/>
               </a:spcAft>
-              <a:defRPr sz="3200" b="1"/>
-            </a:pPr>
-            <a:r>
+              <a:defRPr sz="3200" b="1">
+                <a:latin typeface="Arial"/>
+              </a:defRPr>
+            </a:pPr>
+            <a:r>
+              <a:rPr>
+                <a:latin typeface="Arial"/>
+              </a:rPr>
               <a:t>Metodología: Fórmulas y parámetros</a:t>
             </a:r>
           </a:p>
@@ -4647,9 +4771,14 @@
               <a:spcAft>
                 <a:spcPts val="800"/>
               </a:spcAft>
-              <a:defRPr sz="2000" b="0"/>
-            </a:pPr>
-            <a:r>
+              <a:defRPr sz="2000" b="0">
+                <a:latin typeface="Arial"/>
+              </a:defRPr>
+            </a:pPr>
+            <a:r>
+              <a:rPr>
+                <a:latin typeface="Arial"/>
+              </a:rPr>
               <a:t>• Estandarización manual Z-Score con NumPy: Z = (X - μ) / σ</a:t>
             </a:r>
           </a:p>
@@ -4658,9 +4787,14 @@
               <a:spcAft>
                 <a:spcPts val="800"/>
               </a:spcAft>
-              <a:defRPr sz="2000" b="0"/>
-            </a:pPr>
-            <a:r>
+              <a:defRPr sz="2000" b="0">
+                <a:latin typeface="Arial"/>
+              </a:defRPr>
+            </a:pPr>
+            <a:r>
+              <a:rPr>
+                <a:latin typeface="Arial"/>
+              </a:rPr>
               <a:t>• Vecindad: N_ε(p) = { q | d(p, q) ≤ ε }</a:t>
             </a:r>
           </a:p>
@@ -4669,9 +4803,14 @@
               <a:spcAft>
                 <a:spcPts val="800"/>
               </a:spcAft>
-              <a:defRPr sz="2000" b="0"/>
-            </a:pPr>
-            <a:r>
+              <a:defRPr sz="2000" b="0">
+                <a:latin typeface="Arial"/>
+              </a:defRPr>
+            </a:pPr>
+            <a:r>
+              <a:rPr>
+                <a:latin typeface="Arial"/>
+              </a:rPr>
               <a:t>• Núcleo (Core Point): |N_ε(p)| ≥ min_samples</a:t>
             </a:r>
           </a:p>
@@ -4680,9 +4819,14 @@
               <a:spcAft>
                 <a:spcPts val="800"/>
               </a:spcAft>
-              <a:defRPr sz="2000" b="0"/>
-            </a:pPr>
-            <a:r>
+              <a:defRPr sz="2000" b="0">
+                <a:latin typeface="Arial"/>
+              </a:defRPr>
+            </a:pPr>
+            <a:r>
+              <a:rPr>
+                <a:latin typeface="Arial"/>
+              </a:rPr>
               <a:t>• Parámetros fijados: ε = 0,65 (codo k-NN) y min_samples = 3 (d = 2)</a:t>
             </a:r>
           </a:p>
@@ -4732,9 +4876,14 @@
               <a:spcAft>
                 <a:spcPts val="800"/>
               </a:spcAft>
-              <a:defRPr sz="3200" b="1"/>
-            </a:pPr>
-            <a:r>
+              <a:defRPr sz="3200" b="1">
+                <a:latin typeface="Arial"/>
+              </a:defRPr>
+            </a:pPr>
+            <a:r>
+              <a:rPr>
+                <a:latin typeface="Arial"/>
+              </a:rPr>
               <a:t>Resultado: DBSCAN en 57 materiales</a:t>
             </a:r>
           </a:p>
@@ -4766,9 +4915,14 @@
               <a:spcAft>
                 <a:spcPts val="800"/>
               </a:spcAft>
-              <a:defRPr sz="2000" b="0"/>
-            </a:pPr>
-            <a:r>
+              <a:defRPr sz="2000" b="0">
+                <a:latin typeface="Arial"/>
+              </a:defRPr>
+            </a:pPr>
+            <a:r>
+              <a:rPr>
+                <a:latin typeface="Arial"/>
+              </a:rPr>
               <a:t>• 3 clusters puros descubiertos por densidad: 0 ruido</a:t>
             </a:r>
           </a:p>
@@ -4777,9 +4931,14 @@
               <a:spcAft>
                 <a:spcPts val="800"/>
               </a:spcAft>
-              <a:defRPr sz="2000" b="0"/>
-            </a:pPr>
-            <a:r>
+              <a:defRPr sz="2000" b="0">
+                <a:latin typeface="Arial"/>
+              </a:defRPr>
+            </a:pPr>
+            <a:r>
+              <a:rPr>
+                <a:latin typeface="Arial"/>
+              </a:rPr>
               <a:t>• Cluster 0 (ámbar): 35 metales conductores (Cu, Ag, Au...)</a:t>
             </a:r>
           </a:p>
@@ -4788,9 +4947,14 @@
               <a:spcAft>
                 <a:spcPts val="800"/>
               </a:spcAft>
-              <a:defRPr sz="2000" b="0"/>
-            </a:pPr>
-            <a:r>
+              <a:defRPr sz="2000" b="0">
+                <a:latin typeface="Arial"/>
+              </a:defRPr>
+            </a:pPr>
+            <a:r>
+              <a:rPr>
+                <a:latin typeface="Arial"/>
+              </a:rPr>
               <a:t>• Cluster 1 (azul): 10 aislantes dieléctricos (vidrio, teflón...)</a:t>
             </a:r>
           </a:p>
@@ -4799,9 +4963,14 @@
               <a:spcAft>
                 <a:spcPts val="800"/>
               </a:spcAft>
-              <a:defRPr sz="2000" b="0"/>
-            </a:pPr>
-            <a:r>
+              <a:defRPr sz="2000" b="0">
+                <a:latin typeface="Arial"/>
+              </a:defRPr>
+            </a:pPr>
+            <a:r>
+              <a:rPr>
+                <a:latin typeface="Arial"/>
+              </a:rPr>
               <a:t>• Cluster 2 (verde): 10 semiconductores (Si, Ge, GaAs...)</a:t>
             </a:r>
           </a:p>
@@ -4810,9 +4979,14 @@
               <a:spcAft>
                 <a:spcPts val="800"/>
               </a:spcAft>
-              <a:defRPr sz="2000" b="0"/>
-            </a:pPr>
-            <a:r>
+              <a:defRPr sz="2000" b="0">
+                <a:latin typeface="Arial"/>
+              </a:defRPr>
+            </a:pPr>
+            <a:r>
+              <a:rPr>
+                <a:latin typeface="Arial"/>
+              </a:rPr>
               <a:t>• Frontera α = 0: fonones vs activación térmica</a:t>
             </a:r>
           </a:p>
@@ -4886,9 +5060,14 @@
               <a:spcAft>
                 <a:spcPts val="800"/>
               </a:spcAft>
-              <a:defRPr sz="3200" b="1"/>
-            </a:pPr>
-            <a:r>
+              <a:defRPr sz="3200" b="1">
+                <a:latin typeface="Arial"/>
+              </a:defRPr>
+            </a:pPr>
+            <a:r>
+              <a:rPr>
+                <a:latin typeface="Arial"/>
+              </a:rPr>
               <a:t>Validación física: Matriz de contingencia</a:t>
             </a:r>
           </a:p>
@@ -4920,9 +5099,14 @@
               <a:spcAft>
                 <a:spcPts val="800"/>
               </a:spcAft>
-              <a:defRPr sz="2000" b="0"/>
-            </a:pPr>
-            <a:r>
+              <a:defRPr sz="2000" b="0">
+                <a:latin typeface="Arial"/>
+              </a:defRPr>
+            </a:pPr>
+            <a:r>
+              <a:rPr>
+                <a:latin typeface="Arial"/>
+              </a:rPr>
               <a:t>• Conductores: 35 de 35 (100 % pureza en Cluster 0)</a:t>
             </a:r>
           </a:p>
@@ -4931,9 +5115,14 @@
               <a:spcAft>
                 <a:spcPts val="800"/>
               </a:spcAft>
-              <a:defRPr sz="2000" b="0"/>
-            </a:pPr>
-            <a:r>
+              <a:defRPr sz="2000" b="0">
+                <a:latin typeface="Arial"/>
+              </a:defRPr>
+            </a:pPr>
+            <a:r>
+              <a:rPr>
+                <a:latin typeface="Arial"/>
+              </a:rPr>
               <a:t>• Aislantes: 10 de 10 (100 % pureza en Cluster 1)</a:t>
             </a:r>
           </a:p>
@@ -4942,9 +5131,14 @@
               <a:spcAft>
                 <a:spcPts val="800"/>
               </a:spcAft>
-              <a:defRPr sz="2000" b="0"/>
-            </a:pPr>
-            <a:r>
+              <a:defRPr sz="2000" b="0">
+                <a:latin typeface="Arial"/>
+              </a:defRPr>
+            </a:pPr>
+            <a:r>
+              <a:rPr>
+                <a:latin typeface="Arial"/>
+              </a:rPr>
               <a:t>• Semiconductores: 10 de 12 (83,3 % pureza en Cluster 2; 2 semimetales en cluster 0)</a:t>
             </a:r>
           </a:p>
@@ -4953,9 +5147,14 @@
               <a:spcAft>
                 <a:spcPts val="800"/>
               </a:spcAft>
-              <a:defRPr sz="2000" b="0"/>
-            </a:pPr>
-            <a:r>
+              <a:defRPr sz="2000" b="0">
+                <a:latin typeface="Arial"/>
+              </a:defRPr>
+            </a:pPr>
+            <a:r>
+              <a:rPr>
+                <a:latin typeface="Arial"/>
+              </a:rPr>
               <a:t>• Silhouette Score complementario: 0,7858 (alta cohesión interna)</a:t>
             </a:r>
           </a:p>
@@ -5005,9 +5204,14 @@
               <a:spcAft>
                 <a:spcPts val="800"/>
               </a:spcAft>
-              <a:defRPr sz="3200" b="1"/>
-            </a:pPr>
-            <a:r>
+              <a:defRPr sz="3200" b="1">
+                <a:latin typeface="Arial"/>
+              </a:defRPr>
+            </a:pPr>
+            <a:r>
+              <a:rPr>
+                <a:latin typeface="Arial"/>
+              </a:rPr>
               <a:t>Conclusiones</a:t>
             </a:r>
           </a:p>
@@ -5034,7 +5238,13 @@
             <a:spAutoFit/>
           </a:bodyPr>
           <a:lstStyle/>
-          <a:p/>
+          <a:p>
+            <a:pPr>
+              <a:defRPr>
+                <a:latin typeface="Arial"/>
+              </a:defRPr>
+            </a:pPr>
+          </a:p>
         </p:txBody>
       </p:sp>
       <p:sp>
@@ -5067,9 +5277,13 @@
                 <a:solidFill>
                   <a:srgbClr val="B03030"/>
                 </a:solidFill>
-              </a:defRPr>
-            </a:pPr>
-            <a:r>
+                <a:latin typeface="Arial"/>
+              </a:defRPr>
+            </a:pPr>
+            <a:r>
+              <a:rPr>
+                <a:latin typeface="Arial"/>
+              </a:rPr>
               <a:t>[PENDIENTE: comparativa del equipo: qué algoritmo funcionó mejor y por qué]</a:t>
             </a:r>
           </a:p>
@@ -5119,9 +5333,14 @@
               <a:spcAft>
                 <a:spcPts val="800"/>
               </a:spcAft>
-              <a:defRPr sz="3200" b="1"/>
-            </a:pPr>
-            <a:r>
+              <a:defRPr sz="3200" b="1">
+                <a:latin typeface="Arial"/>
+              </a:defRPr>
+            </a:pPr>
+            <a:r>
+              <a:rPr>
+                <a:latin typeface="Arial"/>
+              </a:rPr>
               <a:t>Preguntas</a:t>
             </a:r>
           </a:p>
@@ -5153,9 +5372,14 @@
               <a:spcAft>
                 <a:spcPts val="800"/>
               </a:spcAft>
-              <a:defRPr sz="2000" b="0"/>
-            </a:pPr>
-            <a:r>
+              <a:defRPr sz="2000" b="0">
+                <a:latin typeface="Arial"/>
+              </a:defRPr>
+            </a:pPr>
+            <a:r>
+              <a:rPr>
+                <a:latin typeface="Arial"/>
+              </a:rPr>
               <a:t>• Código y documento de descripción entregados en Atenea</a:t>
             </a:r>
           </a:p>
@@ -5205,9 +5429,14 @@
               <a:spcAft>
                 <a:spcPts val="800"/>
               </a:spcAft>
-              <a:defRPr sz="3200" b="1"/>
-            </a:pPr>
-            <a:r>
+              <a:defRPr sz="3200" b="1">
+                <a:latin typeface="Arial"/>
+              </a:defRPr>
+            </a:pPr>
+            <a:r>
+              <a:rPr>
+                <a:latin typeface="Arial"/>
+              </a:rPr>
               <a:t>Qué vamos a ver</a:t>
             </a:r>
           </a:p>
@@ -5239,9 +5468,14 @@
               <a:spcAft>
                 <a:spcPts val="800"/>
               </a:spcAft>
-              <a:defRPr sz="2000" b="0"/>
-            </a:pPr>
-            <a:r>
+              <a:defRPr sz="2000" b="0">
+                <a:latin typeface="Arial"/>
+              </a:defRPr>
+            </a:pPr>
+            <a:r>
+              <a:rPr>
+                <a:latin typeface="Arial"/>
+              </a:rPr>
               <a:t>• Clustering: K-Means, DBSCAN, jerárquico</a:t>
             </a:r>
           </a:p>
@@ -5250,9 +5484,14 @@
               <a:spcAft>
                 <a:spcPts val="800"/>
               </a:spcAft>
-              <a:defRPr sz="2000" b="0"/>
-            </a:pPr>
-            <a:r>
+              <a:defRPr sz="2000" b="0">
+                <a:latin typeface="Arial"/>
+              </a:defRPr>
+            </a:pPr>
+            <a:r>
+              <a:rPr>
+                <a:latin typeface="Arial"/>
+              </a:rPr>
               <a:t>• Mezclas gaussianas (GaussianMixture) e Isolation Forest</a:t>
             </a:r>
           </a:p>
@@ -5261,9 +5500,14 @@
               <a:spcAft>
                 <a:spcPts val="800"/>
               </a:spcAft>
-              <a:defRPr sz="2000" b="0"/>
-            </a:pPr>
-            <a:r>
+              <a:defRPr sz="2000" b="0">
+                <a:latin typeface="Arial"/>
+              </a:defRPr>
+            </a:pPr>
+            <a:r>
+              <a:rPr>
+                <a:latin typeface="Arial"/>
+              </a:rPr>
               <a:t>• Evaluar sin etiquetas: silhouette y método del codo</a:t>
             </a:r>
           </a:p>
@@ -5272,9 +5516,14 @@
               <a:spcAft>
                 <a:spcPts val="800"/>
               </a:spcAft>
-              <a:defRPr sz="2000" b="0"/>
-            </a:pPr>
-            <a:r>
+              <a:defRPr sz="2000" b="0">
+                <a:latin typeface="Arial"/>
+              </a:defRPr>
+            </a:pPr>
+            <a:r>
+              <a:rPr>
+                <a:latin typeface="Arial"/>
+              </a:rPr>
               <a:t>• Cuatro problemas con aplicación física, uno por persona</a:t>
             </a:r>
           </a:p>
@@ -5310,9 +5559,13 @@
                 <a:solidFill>
                   <a:srgbClr val="B03030"/>
                 </a:solidFill>
-              </a:defRPr>
-            </a:pPr>
-            <a:r>
+                <a:latin typeface="Arial"/>
+              </a:defRPr>
+            </a:pPr>
+            <a:r>
+              <a:rPr>
+                <a:latin typeface="Arial"/>
+              </a:rPr>
               <a:t>[PENDIENTE: el equipo reparte quién explica la teoría de cada algoritmo]</a:t>
             </a:r>
           </a:p>
@@ -5362,9 +5615,14 @@
               <a:spcAft>
                 <a:spcPts val="800"/>
               </a:spcAft>
-              <a:defRPr sz="3200" b="1"/>
-            </a:pPr>
-            <a:r>
+              <a:defRPr sz="3200" b="1">
+                <a:latin typeface="Arial"/>
+              </a:defRPr>
+            </a:pPr>
+            <a:r>
+              <a:rPr>
+                <a:latin typeface="Arial"/>
+              </a:rPr>
               <a:t>Teoría común</a:t>
             </a:r>
           </a:p>
@@ -5391,7 +5649,13 @@
             <a:spAutoFit/>
           </a:bodyPr>
           <a:lstStyle/>
-          <a:p/>
+          <a:p>
+            <a:pPr>
+              <a:defRPr>
+                <a:latin typeface="Arial"/>
+              </a:defRPr>
+            </a:pPr>
+          </a:p>
         </p:txBody>
       </p:sp>
       <p:sp>
@@ -5424,9 +5688,13 @@
                 <a:solidFill>
                   <a:srgbClr val="B03030"/>
                 </a:solidFill>
-              </a:defRPr>
-            </a:pPr>
-            <a:r>
+                <a:latin typeface="Arial"/>
+              </a:defRPr>
+            </a:pPr>
+            <a:r>
+              <a:rPr>
+                <a:latin typeface="Arial"/>
+              </a:rPr>
               <a:t>[PENDIENTE: diapositivas de K-Means, DBSCAN, jerárquico, GMM, Isolation Forest, silhouette y codo]</a:t>
             </a:r>
           </a:p>
@@ -5476,9 +5744,14 @@
               <a:spcAft>
                 <a:spcPts val="800"/>
               </a:spcAft>
-              <a:defRPr sz="3200" b="1"/>
-            </a:pPr>
-            <a:r>
+              <a:defRPr sz="3200" b="1">
+                <a:latin typeface="Arial"/>
+              </a:defRPr>
+            </a:pPr>
+            <a:r>
+              <a:rPr>
+                <a:latin typeface="Arial"/>
+              </a:rPr>
               <a:t>Problema: ¿terremoto o explosión nuclear?</a:t>
             </a:r>
           </a:p>
@@ -5510,9 +5783,14 @@
               <a:spcAft>
                 <a:spcPts val="800"/>
               </a:spcAft>
-              <a:defRPr sz="2000" b="0"/>
-            </a:pPr>
-            <a:r>
+              <a:defRPr sz="2000" b="0">
+                <a:latin typeface="Arial"/>
+              </a:defRPr>
+            </a:pPr>
+            <a:r>
+              <a:rPr>
+                <a:latin typeface="Arial"/>
+              </a:rPr>
               <a:t>• Sismógrafos: mismos registros para terremotos y explosiones</a:t>
             </a:r>
           </a:p>
@@ -5521,9 +5799,14 @@
               <a:spcAft>
                 <a:spcPts val="800"/>
               </a:spcAft>
-              <a:defRPr sz="2000" b="0"/>
-            </a:pPr>
-            <a:r>
+              <a:defRPr sz="2000" b="0">
+                <a:latin typeface="Arial"/>
+              </a:defRPr>
+            </a:pPr>
+            <a:r>
+              <a:rPr>
+                <a:latin typeface="Arial"/>
+              </a:rPr>
               <a:t>• Sin usar la etiqueta, ¿puede un clustering señalarlas?</a:t>
             </a:r>
           </a:p>
@@ -5532,9 +5815,14 @@
               <a:spcAft>
                 <a:spcPts val="800"/>
               </a:spcAft>
-              <a:defRPr sz="2000" b="0"/>
-            </a:pPr>
-            <a:r>
+              <a:defRPr sz="2000" b="0">
+                <a:latin typeface="Arial"/>
+              </a:defRPr>
+            </a:pPr>
+            <a:r>
+              <a:rPr>
+                <a:latin typeface="Arial"/>
+              </a:rPr>
               <a:t>• Pista 1: las pruebas se repiten en los mismos polígonos</a:t>
             </a:r>
           </a:p>
@@ -5543,9 +5831,14 @@
               <a:spcAft>
                 <a:spcPts val="800"/>
               </a:spcAft>
-              <a:defRPr sz="2000" b="0"/>
-            </a:pPr>
-            <a:r>
+              <a:defRPr sz="2000" b="0">
+                <a:latin typeface="Arial"/>
+              </a:defRPr>
+            </a:pPr>
+            <a:r>
+              <a:rPr>
+                <a:latin typeface="Arial"/>
+              </a:rPr>
               <a:t>• Pista 2: ocurren casi en la superficie (mediana 0 km frente a 22 km)</a:t>
             </a:r>
           </a:p>
@@ -5619,9 +5912,14 @@
               <a:spcAft>
                 <a:spcPts val="800"/>
               </a:spcAft>
-              <a:defRPr sz="3200" b="1"/>
-            </a:pPr>
-            <a:r>
+              <a:defRPr sz="3200" b="1">
+                <a:latin typeface="Arial"/>
+              </a:defRPr>
+            </a:pPr>
+            <a:r>
+              <a:rPr>
+                <a:latin typeface="Arial"/>
+              </a:rPr>
               <a:t>Datos</a:t>
             </a:r>
           </a:p>
@@ -5653,9 +5951,14 @@
               <a:spcAft>
                 <a:spcPts val="800"/>
               </a:spcAft>
-              <a:defRPr sz="2000" b="0"/>
-            </a:pPr>
-            <a:r>
+              <a:defRPr sz="2000" b="0">
+                <a:latin typeface="Arial"/>
+              </a:defRPr>
+            </a:pPr>
+            <a:r>
+              <a:rPr>
+                <a:latin typeface="Arial"/>
+              </a:rPr>
               <a:t>• Catálogo USGS, M ≥ 4,5, 1951-2025</a:t>
             </a:r>
           </a:p>
@@ -5664,9 +5967,14 @@
               <a:spcAft>
                 <a:spcPts val="800"/>
               </a:spcAft>
-              <a:defRPr sz="2000" b="0"/>
-            </a:pPr>
-            <a:r>
+              <a:defRPr sz="2000" b="0">
+                <a:latin typeface="Arial"/>
+              </a:defRPr>
+            </a:pPr>
+            <a:r>
+              <a:rPr>
+                <a:latin typeface="Arial"/>
+              </a:rPr>
               <a:t>• 298 025 eventos; 614 etiquetados «nuclear explosion»</a:t>
             </a:r>
           </a:p>
@@ -5675,9 +5983,14 @@
               <a:spcAft>
                 <a:spcPts val="800"/>
               </a:spcAft>
-              <a:defRPr sz="2000" b="0"/>
-            </a:pPr>
-            <a:r>
+              <a:defRPr sz="2000" b="0">
+                <a:latin typeface="Arial"/>
+              </a:defRPr>
+            </a:pPr>
+            <a:r>
+              <a:rPr>
+                <a:latin typeface="Arial"/>
+              </a:rPr>
               <a:t>• La etiqueta solo se usa para evaluar, nunca para entrenar</a:t>
             </a:r>
           </a:p>
@@ -5751,9 +6064,14 @@
               <a:spcAft>
                 <a:spcPts val="800"/>
               </a:spcAft>
-              <a:defRPr sz="3200" b="1"/>
-            </a:pPr>
-            <a:r>
+              <a:defRPr sz="3200" b="1">
+                <a:latin typeface="Arial"/>
+              </a:defRPr>
+            </a:pPr>
+            <a:r>
+              <a:rPr>
+                <a:latin typeface="Arial"/>
+              </a:rPr>
               <a:t>Cómo se detecta</a:t>
             </a:r>
           </a:p>
@@ -5785,9 +6103,14 @@
               <a:spcAft>
                 <a:spcPts val="800"/>
               </a:spcAft>
-              <a:defRPr sz="2000" b="0"/>
-            </a:pPr>
-            <a:r>
+              <a:defRPr sz="2000" b="0">
+                <a:latin typeface="Arial"/>
+              </a:defRPr>
+            </a:pPr>
+            <a:r>
+              <a:rPr>
+                <a:latin typeface="Arial"/>
+              </a:rPr>
               <a:t>• 1. DBSCAN con distancia haversine (esfera)</a:t>
             </a:r>
           </a:p>
@@ -5796,9 +6119,14 @@
               <a:spcAft>
                 <a:spcPts val="800"/>
               </a:spcAft>
-              <a:defRPr sz="2000" b="0"/>
-            </a:pPr>
-            <a:r>
+              <a:defRPr sz="2000" b="0">
+                <a:latin typeface="Arial"/>
+              </a:defRPr>
+            </a:pPr>
+            <a:r>
+              <a:rPr>
+                <a:latin typeface="Arial"/>
+              </a:rPr>
               <a:t>• 2. Mediana de profundidad de cada cluster</a:t>
             </a:r>
           </a:p>
@@ -5807,9 +6135,14 @@
               <a:spcAft>
                 <a:spcPts val="800"/>
               </a:spcAft>
-              <a:defRPr sz="2000" b="0"/>
-            </a:pPr>
-            <a:r>
+              <a:defRPr sz="2000" b="0">
+                <a:latin typeface="Arial"/>
+              </a:defRPr>
+            </a:pPr>
+            <a:r>
+              <a:rPr>
+                <a:latin typeface="Arial"/>
+              </a:rPr>
               <a:t>• 3. Sospechoso si mediana en [dmin, dmax)</a:t>
             </a:r>
           </a:p>
@@ -5818,9 +6151,14 @@
               <a:spcAft>
                 <a:spcPts val="800"/>
               </a:spcAft>
-              <a:defRPr sz="2000" b="0"/>
-            </a:pPr>
-            <a:r>
+              <a:defRPr sz="2000" b="0">
+                <a:latin typeface="Arial"/>
+              </a:defRPr>
+            </a:pPr>
+            <a:r>
+              <a:rPr>
+                <a:latin typeface="Arial"/>
+              </a:rPr>
               <a:t>• 4. Comparar con la etiqueta: aciertos, falsos positivos (FP) y falsos negativos (FN)</a:t>
             </a:r>
           </a:p>
@@ -5894,9 +6232,14 @@
               <a:spcAft>
                 <a:spcPts val="800"/>
               </a:spcAft>
-              <a:defRPr sz="3200" b="1"/>
-            </a:pPr>
-            <a:r>
+              <a:defRPr sz="3200" b="1">
+                <a:latin typeface="Arial"/>
+              </a:defRPr>
+            </a:pPr>
+            <a:r>
+              <a:rPr>
+                <a:latin typeface="Arial"/>
+              </a:rPr>
               <a:t>Elegir y validar los parámetros</a:t>
             </a:r>
           </a:p>
@@ -5928,9 +6271,14 @@
               <a:spcAft>
                 <a:spcPts val="800"/>
               </a:spcAft>
-              <a:defRPr sz="2000" b="0"/>
-            </a:pPr>
-            <a:r>
+              <a:defRPr sz="2000" b="0">
+                <a:latin typeface="Arial"/>
+              </a:defRPr>
+            </a:pPr>
+            <a:r>
+              <a:rPr>
+                <a:latin typeface="Arial"/>
+              </a:rPr>
               <a:t>• Parámetros fijos: eps = 25 km, vmin = 1, profundidad mediana en [0; 2,5) km (criterio físico)</a:t>
             </a:r>
           </a:p>
@@ -5939,9 +6287,14 @@
               <a:spcAft>
                 <a:spcPts val="800"/>
               </a:spcAft>
-              <a:defRPr sz="2000" b="0"/>
-            </a:pPr>
-            <a:r>
+              <a:defRPr sz="2000" b="0">
+                <a:latin typeface="Arial"/>
+              </a:defRPr>
+            </a:pPr>
+            <a:r>
+              <a:rPr>
+                <a:latin typeface="Arial"/>
+              </a:rPr>
               <a:t>• eps = 25 km da el mínimo de falsos positivos (91) entre 5 y 100 km; es la única elección que mira la etiqueta</a:t>
             </a:r>
           </a:p>
@@ -5950,9 +6303,14 @@
               <a:spcAft>
                 <a:spcPts val="800"/>
               </a:spcAft>
-              <a:defRPr sz="2000" b="0"/>
-            </a:pPr>
-            <a:r>
+              <a:defRPr sz="2000" b="0">
+                <a:latin typeface="Arial"/>
+              </a:defRPr>
+            </a:pPr>
+            <a:r>
+              <a:rPr>
+                <a:latin typeface="Arial"/>
+              </a:rPr>
               <a:t>• La silueta no elige eps (es negativa y baja con eps); el codo de distancias k no marca un valor claro</a:t>
             </a:r>
           </a:p>
@@ -5961,9 +6319,14 @@
               <a:spcAft>
                 <a:spcPts val="800"/>
               </a:spcAft>
-              <a:defRPr sz="2000" b="0"/>
-            </a:pPr>
-            <a:r>
+              <a:defRPr sz="2000" b="0">
+                <a:latin typeface="Arial"/>
+              </a:defRPr>
+            </a:pPr>
+            <a:r>
+              <a:rPr>
+                <a:latin typeface="Arial"/>
+              </a:rPr>
               <a:t>• Con eps ≥ 50 km los grupos se funden con terremotos profundos: FP 460 (50 km) y FN 261 (75 km)</a:t>
             </a:r>
           </a:p>
@@ -5972,9 +6335,14 @@
               <a:spcAft>
                 <a:spcPts val="800"/>
               </a:spcAft>
-              <a:defRPr sz="2000" b="0"/>
-            </a:pPr>
-            <a:r>
+              <a:defRPr sz="2000" b="0">
+                <a:latin typeface="Arial"/>
+              </a:defRPr>
+            </a:pPr>
+            <a:r>
+              <a:rPr>
+                <a:latin typeface="Arial"/>
+              </a:rPr>
               <a:t>• Estabilidad (ARI, muestra del 50 %): 0,52-0,62</a:t>
             </a:r>
           </a:p>
@@ -5983,9 +6351,14 @@
               <a:spcAft>
                 <a:spcPts val="800"/>
               </a:spcAft>
-              <a:defRPr sz="2000" b="0"/>
-            </a:pPr>
-            <a:r>
+              <a:defRPr sz="2000" b="0">
+                <a:latin typeface="Arial"/>
+              </a:defRPr>
+            </a:pPr>
+            <a:r>
+              <a:rPr>
+                <a:latin typeface="Arial"/>
+              </a:rPr>
               <a:t>• nuke_optimizar.py se probó y se descartó: su ventana [0; 0,1) mide la convención del USGS</a:t>
             </a:r>
           </a:p>
@@ -6059,9 +6432,14 @@
               <a:spcAft>
                 <a:spcPts val="800"/>
               </a:spcAft>
-              <a:defRPr sz="3200" b="1"/>
-            </a:pPr>
-            <a:r>
+              <a:defRPr sz="3200" b="1">
+                <a:latin typeface="Arial"/>
+              </a:defRPr>
+            </a:pPr>
+            <a:r>
+              <a:rPr>
+                <a:latin typeface="Arial"/>
+              </a:rPr>
               <a:t>Resultado</a:t>
             </a:r>
           </a:p>
@@ -6093,9 +6471,14 @@
               <a:spcAft>
                 <a:spcPts val="800"/>
               </a:spcAft>
-              <a:defRPr sz="2000" b="0"/>
-            </a:pPr>
-            <a:r>
+              <a:defRPr sz="2000" b="0">
+                <a:latin typeface="Arial"/>
+              </a:defRPr>
+            </a:pPr>
+            <a:r>
+              <a:rPr>
+                <a:latin typeface="Arial"/>
+              </a:rPr>
               <a:t>• 586 aciertos, 91 FP, 28 FN</a:t>
             </a:r>
           </a:p>
@@ -6104,9 +6487,14 @@
               <a:spcAft>
                 <a:spcPts val="800"/>
               </a:spcAft>
-              <a:defRPr sz="2000" b="0"/>
-            </a:pPr>
-            <a:r>
+              <a:defRPr sz="2000" b="0">
+                <a:latin typeface="Arial"/>
+              </a:defRPr>
+            </a:pPr>
+            <a:r>
+              <a:rPr>
+                <a:latin typeface="Arial"/>
+              </a:rPr>
               <a:t>• Precisión 86,6 %  ·  recall 95,4 %  ·  F1 = 0,908</a:t>
             </a:r>
           </a:p>
@@ -6115,9 +6503,14 @@
               <a:spcAft>
                 <a:spcPts val="800"/>
               </a:spcAft>
-              <a:defRPr sz="2000" b="0"/>
-            </a:pPr>
-            <a:r>
+              <a:defRPr sz="2000" b="0">
+                <a:latin typeface="Arial"/>
+              </a:defRPr>
+            </a:pPr>
+            <a:r>
+              <a:rPr>
+                <a:latin typeface="Arial"/>
+              </a:rPr>
               <a:t>• Globo interactivo: problemas/2_Nuclear/globo.html (4 vistas, sin internet)</a:t>
             </a:r>
           </a:p>
@@ -6191,9 +6584,14 @@
               <a:spcAft>
                 <a:spcPts val="800"/>
               </a:spcAft>
-              <a:defRPr sz="3200" b="1"/>
-            </a:pPr>
-            <a:r>
+              <a:defRPr sz="3200" b="1">
+                <a:latin typeface="Arial"/>
+              </a:defRPr>
+            </a:pPr>
+            <a:r>
+              <a:rPr>
+                <a:latin typeface="Arial"/>
+              </a:rPr>
               <a:t>Limitaciones (preguntas probables)</a:t>
             </a:r>
           </a:p>
@@ -6225,9 +6623,14 @@
               <a:spcAft>
                 <a:spcPts val="800"/>
               </a:spcAft>
-              <a:defRPr sz="2000" b="0"/>
-            </a:pPr>
-            <a:r>
+              <a:defRPr sz="2000" b="0">
+                <a:latin typeface="Arial"/>
+              </a:defRPr>
+            </a:pPr>
+            <a:r>
+              <a:rPr>
+                <a:latin typeface="Arial"/>
+              </a:rPr>
               <a:t>• vmin = 1: no hay ruido; la selección real la hace la profundidad. Con vmin = 3, F1 baja a 0,910</a:t>
             </a:r>
           </a:p>
@@ -6236,9 +6639,14 @@
               <a:spcAft>
                 <a:spcPts val="800"/>
               </a:spcAft>
-              <a:defRPr sz="2000" b="0"/>
-            </a:pPr>
-            <a:r>
+              <a:defRPr sz="2000" b="0">
+                <a:latin typeface="Arial"/>
+              </a:defRPr>
+            </a:pPr>
+            <a:r>
+              <a:rPr>
+                <a:latin typeface="Arial"/>
+              </a:rPr>
               <a:t>• Mismos parámetros en los dos catálogos: F1 0,908 (grande) y 0,955 (pequeño); sin conjunto de prueba separado</a:t>
             </a:r>
           </a:p>
@@ -6247,9 +6655,14 @@
               <a:spcAft>
                 <a:spcPts val="800"/>
               </a:spcAft>
-              <a:defRPr sz="2000" b="0"/>
-            </a:pPr>
-            <a:r>
+              <a:defRPr sz="2000" b="0">
+                <a:latin typeface="Arial"/>
+              </a:defRPr>
+            </a:pPr>
+            <a:r>
+              <a:rPr>
+                <a:latin typeface="Arial"/>
+              </a:rPr>
               <a:t>• El 85 % de las explosiones figura con profundidad 0,0 km en el USGS: una ventana [0; 0,1) daría F1 0,947, pero mediría esa convención</a:t>
             </a:r>
           </a:p>
@@ -6258,9 +6671,14 @@
               <a:spcAft>
                 <a:spcPts val="800"/>
               </a:spcAft>
-              <a:defRPr sz="2000" b="0"/>
-            </a:pPr>
-            <a:r>
+              <a:defRPr sz="2000" b="0">
+                <a:latin typeface="Arial"/>
+              </a:defRPr>
+            </a:pPr>
+            <a:r>
+              <a:rPr>
+                <a:latin typeface="Arial"/>
+              </a:rPr>
               <a:t>• FP: terremotos muy superficiales y explosiones de minas; algunas pruebas oficiales figuran como earthquake</a:t>
             </a:r>
           </a:p>
@@ -6269,9 +6687,14 @@
               <a:spcAft>
                 <a:spcPts val="800"/>
               </a:spcAft>
-              <a:defRPr sz="2000" b="0"/>
-            </a:pPr>
-            <a:r>
+              <a:defRPr sz="2000" b="0">
+                <a:latin typeface="Arial"/>
+              </a:defRPr>
+            </a:pPr>
+            <a:r>
+              <a:rPr>
+                <a:latin typeface="Arial"/>
+              </a:rPr>
               <a:t>• No usamos año ni número de estaciones: delatarían la época, no la física</a:t>
             </a:r>
           </a:p>

</xml_diff>

<commit_message>
Regenerar presentacion con el catalogo completo tras integrar la parte de Uriel
Co-Authored-By: Claude Sonnet 5.5 <noreply@anthropic.com>
Claude-Session: https://claude.ai/code/session_01Q6fDk4UWe6v6CR3QJZP5xS
</commit_message>
<xml_diff>
--- a/presentacion/expo_cpia.pptx
+++ b/presentacion/expo_cpia.pptx
@@ -5959,7 +5959,7 @@
               <a:rPr>
                 <a:latin typeface="Arial"/>
               </a:rPr>
-              <a:t>• Catálogo USGS, M ≥ 4,5, 1951-2025</a:t>
+              <a:t>• Catálogo USGS, M ≥ 4,5, 1951-2025, todos los tipos de evento</a:t>
             </a:r>
           </a:p>
           <a:p>
@@ -5975,7 +5975,7 @@
               <a:rPr>
                 <a:latin typeface="Arial"/>
               </a:rPr>
-              <a:t>• 298 025 eventos; 614 etiquetados «nuclear explosion»</a:t>
+              <a:t>• 298 127 eventos; 614 etiquetados «nuclear explosion»</a:t>
             </a:r>
           </a:p>
           <a:p>
@@ -6295,7 +6295,7 @@
               <a:rPr>
                 <a:latin typeface="Arial"/>
               </a:rPr>
-              <a:t>• eps = 25 km da el mínimo de falsos positivos (91) entre 5 y 100 km; es la única elección que mira la etiqueta</a:t>
+              <a:t>• eps = 25 km da el mínimo de falsos positivos (115) entre 5 y 100 km; es la única elección que mira la etiqueta</a:t>
             </a:r>
           </a:p>
           <a:p>
@@ -6327,7 +6327,7 @@
               <a:rPr>
                 <a:latin typeface="Arial"/>
               </a:rPr>
-              <a:t>• Con eps ≥ 50 km los grupos se funden con terremotos profundos: FP 460 (50 km) y FN 261 (75 km)</a:t>
+              <a:t>• Con eps ≥ 50 km los grupos se funden con terremotos profundos: FP 483 (50 km) y FN 261 (75 km)</a:t>
             </a:r>
           </a:p>
           <a:p>
@@ -6343,7 +6343,7 @@
               <a:rPr>
                 <a:latin typeface="Arial"/>
               </a:rPr>
-              <a:t>• Estabilidad (ARI, muestra del 50 %): 0,52-0,62</a:t>
+              <a:t>• Estabilidad (ARI, muestra del 50 %): 0,54-0,65</a:t>
             </a:r>
           </a:p>
           <a:p>
@@ -6479,7 +6479,7 @@
               <a:rPr>
                 <a:latin typeface="Arial"/>
               </a:rPr>
-              <a:t>• 586 aciertos, 91 FP, 28 FN</a:t>
+              <a:t>• 586 aciertos, 115 FP, 28 FN</a:t>
             </a:r>
           </a:p>
           <a:p>
@@ -6495,7 +6495,7 @@
               <a:rPr>
                 <a:latin typeface="Arial"/>
               </a:rPr>
-              <a:t>• Precisión 86,6 %  ·  recall 95,4 %  ·  F1 = 0,908</a:t>
+              <a:t>• Precisión 83,6 %  ·  recall 95,4 %  ·  F1 = 0,891</a:t>
             </a:r>
           </a:p>
           <a:p>
@@ -6631,7 +6631,7 @@
               <a:rPr>
                 <a:latin typeface="Arial"/>
               </a:rPr>
-              <a:t>• vmin = 1: no hay ruido; la selección real la hace la profundidad. Con vmin = 3, F1 baja a 0,910</a:t>
+              <a:t>• vmin = 1: no hay ruido; la selección real la hace la profundidad. Con vmin = 3, F1 baja a 0,899</a:t>
             </a:r>
           </a:p>
           <a:p>
@@ -6647,7 +6647,7 @@
               <a:rPr>
                 <a:latin typeface="Arial"/>
               </a:rPr>
-              <a:t>• Mismos parámetros en los dos catálogos: F1 0,908 (grande) y 0,955 (pequeño); sin conjunto de prueba separado</a:t>
+              <a:t>• Sin conjunto de prueba separado: se ajusta y se evalúa en el mismo catálogo</a:t>
             </a:r>
           </a:p>
           <a:p>
@@ -6663,7 +6663,7 @@
               <a:rPr>
                 <a:latin typeface="Arial"/>
               </a:rPr>
-              <a:t>• El 85 % de las explosiones figura con profundidad 0,0 km en el USGS: una ventana [0; 0,1) daría F1 0,947, pero mediría esa convención</a:t>
+              <a:t>• El 85 % de las explosiones figura con profundidad 0,0 km en el USGS: una ventana [0; 0,1) daría F1 0,931, pero mediría esa convención</a:t>
             </a:r>
           </a:p>
           <a:p>
@@ -6679,7 +6679,23 @@
               <a:rPr>
                 <a:latin typeface="Arial"/>
               </a:rPr>
-              <a:t>• FP: terremotos muy superficiales y explosiones de minas; algunas pruebas oficiales figuran como earthquake</a:t>
+              <a:t>• 115 FP: 24 son otros eventos no sísmicos (explosiones, minas); sin ellos serían 91 y F1 0,908</a:t>
+            </a:r>
+          </a:p>
+          <a:p>
+            <a:pPr>
+              <a:spcAft>
+                <a:spcPts val="800"/>
+              </a:spcAft>
+              <a:defRPr sz="2000" b="0">
+                <a:latin typeface="Arial"/>
+              </a:defRPr>
+            </a:pPr>
+            <a:r>
+              <a:rPr>
+                <a:latin typeface="Arial"/>
+              </a:rPr>
+              <a:t>• Algunas pruebas oficiales figuran como earthquake (error de la etiqueta)</a:t>
             </a:r>
           </a:p>
           <a:p>

</xml_diff>

<commit_message>
docs(catala): traduir informe LaTeX, presentacio i grafics al catala
</commit_message>
<xml_diff>
--- a/presentacion/expo_cpia.pptx
+++ b/presentacion/expo_cpia.pptx
@@ -590,7 +590,7 @@
           <a:lstStyle/>
           <a:p>
             <a:r>
-              <a:t>Estructura de bandas y variación térmica: el signo y magnitud de alfa delatan la física microscópica.</a:t>
+              <a:t>Estructura de bandes i variació tèrmica: el signe i la magnitud d'alfa delaten la física microscòpica.</a:t>
             </a:r>
           </a:p>
         </p:txBody>
@@ -660,7 +660,7 @@
           <a:lstStyle/>
           <a:p>
             <a:r>
-              <a:t>Comparativa de escala: la compresión logarítmica es imprescindible para que los metales y aislantes coexistan.</a:t>
+              <a:t>Comparativa d'escala: la compressió logarítmica és imprescindible perquè metalls i aïllants coexisteixin.</a:t>
             </a:r>
           </a:p>
         </p:txBody>
@@ -730,7 +730,7 @@
           <a:lstStyle/>
           <a:p>
             <a:r>
-              <a:t>K-Means asume varianzas similares y falla; DBSCAN conecta por densidad y respeta la dispersión natural.</a:t>
+              <a:t>K-Means assumeix variàncies similars i falla; DBSCAN connecta per densitat i respecta la dispersió natural.</a:t>
             </a:r>
           </a:p>
         </p:txBody>
@@ -800,7 +800,7 @@
           <a:lstStyle/>
           <a:p>
             <a:r>
-              <a:t>Resultado gráfico: el plano 2D muestra la separación nítida de las tres clases.</a:t>
+              <a:t>Resultat gràfic: el pla 2D mostra la separació nítida de les tres classes.</a:t>
             </a:r>
           </a:p>
         </p:txBody>
@@ -4236,7 +4236,7 @@
               <a:rPr>
                 <a:latin typeface="Arial"/>
               </a:rPr>
-              <a:t>Problema: 3 familias y firmas térmicas</a:t>
+              <a:t>Problema: 3 famílies i signatures tèrmiques</a:t>
             </a:r>
           </a:p>
         </p:txBody>
@@ -4275,7 +4275,7 @@
               <a:rPr>
                 <a:latin typeface="Arial"/>
               </a:rPr>
-              <a:t>• Conducción según la estructura cuántica de bandas</a:t>
+              <a:t>• Conducció segons l'estructura quàntica de bandes</a:t>
             </a:r>
           </a:p>
           <a:p>
@@ -4291,7 +4291,7 @@
               <a:rPr>
                 <a:latin typeface="Arial"/>
               </a:rPr>
-              <a:t>• Variación térmica: ρ(T) = ρ₀ · [1 + α·(T - T₀)]</a:t>
+              <a:t>• Variació tèrmica: ρ(T) = ρ₀ · [1 + α·(T - T₀)]</a:t>
             </a:r>
           </a:p>
           <a:p>
@@ -4307,7 +4307,7 @@
               <a:rPr>
                 <a:latin typeface="Arial"/>
               </a:rPr>
-              <a:t>• Coeficiente térmico: α = (1 / ρ₀) · (dρ / dT)₃₀₀K</a:t>
+              <a:t>• Coeficient tèrmic: α = (1 / ρ₀) · (dρ / dT)₃₀₀K</a:t>
             </a:r>
           </a:p>
           <a:p>
@@ -4323,7 +4323,7 @@
               <a:rPr>
                 <a:latin typeface="Arial"/>
               </a:rPr>
-              <a:t>• Metales (α &gt; 0) · Semiconductores (α &lt; 0) · Aislantes (α ≈ 0)</a:t>
+              <a:t>• Metalls (α &gt; 0) · Semiconductors (α &lt; 0) · Aïllants (α ≈ 0)</a:t>
             </a:r>
           </a:p>
         </p:txBody>
@@ -4404,7 +4404,7 @@
               <a:rPr>
                 <a:latin typeface="Arial"/>
               </a:rPr>
-              <a:t>Dataset y espacio (log₁₀ρ, α)</a:t>
+              <a:t>Dataset i espai (log₁₀ρ, α)</a:t>
             </a:r>
           </a:p>
         </p:txBody>
@@ -4443,7 +4443,7 @@
               <a:rPr>
                 <a:latin typeface="Arial"/>
               </a:rPr>
-              <a:t>• 57 materiales reales recopilados experimentalmente</a:t>
+              <a:t>• 57 materials reals recopilats experimentalment</a:t>
             </a:r>
           </a:p>
           <a:p>
@@ -4459,7 +4459,7 @@
               <a:rPr>
                 <a:latin typeface="Arial"/>
               </a:rPr>
-              <a:t>• 30 órdenes de magnitud en resistividad (10⁻⁸ a 10²² Ω·m)</a:t>
+              <a:t>• 30 ordres de magnitud en resistivitat (10⁻⁸ a 10²² Ω·m)</a:t>
             </a:r>
           </a:p>
           <a:p>
@@ -4475,7 +4475,7 @@
               <a:rPr>
                 <a:latin typeface="Arial"/>
               </a:rPr>
-              <a:t>• Escala lineal colapsa en el origen; log₁₀(ρ) separa las fases</a:t>
+              <a:t>• Escala lineal col·lapsa a l'origen; log₁₀(ρ) separa les fases</a:t>
             </a:r>
           </a:p>
           <a:p>
@@ -4491,7 +4491,7 @@
               <a:rPr>
                 <a:latin typeface="Arial"/>
               </a:rPr>
-              <a:t>• Clustering no supervisado: descubrir las clases sin etiquetas</a:t>
+              <a:t>• Clustering no supervisat: descobrir les classes sense etiquetes</a:t>
             </a:r>
           </a:p>
         </p:txBody>
@@ -4572,7 +4572,7 @@
               <a:rPr>
                 <a:latin typeface="Arial"/>
               </a:rPr>
-              <a:t>¿Por qué DBSCAN frente a K-Means?</a:t>
+              <a:t>Per què DBSCAN enfront de K-Means?</a:t>
             </a:r>
           </a:p>
         </p:txBody>
@@ -4611,7 +4611,7 @@
               <a:rPr>
                 <a:latin typeface="Arial"/>
               </a:rPr>
-              <a:t>• ✖ K-Means: asume esfericidad, fractura aislantes y no aísla ruido</a:t>
+              <a:t>• ✖ K-Means: assumeix esfericitat, fractura aïllants i no aïlla soroll</a:t>
             </a:r>
           </a:p>
           <a:p>
@@ -4627,7 +4627,7 @@
               <a:rPr>
                 <a:latin typeface="Arial"/>
               </a:rPr>
-              <a:t>• ✔ DBSCAN: conecta por densidad local y tolera densidades desiguales</a:t>
+              <a:t>• ✔ DBSCAN: connecta per densitat local i tolera densitats desiguals</a:t>
             </a:r>
           </a:p>
           <a:p>
@@ -4643,7 +4643,7 @@
               <a:rPr>
                 <a:latin typeface="Arial"/>
               </a:rPr>
-              <a:t>• Metales hiperdensos vs aislantes extendidos en 12 órdenes</a:t>
+              <a:t>• Metalls hiperdensos vs aïllants estesos en 12 ordres</a:t>
             </a:r>
           </a:p>
           <a:p>
@@ -4659,7 +4659,7 @@
               <a:rPr>
                 <a:latin typeface="Arial"/>
               </a:rPr>
-              <a:t>• DBSCAN detecta anomalías de forma nativa (etiqueta -1)</a:t>
+              <a:t>• DBSCAN detecta anomalies de manera nativa (etiqueta -1)</a:t>
             </a:r>
           </a:p>
         </p:txBody>
@@ -4740,7 +4740,7 @@
               <a:rPr>
                 <a:latin typeface="Arial"/>
               </a:rPr>
-              <a:t>Metodología: Fórmulas y parámetros</a:t>
+              <a:t>Metodologia: Fórmules i paràmetres</a:t>
             </a:r>
           </a:p>
         </p:txBody>
@@ -4779,7 +4779,7 @@
               <a:rPr>
                 <a:latin typeface="Arial"/>
               </a:rPr>
-              <a:t>• Estandarización manual Z-Score con NumPy: Z = (X - μ) / σ</a:t>
+              <a:t>• Estandardització manual Z-Score amb NumPy: Z = (X - μ) / σ</a:t>
             </a:r>
           </a:p>
           <a:p>
@@ -4795,7 +4795,7 @@
               <a:rPr>
                 <a:latin typeface="Arial"/>
               </a:rPr>
-              <a:t>• Vecindad: N_ε(p) = { q | d(p, q) ≤ ε }</a:t>
+              <a:t>• Veïnat: N_ε(p) = { q | d(p, q) ≤ ε }</a:t>
             </a:r>
           </a:p>
           <a:p>
@@ -4811,7 +4811,7 @@
               <a:rPr>
                 <a:latin typeface="Arial"/>
               </a:rPr>
-              <a:t>• Núcleo (Core Point): |N_ε(p)| ≥ min_samples</a:t>
+              <a:t>• Nucli (Core Point): |N_ε(p)| ≥ min_samples</a:t>
             </a:r>
           </a:p>
           <a:p>
@@ -4827,7 +4827,7 @@
               <a:rPr>
                 <a:latin typeface="Arial"/>
               </a:rPr>
-              <a:t>• Parámetros fijados: ε = 0,65 (codo k-NN) y min_samples = 3 (d = 2)</a:t>
+              <a:t>• Paràmetres fixats: ε = 0,65 (colze k-NN) i min_samples = 3 (d = 2)</a:t>
             </a:r>
           </a:p>
         </p:txBody>
@@ -4884,7 +4884,7 @@
               <a:rPr>
                 <a:latin typeface="Arial"/>
               </a:rPr>
-              <a:t>Resultado: DBSCAN en 57 materiales</a:t>
+              <a:t>Resultat: DBSCAN en 57 materials</a:t>
             </a:r>
           </a:p>
         </p:txBody>
@@ -4923,7 +4923,7 @@
               <a:rPr>
                 <a:latin typeface="Arial"/>
               </a:rPr>
-              <a:t>• 3 clusters puros descubiertos por densidad: 0 ruido</a:t>
+              <a:t>• 3 clústers purs descoberts per densitat: 0 soroll</a:t>
             </a:r>
           </a:p>
           <a:p>
@@ -4939,7 +4939,7 @@
               <a:rPr>
                 <a:latin typeface="Arial"/>
               </a:rPr>
-              <a:t>• Cluster 0 (ámbar): 35 metales conductores (Cu, Ag, Au...)</a:t>
+              <a:t>• Clúster 0 (ambre): 35 metalls conductors (Cu, Ag, Au...)</a:t>
             </a:r>
           </a:p>
           <a:p>
@@ -4955,7 +4955,7 @@
               <a:rPr>
                 <a:latin typeface="Arial"/>
               </a:rPr>
-              <a:t>• Cluster 1 (azul): 10 aislantes dieléctricos (vidrio, teflón...)</a:t>
+              <a:t>• Clúster 1 (blau): 10 aïllants dielèctrics (vidre, tefló...)</a:t>
             </a:r>
           </a:p>
           <a:p>
@@ -4971,7 +4971,7 @@
               <a:rPr>
                 <a:latin typeface="Arial"/>
               </a:rPr>
-              <a:t>• Cluster 2 (verde): 10 semiconductores (Si, Ge, GaAs...)</a:t>
+              <a:t>• Clúster 2 (verd): 10 semiconductors (Si, Ge, GaAs...)</a:t>
             </a:r>
           </a:p>
           <a:p>
@@ -4987,7 +4987,7 @@
               <a:rPr>
                 <a:latin typeface="Arial"/>
               </a:rPr>
-              <a:t>• Frontera α = 0: fonones vs activación térmica</a:t>
+              <a:t>• Frontera α = 0: fonons vs activació tèrmica</a:t>
             </a:r>
           </a:p>
         </p:txBody>
@@ -5068,7 +5068,7 @@
               <a:rPr>
                 <a:latin typeface="Arial"/>
               </a:rPr>
-              <a:t>Validación física: Matriz de contingencia</a:t>
+              <a:t>Validació física: Matriu de contingència</a:t>
             </a:r>
           </a:p>
         </p:txBody>
@@ -5107,7 +5107,7 @@
               <a:rPr>
                 <a:latin typeface="Arial"/>
               </a:rPr>
-              <a:t>• Conductores: 35 de 35 (100 % pureza en Cluster 0)</a:t>
+              <a:t>• Conductors: 35 de 35 (100 % puresa al Clúster 0)</a:t>
             </a:r>
           </a:p>
           <a:p>
@@ -5123,7 +5123,7 @@
               <a:rPr>
                 <a:latin typeface="Arial"/>
               </a:rPr>
-              <a:t>• Aislantes: 10 de 10 (100 % pureza en Cluster 1)</a:t>
+              <a:t>• Aïllants: 10 de 10 (100 % puresa al Clúster 1)</a:t>
             </a:r>
           </a:p>
           <a:p>
@@ -5139,7 +5139,7 @@
               <a:rPr>
                 <a:latin typeface="Arial"/>
               </a:rPr>
-              <a:t>• Semiconductores: 10 de 12 (83,3 % pureza en Cluster 2; 2 semimetales en cluster 0)</a:t>
+              <a:t>• Semiconductors: 10 de 12 (83,3 % puresa al Clúster 2; 2 semimetalls al clúster 0)</a:t>
             </a:r>
           </a:p>
           <a:p>
@@ -5155,7 +5155,7 @@
               <a:rPr>
                 <a:latin typeface="Arial"/>
               </a:rPr>
-              <a:t>• Silhouette Score complementario: 0,7858 (alta cohesión interna)</a:t>
+              <a:t>• Silhouette Score complementari: 0,7858 (alta cohesió interna)</a:t>
             </a:r>
           </a:p>
         </p:txBody>

</xml_diff>

<commit_message>
docs: afegir fotografies del pla pre-clustering i panell comparatiu a l'informe i a la presentacio
</commit_message>
<xml_diff>
--- a/presentacion/expo_cpia.pptx
+++ b/presentacion/expo_cpia.pptx
@@ -4498,7 +4498,7 @@
       </p:sp>
       <p:pic>
         <p:nvPicPr>
-          <p:cNvPr id="4" name="Picture 3" descr="distribucion_escala_rho.png"/>
+          <p:cNvPr id="4" name="Picture 3" descr="materiales_antes_clustering.png"/>
           <p:cNvPicPr>
             <a:picLocks noChangeAspect="1"/>
           </p:cNvPicPr>
@@ -4513,7 +4513,7 @@
         <p:spPr>
           <a:xfrm>
             <a:off x="5394960" y="1371600"/>
-            <a:ext cx="6583680" cy="2460567"/>
+            <a:ext cx="6583680" cy="4279392"/>
           </a:xfrm>
           <a:prstGeom prst="rect">
             <a:avLst/>
@@ -4994,7 +4994,7 @@
       </p:sp>
       <p:pic>
         <p:nvPicPr>
-          <p:cNvPr id="4" name="Picture 3" descr="clusters_materiales_dbscan.png"/>
+          <p:cNvPr id="4" name="Picture 3" descr="comparativa_abans_despres_dbscan.png"/>
           <p:cNvPicPr>
             <a:picLocks noChangeAspect="1"/>
           </p:cNvPicPr>
@@ -5009,7 +5009,7 @@
         <p:spPr>
           <a:xfrm>
             <a:off x="5394960" y="1371600"/>
-            <a:ext cx="6583680" cy="4279392"/>
+            <a:ext cx="6583680" cy="2551176"/>
           </a:xfrm>
           <a:prstGeom prst="rect">
             <a:avLst/>

</xml_diff>

<commit_message>
Cambio a vmin=2 (F1 0,902: 551 TP, 57 FP, 63 FN): codigo, figuras, informe y pptx; mas contenido de Matias (figura de anomalias, conclusiones)
Co-Authored-By: Claude Sonnet 5.5 <noreply@anthropic.com>
Claude-Session: https://claude.ai/code/session_01Q6fDk4UWe6v6CR3QJZP5xS
</commit_message>
<xml_diff>
--- a/presentacion/expo_cpia.pptx
+++ b/presentacion/expo_cpia.pptx
@@ -6279,7 +6279,7 @@
               <a:rPr>
                 <a:latin typeface="Arial"/>
               </a:rPr>
-              <a:t>• Parámetros fijos: eps = 25 km, vmin = 1, profundidad mediana en [0; 2,5) km (criterio físico)</a:t>
+              <a:t>• Parámetros fijos: eps = 25 km, vmin = 2, profundidad mediana en [0; 2,5) km (criterio físico)</a:t>
             </a:r>
           </a:p>
           <a:p>
@@ -6295,7 +6295,7 @@
               <a:rPr>
                 <a:latin typeface="Arial"/>
               </a:rPr>
-              <a:t>• eps = 25 km da el mínimo de falsos positivos (115) entre 5 y 100 km; es la única elección que mira la etiqueta</a:t>
+              <a:t>• eps = 25 km da el mínimo de falsos positivos (57) entre 5 y 100 km; es la única elección que mira la etiqueta</a:t>
             </a:r>
           </a:p>
           <a:p>
@@ -6327,7 +6327,7 @@
               <a:rPr>
                 <a:latin typeface="Arial"/>
               </a:rPr>
-              <a:t>• Con eps ≥ 50 km los grupos se funden con terremotos profundos: FP 483 (50 km) y FN 261 (75 km)</a:t>
+              <a:t>• Con eps ≥ 50 km los grupos se funden con terremotos profundos: FP 453 (50 km) y FN 288 (75 km)</a:t>
             </a:r>
           </a:p>
           <a:p>
@@ -6343,7 +6343,7 @@
               <a:rPr>
                 <a:latin typeface="Arial"/>
               </a:rPr>
-              <a:t>• Estabilidad (ARI, muestra del 50 %): 0,54-0,65</a:t>
+              <a:t>• Estabilidad (ARI, muestra del 50 %): 0,54-0,64</a:t>
             </a:r>
           </a:p>
           <a:p>
@@ -6479,7 +6479,7 @@
               <a:rPr>
                 <a:latin typeface="Arial"/>
               </a:rPr>
-              <a:t>• 586 aciertos, 115 FP, 28 FN</a:t>
+              <a:t>• 551 aciertos, 57 FP, 63 FN</a:t>
             </a:r>
           </a:p>
           <a:p>
@@ -6495,7 +6495,7 @@
               <a:rPr>
                 <a:latin typeface="Arial"/>
               </a:rPr>
-              <a:t>• Precisión 83,6 %  ·  recall 95,4 %  ·  F1 = 0,891</a:t>
+              <a:t>• Precisión 90,6 %  ·  recall 89,7 %  ·  F1 = 0,902</a:t>
             </a:r>
           </a:p>
           <a:p>
@@ -6631,7 +6631,7 @@
               <a:rPr>
                 <a:latin typeface="Arial"/>
               </a:rPr>
-              <a:t>• vmin = 1: no hay ruido; la selección real la hace la profundidad. Con vmin = 3, F1 baja a 0,899</a:t>
+              <a:t>• vmin = 2: los sismos aislados son ruido. Con vmin = 1 hay 28 FN pero 115 FP (F1 0,891): compromiso precisión-recall</a:t>
             </a:r>
           </a:p>
           <a:p>
@@ -6663,7 +6663,7 @@
               <a:rPr>
                 <a:latin typeface="Arial"/>
               </a:rPr>
-              <a:t>• El 85 % de las explosiones figura con profundidad 0,0 km en el USGS: una ventana [0; 0,1) daría F1 0,931, pero mediría esa convención</a:t>
+              <a:t>• El 85 % de las explosiones figura con profundidad 0,0 km en el USGS: una ventana [0; 0,1) daría F1 0,922, pero mediría esa convención</a:t>
             </a:r>
           </a:p>
           <a:p>
@@ -6679,7 +6679,7 @@
               <a:rPr>
                 <a:latin typeface="Arial"/>
               </a:rPr>
-              <a:t>• 115 FP: 24 son otros eventos no sísmicos (explosiones, minas); sin ellos serían 91 y F1 0,908</a:t>
+              <a:t>• 57 FP: 14 son otros eventos no sísmicos (explosiones, minas); sin ellos serían 43 y F1 0,912. 40 de los 63 FN son explosiones aisladas (ruido)</a:t>
             </a:r>
           </a:p>
           <a:p>

</xml_diff>

<commit_message>
docs(slides): unificar totes les versions de la presentacio (individual i conjunta)
</commit_message>
<xml_diff>
--- a/presentacion/expo_cpia.pptx
+++ b/presentacion/expo_cpia.pptx
@@ -24,6 +24,8 @@
     <p:sldId id="272" r:id="rId24"/>
     <p:sldId id="273" r:id="rId25"/>
     <p:sldId id="274" r:id="rId26"/>
+    <p:sldId id="275" r:id="rId27"/>
+    <p:sldId id="276" r:id="rId28"/>
   </p:sldIdLst>
   <p:sldSz cx="12191695" cy="6858000" type="screen4x3"/>
   <p:notesSz cx="6858000" cy="9144000"/>
@@ -590,7 +592,12 @@
           <a:lstStyle/>
           <a:p>
             <a:r>
-              <a:t>Estructura de bandes i variació tèrmica: el signe i la magnitud d'alfa delaten la física microscòpica.</a:t>
+              <a:t>GUIÓ SLIDE 1:</a:t>
+            </a:r>
+          </a:p>
+          <a:p>
+            <a:r>
+              <a:t>Bon dia tribunal i companys. Sóc l'Uriel i presento la classificació no supervisada de materials elèctrics mitjançant DBSCAN.</a:t>
             </a:r>
           </a:p>
         </p:txBody>
@@ -660,7 +667,32 @@
           <a:lstStyle/>
           <a:p>
             <a:r>
-              <a:t>Comparativa d'escala: la compressió logarítmica és imprescindible perquè metalls i aïllants coexisteixin.</a:t>
+              <a:t>GUIÓ SLIDE 2:</a:t>
+            </a:r>
+          </a:p>
+          <a:p>
+            <a:r>
+              <a:t>Definim el problema físic a partir de les equacions de transport:</a:t>
+            </a:r>
+          </a:p>
+          <a:p>
+            <a:r>
+              <a:t>- La variació tèrmica de la resistivitat rho(T) i la seva derivada tèrmica alfa.</a:t>
+            </a:r>
+          </a:p>
+          <a:p>
+            <a:r>
+              <a:t>- Metalls: bandes solapades, electrons lliures, alfa positiu per xocs amb fonons de la xarxa.</a:t>
+            </a:r>
+          </a:p>
+          <a:p>
+            <a:r>
+              <a:t>- Semiconductors: bandgap moderat, alfa negatiu per activació tèrmica exponencial segons Boltzmann.</a:t>
+            </a:r>
+          </a:p>
+          <a:p>
+            <a:r>
+              <a:t>- Aïllants: bandgap colossal (&gt; 5 eV), sense portadors lliures a 300 K, alfa nul i resistivitat gegantina.</a:t>
             </a:r>
           </a:p>
         </p:txBody>
@@ -730,7 +762,17 @@
           <a:lstStyle/>
           <a:p>
             <a:r>
-              <a:t>K-Means assumeix variàncies similars i falla; DBSCAN connecta per densitat i respecta la dispersió natural.</a:t>
+              <a:t>GUIÓ SLIDE 3:</a:t>
+            </a:r>
+          </a:p>
+          <a:p>
+            <a:r>
+              <a:t>Disposem de 57 materials reals al dataset.</a:t>
+            </a:r>
+          </a:p>
+          <a:p>
+            <a:r>
+              <a:t>A la dreta veiem l'espai bidimensional físic ABANS d'aplicar cap algorisme: els materials en brut sense etiquetes. El logaritme de resistivitat desplega els 30 ordres de magnitud i alfa separa els règims microscòpics.</a:t>
             </a:r>
           </a:p>
         </p:txBody>
@@ -800,7 +842,397 @@
           <a:lstStyle/>
           <a:p>
             <a:r>
-              <a:t>Resultat gràfic: el pla 2D mostra la separació nítida de les tres classes.</a:t>
+              <a:t>GUIÓ SLIDE 4:</a:t>
+            </a:r>
+          </a:p>
+          <a:p>
+            <a:r>
+              <a:t>DBSCAN vs. K-Means:</a:t>
+            </a:r>
+          </a:p>
+          <a:p>
+            <a:r>
+              <a:t>Al gràfic de la dreta es veu clar: K-Means imposa fronteres esfèriques forçades. En tenir metalls ultra concentrats i aïllants dispersos, K-Means falla. DBSCAN segueix els camins de densitat natural i aïlla punts atípics com a soroll.</a:t>
+            </a:r>
+          </a:p>
+        </p:txBody>
+      </p:sp>
+      <p:sp>
+        <p:nvSpPr>
+          <p:cNvPr id="4" name="Slide Number Placeholder 3"/>
+          <p:cNvSpPr>
+            <a:spLocks noGrp="1"/>
+          </p:cNvSpPr>
+          <p:nvPr>
+            <p:ph type="sldNum" idx="5" sz="quarter"/>
+          </p:nvPr>
+        </p:nvSpPr>
+        <p:spPr/>
+      </p:sp>
+    </p:spTree>
+  </p:cSld>
+  <p:clrMapOvr>
+    <a:masterClrMapping/>
+  </p:clrMapOvr>
+</p:notes>
+</file>
+
+<file path=ppt/notesSlides/notesSlide6.xml><?xml version="1.0" encoding="utf-8"?>
+<p:notes xmlns:a="http://schemas.openxmlformats.org/drawingml/2006/main" xmlns:p="http://schemas.openxmlformats.org/presentationml/2006/main" xmlns:r="http://schemas.openxmlformats.org/officeDocument/2006/relationships">
+  <p:cSld>
+    <p:spTree>
+      <p:nvGrpSpPr>
+        <p:cNvPr id="1" name=""/>
+        <p:cNvGrpSpPr/>
+        <p:nvPr/>
+      </p:nvGrpSpPr>
+      <p:grpSpPr>
+        <a:xfrm>
+          <a:off x="0" y="0"/>
+          <a:ext cx="0" cy="0"/>
+          <a:chOff x="0" y="0"/>
+          <a:chExt cx="0" cy="0"/>
+        </a:xfrm>
+      </p:grpSpPr>
+      <p:sp>
+        <p:nvSpPr>
+          <p:cNvPr id="2" name="Slide Image Placeholder 1"/>
+          <p:cNvSpPr>
+            <a:spLocks noGrp="1"/>
+          </p:cNvSpPr>
+          <p:nvPr>
+            <p:ph type="sldImg" idx="2"/>
+          </p:nvPr>
+        </p:nvSpPr>
+        <p:spPr/>
+      </p:sp>
+      <p:sp>
+        <p:nvSpPr>
+          <p:cNvPr id="3" name="Notes Placeholder 2"/>
+          <p:cNvSpPr>
+            <a:spLocks noGrp="1"/>
+          </p:cNvSpPr>
+          <p:nvPr>
+            <p:ph type="body" idx="3" sz="quarter"/>
+          </p:nvPr>
+        </p:nvSpPr>
+        <p:spPr/>
+        <p:txBody>
+          <a:bodyPr/>
+          <a:lstStyle/>
+          <a:p>
+            <a:r>
+              <a:t>GUIÓ SLIDE 5:</a:t>
+            </a:r>
+          </a:p>
+          <a:p>
+            <a:r>
+              <a:t>En metodologia: fórmules en LaTeX clares i netes.</a:t>
+            </a:r>
+          </a:p>
+          <a:p>
+            <a:r>
+              <a:t>1. Escalat Z-Score manual amb NumPy per igualar variàncies.</a:t>
+            </a:r>
+          </a:p>
+          <a:p>
+            <a:r>
+              <a:t>2. Criteri de nucli de DBSCAN: punts amb almenys min_samples veïns en radi èpsilon.</a:t>
+            </a:r>
+          </a:p>
+          <a:p>
+            <a:r>
+              <a:t>3. Hiperparàmetres fixats rigorosament: min_samples=3 (dimensió + 1) i èpsilon=0.65 obtingut pel colze k-NN.</a:t>
+            </a:r>
+          </a:p>
+        </p:txBody>
+      </p:sp>
+      <p:sp>
+        <p:nvSpPr>
+          <p:cNvPr id="4" name="Slide Number Placeholder 3"/>
+          <p:cNvSpPr>
+            <a:spLocks noGrp="1"/>
+          </p:cNvSpPr>
+          <p:nvPr>
+            <p:ph type="sldNum" idx="5" sz="quarter"/>
+          </p:nvPr>
+        </p:nvSpPr>
+        <p:spPr/>
+      </p:sp>
+    </p:spTree>
+  </p:cSld>
+  <p:clrMapOvr>
+    <a:masterClrMapping/>
+  </p:clrMapOvr>
+</p:notes>
+</file>
+
+<file path=ppt/notesSlides/notesSlide7.xml><?xml version="1.0" encoding="utf-8"?>
+<p:notes xmlns:a="http://schemas.openxmlformats.org/drawingml/2006/main" xmlns:p="http://schemas.openxmlformats.org/presentationml/2006/main" xmlns:r="http://schemas.openxmlformats.org/officeDocument/2006/relationships">
+  <p:cSld>
+    <p:spTree>
+      <p:nvGrpSpPr>
+        <p:cNvPr id="1" name=""/>
+        <p:cNvGrpSpPr/>
+        <p:nvPr/>
+      </p:nvGrpSpPr>
+      <p:grpSpPr>
+        <a:xfrm>
+          <a:off x="0" y="0"/>
+          <a:ext cx="0" cy="0"/>
+          <a:chOff x="0" y="0"/>
+          <a:chExt cx="0" cy="0"/>
+        </a:xfrm>
+      </p:grpSpPr>
+      <p:sp>
+        <p:nvSpPr>
+          <p:cNvPr id="2" name="Slide Image Placeholder 1"/>
+          <p:cNvSpPr>
+            <a:spLocks noGrp="1"/>
+          </p:cNvSpPr>
+          <p:nvPr>
+            <p:ph type="sldImg" idx="2"/>
+          </p:nvPr>
+        </p:nvSpPr>
+        <p:spPr/>
+      </p:sp>
+      <p:sp>
+        <p:nvSpPr>
+          <p:cNvPr id="3" name="Notes Placeholder 2"/>
+          <p:cNvSpPr>
+            <a:spLocks noGrp="1"/>
+          </p:cNvSpPr>
+          <p:nvPr>
+            <p:ph type="body" idx="3" sz="quarter"/>
+          </p:nvPr>
+        </p:nvSpPr>
+        <p:spPr/>
+        <p:txBody>
+          <a:bodyPr/>
+          <a:lstStyle/>
+          <a:p>
+            <a:r>
+              <a:t>GUIÓ SLIDE 6:</a:t>
+            </a:r>
+          </a:p>
+          <a:p>
+            <a:r>
+              <a:t>Aquest és el panell comparatiu d'abans i després en pantalla gran:</a:t>
+            </a:r>
+          </a:p>
+          <a:p>
+            <a:r>
+              <a:t>- A l'esquerra: les 57 dades experimentals en brut tal com entren a l'algorisme, sense etiquetes de classe.</a:t>
+            </a:r>
+          </a:p>
+          <a:p>
+            <a:r>
+              <a:t>- A la dreta: el descobriment autònom de les 3 classes físiques pures per connectivitat de densitat amb DBSCAN:</a:t>
+            </a:r>
+          </a:p>
+          <a:p>
+            <a:r>
+              <a:t>  • Clúster 0 (ambre): 35 metalls conductors amb alfa &gt; 0.</a:t>
+            </a:r>
+          </a:p>
+          <a:p>
+            <a:r>
+              <a:t>  • Clúster 1 (blau): 10 aïllants dielèctrics amb alfa proper a zero i resistivitat gegant.</a:t>
+            </a:r>
+          </a:p>
+          <a:p>
+            <a:r>
+              <a:t>  • Clúster 2 (verd): 10 semiconductors per sota de la frontera física alfa = 0.</a:t>
+            </a:r>
+          </a:p>
+          <a:p>
+            <a:r>
+              <a:t>- La línia d'alfa = 0 separa clarament la conducció per fonons de l'activació tèrmica.</a:t>
+            </a:r>
+          </a:p>
+        </p:txBody>
+      </p:sp>
+      <p:sp>
+        <p:nvSpPr>
+          <p:cNvPr id="4" name="Slide Number Placeholder 3"/>
+          <p:cNvSpPr>
+            <a:spLocks noGrp="1"/>
+          </p:cNvSpPr>
+          <p:nvPr>
+            <p:ph type="sldNum" idx="5" sz="quarter"/>
+          </p:nvPr>
+        </p:nvSpPr>
+        <p:spPr/>
+      </p:sp>
+    </p:spTree>
+  </p:cSld>
+  <p:clrMapOvr>
+    <a:masterClrMapping/>
+  </p:clrMapOvr>
+</p:notes>
+</file>
+
+<file path=ppt/notesSlides/notesSlide8.xml><?xml version="1.0" encoding="utf-8"?>
+<p:notes xmlns:a="http://schemas.openxmlformats.org/drawingml/2006/main" xmlns:p="http://schemas.openxmlformats.org/presentationml/2006/main" xmlns:r="http://schemas.openxmlformats.org/officeDocument/2006/relationships">
+  <p:cSld>
+    <p:spTree>
+      <p:nvGrpSpPr>
+        <p:cNvPr id="1" name=""/>
+        <p:cNvGrpSpPr/>
+        <p:nvPr/>
+      </p:nvGrpSpPr>
+      <p:grpSpPr>
+        <a:xfrm>
+          <a:off x="0" y="0"/>
+          <a:ext cx="0" cy="0"/>
+          <a:chOff x="0" y="0"/>
+          <a:chExt cx="0" cy="0"/>
+        </a:xfrm>
+      </p:grpSpPr>
+      <p:sp>
+        <p:nvSpPr>
+          <p:cNvPr id="2" name="Slide Image Placeholder 1"/>
+          <p:cNvSpPr>
+            <a:spLocks noGrp="1"/>
+          </p:cNvSpPr>
+          <p:nvPr>
+            <p:ph type="sldImg" idx="2"/>
+          </p:nvPr>
+        </p:nvSpPr>
+        <p:spPr/>
+      </p:sp>
+      <p:sp>
+        <p:nvSpPr>
+          <p:cNvPr id="3" name="Notes Placeholder 2"/>
+          <p:cNvSpPr>
+            <a:spLocks noGrp="1"/>
+          </p:cNvSpPr>
+          <p:nvPr>
+            <p:ph type="body" idx="3" sz="quarter"/>
+          </p:nvPr>
+        </p:nvSpPr>
+        <p:spPr/>
+        <p:txBody>
+          <a:bodyPr/>
+          <a:lstStyle/>
+          <a:p>
+            <a:r>
+              <a:t>GUIÓ SLIDE 7:</a:t>
+            </a:r>
+          </a:p>
+          <a:p>
+            <a:r>
+              <a:t>Pel que fa a validació, la prova reina és la Matriu de Contingència Física:</a:t>
+            </a:r>
+          </a:p>
+          <a:p>
+            <a:r>
+              <a:t>- 100% de puresa en conductors (35 de 35 metalls al clúster 0).</a:t>
+            </a:r>
+          </a:p>
+          <a:p>
+            <a:r>
+              <a:t>- 100% de puresa en aïllants (10 de 10 dielèctrics al clúster 1).</a:t>
+            </a:r>
+          </a:p>
+          <a:p>
+            <a:r>
+              <a:t>- En semiconductors, 10 de 12 materials purs formen el clúster 2. Els dos restants són semimetalls amb transport cuasimetàl·lic a 300 K.</a:t>
+            </a:r>
+          </a:p>
+        </p:txBody>
+      </p:sp>
+      <p:sp>
+        <p:nvSpPr>
+          <p:cNvPr id="4" name="Slide Number Placeholder 3"/>
+          <p:cNvSpPr>
+            <a:spLocks noGrp="1"/>
+          </p:cNvSpPr>
+          <p:nvPr>
+            <p:ph type="sldNum" idx="5" sz="quarter"/>
+          </p:nvPr>
+        </p:nvSpPr>
+        <p:spPr/>
+      </p:sp>
+    </p:spTree>
+  </p:cSld>
+  <p:clrMapOvr>
+    <a:masterClrMapping/>
+  </p:clrMapOvr>
+</p:notes>
+</file>
+
+<file path=ppt/notesSlides/notesSlide9.xml><?xml version="1.0" encoding="utf-8"?>
+<p:notes xmlns:a="http://schemas.openxmlformats.org/drawingml/2006/main" xmlns:p="http://schemas.openxmlformats.org/presentationml/2006/main" xmlns:r="http://schemas.openxmlformats.org/officeDocument/2006/relationships">
+  <p:cSld>
+    <p:spTree>
+      <p:nvGrpSpPr>
+        <p:cNvPr id="1" name=""/>
+        <p:cNvGrpSpPr/>
+        <p:nvPr/>
+      </p:nvGrpSpPr>
+      <p:grpSpPr>
+        <a:xfrm>
+          <a:off x="0" y="0"/>
+          <a:ext cx="0" cy="0"/>
+          <a:chOff x="0" y="0"/>
+          <a:chExt cx="0" cy="0"/>
+        </a:xfrm>
+      </p:grpSpPr>
+      <p:sp>
+        <p:nvSpPr>
+          <p:cNvPr id="2" name="Slide Image Placeholder 1"/>
+          <p:cNvSpPr>
+            <a:spLocks noGrp="1"/>
+          </p:cNvSpPr>
+          <p:nvPr>
+            <p:ph type="sldImg" idx="2"/>
+          </p:nvPr>
+        </p:nvSpPr>
+        <p:spPr/>
+      </p:sp>
+      <p:sp>
+        <p:nvSpPr>
+          <p:cNvPr id="3" name="Notes Placeholder 2"/>
+          <p:cNvSpPr>
+            <a:spLocks noGrp="1"/>
+          </p:cNvSpPr>
+          <p:nvPr>
+            <p:ph type="body" idx="3" sz="quarter"/>
+          </p:nvPr>
+        </p:nvSpPr>
+        <p:spPr/>
+        <p:txBody>
+          <a:bodyPr/>
+          <a:lstStyle/>
+          <a:p>
+            <a:r>
+              <a:t>GUIÓ SLIDE 8:</a:t>
+            </a:r>
+          </a:p>
+          <a:p>
+            <a:r>
+              <a:t>Per concloure:</a:t>
+            </a:r>
+          </a:p>
+          <a:p>
+            <a:r>
+              <a:t>1. DBSCAN demostra que la densitat espacial macroscòpica reflecteix fidelment la física quàntica de bandes.</a:t>
+            </a:r>
+          </a:p>
+          <a:p>
+            <a:r>
+              <a:t>2. Ha demostrat ser l'eina adequada davant K-Means en tolerar densitats desiguals.</a:t>
+            </a:r>
+          </a:p>
+          <a:p>
+            <a:r>
+              <a:t>3. Amb només dues variables físiques i una estandardització rigorosa, s'obté un 100% de puresa en conductors i aïllants.</a:t>
+            </a:r>
+          </a:p>
+          <a:p>
+            <a:r>
+              <a:t>Moltes gràcies.</a:t>
             </a:r>
           </a:p>
         </p:txBody>
@@ -4204,14 +4636,102 @@
       <p:grpSpPr/>
       <p:sp>
         <p:nvSpPr>
-          <p:cNvPr id="2" name="TextBox 1"/>
+          <p:cNvPr id="2" name="Rounded Rectangle 1"/>
+          <p:cNvSpPr/>
+          <p:nvPr/>
+        </p:nvSpPr>
+        <p:spPr>
+          <a:xfrm>
+            <a:off x="731520" y="731520"/>
+            <a:ext cx="10728655" cy="5394960"/>
+          </a:xfrm>
+          <a:prstGeom prst="roundRect">
+            <a:avLst/>
+          </a:prstGeom>
+          <a:solidFill>
+            <a:srgbClr val="FFFFFF"/>
+          </a:solidFill>
+          <a:ln w="19050">
+            <a:solidFill>
+              <a:srgbClr val="000000"/>
+            </a:solidFill>
+          </a:ln>
+        </p:spPr>
+        <p:style>
+          <a:lnRef idx="1">
+            <a:schemeClr val="accent1"/>
+          </a:lnRef>
+          <a:fillRef idx="3">
+            <a:schemeClr val="accent1"/>
+          </a:fillRef>
+          <a:effectRef idx="2">
+            <a:schemeClr val="accent1"/>
+          </a:effectRef>
+          <a:fontRef idx="minor">
+            <a:schemeClr val="lt1"/>
+          </a:fontRef>
+        </p:style>
+        <p:txBody>
+          <a:bodyPr rtlCol="0" anchor="ctr"/>
+          <a:lstStyle/>
+          <a:p>
+            <a:pPr algn="ctr">
+              <a:defRPr>
+                <a:latin typeface="Arial"/>
+              </a:defRPr>
+            </a:pPr>
+          </a:p>
+        </p:txBody>
+      </p:sp>
+      <p:sp>
+        <p:nvSpPr>
+          <p:cNvPr id="3" name="TextBox 2"/>
           <p:cNvSpPr txBox="1"/>
           <p:nvPr/>
         </p:nvSpPr>
         <p:spPr>
           <a:xfrm>
-            <a:off x="548640" y="320040"/>
-            <a:ext cx="10972800" cy="914400"/>
+            <a:off x="1188720" y="1188720"/>
+            <a:ext cx="9784080" cy="457200"/>
+          </a:xfrm>
+          <a:prstGeom prst="rect">
+            <a:avLst/>
+          </a:prstGeom>
+          <a:noFill/>
+        </p:spPr>
+        <p:txBody>
+          <a:bodyPr wrap="none">
+            <a:spAutoFit/>
+          </a:bodyPr>
+          <a:lstStyle/>
+          <a:p>
+            <a:pPr>
+              <a:defRPr sz="1300" b="1">
+                <a:solidFill>
+                  <a:srgbClr val="000000"/>
+                </a:solidFill>
+                <a:latin typeface="Arial"/>
+              </a:defRPr>
+            </a:pPr>
+            <a:r>
+              <a:rPr>
+                <a:latin typeface="Arial"/>
+              </a:rPr>
+              <a:t>CPIA · APRENENTATGE NO SUPERVISAT</a:t>
+            </a:r>
+          </a:p>
+        </p:txBody>
+      </p:sp>
+      <p:sp>
+        <p:nvSpPr>
+          <p:cNvPr id="4" name="TextBox 3"/>
+          <p:cNvSpPr txBox="1"/>
+          <p:nvPr/>
+        </p:nvSpPr>
+        <p:spPr>
+          <a:xfrm>
+            <a:off x="1188720" y="1737360"/>
+            <a:ext cx="9784080" cy="1645920"/>
           </a:xfrm>
           <a:prstGeom prst="rect">
             <a:avLst/>
@@ -4225,32 +4745,32 @@
           <a:lstStyle/>
           <a:p>
             <a:pPr>
-              <a:spcAft>
-                <a:spcPts val="800"/>
-              </a:spcAft>
-              <a:defRPr sz="3200" b="1">
-                <a:latin typeface="Arial"/>
-              </a:defRPr>
-            </a:pPr>
-            <a:r>
-              <a:rPr>
-                <a:latin typeface="Arial"/>
-              </a:rPr>
-              <a:t>Problema: 3 famílies i signatures tèrmiques</a:t>
-            </a:r>
-          </a:p>
-        </p:txBody>
-      </p:sp>
-      <p:sp>
-        <p:nvSpPr>
-          <p:cNvPr id="3" name="TextBox 2"/>
+              <a:defRPr sz="3600" b="1">
+                <a:solidFill>
+                  <a:srgbClr val="000000"/>
+                </a:solidFill>
+                <a:latin typeface="Arial"/>
+              </a:defRPr>
+            </a:pPr>
+            <a:r>
+              <a:rPr>
+                <a:latin typeface="Arial"/>
+              </a:rPr>
+              <a:t>Classificació de Materials Elèctrics mitjançant DBSCAN</a:t>
+            </a:r>
+          </a:p>
+        </p:txBody>
+      </p:sp>
+      <p:sp>
+        <p:nvSpPr>
+          <p:cNvPr id="5" name="TextBox 4"/>
           <p:cNvSpPr txBox="1"/>
           <p:nvPr/>
         </p:nvSpPr>
         <p:spPr>
           <a:xfrm>
-            <a:off x="548640" y="1371600"/>
-            <a:ext cx="4754880" cy="4572000"/>
+            <a:off x="1188720" y="3291840"/>
+            <a:ext cx="9784080" cy="914400"/>
           </a:xfrm>
           <a:prstGeom prst="rect">
             <a:avLst/>
@@ -4258,100 +4778,83 @@
           <a:noFill/>
         </p:spPr>
         <p:txBody>
-          <a:bodyPr wrap="square">
+          <a:bodyPr wrap="none">
             <a:spAutoFit/>
           </a:bodyPr>
           <a:lstStyle/>
           <a:p>
             <a:pPr>
-              <a:spcAft>
-                <a:spcPts val="800"/>
-              </a:spcAft>
-              <a:defRPr sz="2000" b="0">
-                <a:latin typeface="Arial"/>
-              </a:defRPr>
-            </a:pPr>
-            <a:r>
-              <a:rPr>
-                <a:latin typeface="Arial"/>
-              </a:rPr>
-              <a:t>• Conducció segons l'estructura quàntica de bandes</a:t>
-            </a:r>
-          </a:p>
-          <a:p>
-            <a:pPr>
-              <a:spcAft>
-                <a:spcPts val="800"/>
-              </a:spcAft>
-              <a:defRPr sz="2000" b="0">
-                <a:latin typeface="Arial"/>
-              </a:defRPr>
-            </a:pPr>
-            <a:r>
-              <a:rPr>
-                <a:latin typeface="Arial"/>
-              </a:rPr>
-              <a:t>• Variació tèrmica: ρ(T) = ρ₀ · [1 + α·(T - T₀)]</a:t>
-            </a:r>
-          </a:p>
-          <a:p>
-            <a:pPr>
-              <a:spcAft>
-                <a:spcPts val="800"/>
-              </a:spcAft>
-              <a:defRPr sz="2000" b="0">
-                <a:latin typeface="Arial"/>
-              </a:defRPr>
-            </a:pPr>
-            <a:r>
-              <a:rPr>
-                <a:latin typeface="Arial"/>
-              </a:rPr>
-              <a:t>• Coeficient tèrmic: α = (1 / ρ₀) · (dρ / dT)₃₀₀K</a:t>
-            </a:r>
-          </a:p>
-          <a:p>
-            <a:pPr>
-              <a:spcAft>
-                <a:spcPts val="800"/>
-              </a:spcAft>
-              <a:defRPr sz="2000" b="0">
-                <a:latin typeface="Arial"/>
-              </a:defRPr>
-            </a:pPr>
-            <a:r>
-              <a:rPr>
-                <a:latin typeface="Arial"/>
-              </a:rPr>
-              <a:t>• Metalls (α &gt; 0) · Semiconductors (α &lt; 0) · Aïllants (α ≈ 0)</a:t>
-            </a:r>
-          </a:p>
-        </p:txBody>
-      </p:sp>
-      <p:pic>
-        <p:nvPicPr>
-          <p:cNvPr id="4" name="Picture 3" descr="esquema_bandas_materiales.png"/>
-          <p:cNvPicPr>
-            <a:picLocks noChangeAspect="1"/>
-          </p:cNvPicPr>
+              <a:defRPr sz="1700">
+                <a:solidFill>
+                  <a:srgbClr val="000000"/>
+                </a:solidFill>
+                <a:latin typeface="Arial"/>
+              </a:defRPr>
+            </a:pPr>
+            <a:r>
+              <a:rPr>
+                <a:latin typeface="Arial"/>
+              </a:rPr>
+              <a:t>Classificació de materials Conductors, Semiconductors i Aïllants</a:t>
+            </a:r>
+          </a:p>
+        </p:txBody>
+      </p:sp>
+      <p:sp>
+        <p:nvSpPr>
+          <p:cNvPr id="6" name="TextBox 5"/>
+          <p:cNvSpPr txBox="1"/>
           <p:nvPr/>
-        </p:nvPicPr>
-        <p:blipFill>
-          <a:blip r:embed="rId2"/>
-          <a:stretch>
-            <a:fillRect/>
-          </a:stretch>
-        </p:blipFill>
-        <p:spPr>
-          <a:xfrm>
-            <a:off x="5394960" y="1371600"/>
-            <a:ext cx="6583680" cy="2332404"/>
+        </p:nvSpPr>
+        <p:spPr>
+          <a:xfrm>
+            <a:off x="1188720" y="4297680"/>
+            <a:ext cx="9784080" cy="1371600"/>
           </a:xfrm>
           <a:prstGeom prst="rect">
             <a:avLst/>
           </a:prstGeom>
-        </p:spPr>
-      </p:pic>
+          <a:noFill/>
+        </p:spPr>
+        <p:txBody>
+          <a:bodyPr wrap="none">
+            <a:spAutoFit/>
+          </a:bodyPr>
+          <a:lstStyle/>
+          <a:p>
+            <a:pPr>
+              <a:defRPr sz="1600" b="1">
+                <a:solidFill>
+                  <a:srgbClr val="000000"/>
+                </a:solidFill>
+                <a:latin typeface="Arial"/>
+              </a:defRPr>
+            </a:pPr>
+            <a:r>
+              <a:rPr>
+                <a:latin typeface="Arial"/>
+              </a:rPr>
+              <a:t>Uriel · Grau en Enginyeria Física (UPC)</a:t>
+            </a:r>
+          </a:p>
+          <a:p>
+            <a:pPr>
+              <a:defRPr sz="1400">
+                <a:solidFill>
+                  <a:srgbClr val="000000"/>
+                </a:solidFill>
+                <a:latin typeface="Arial"/>
+              </a:defRPr>
+            </a:pPr>
+            <a:r>
+              <a:rPr>
+                <a:latin typeface="Arial"/>
+              </a:rPr>
+              <a:t>Equip: Matías · Martí · Uriel · Arnau Montull</a:t>
+            </a:r>
+          </a:p>
+        </p:txBody>
+      </p:sp>
     </p:spTree>
   </p:cSld>
   <p:clrMapOvr>
@@ -4378,8 +4881,8 @@
         </p:nvSpPr>
         <p:spPr>
           <a:xfrm>
-            <a:off x="548640" y="320040"/>
-            <a:ext cx="10972800" cy="914400"/>
+            <a:off x="731520" y="365760"/>
+            <a:ext cx="10698480" cy="320040"/>
           </a:xfrm>
           <a:prstGeom prst="rect">
             <a:avLst/>
@@ -4387,24 +4890,24 @@
           <a:noFill/>
         </p:spPr>
         <p:txBody>
-          <a:bodyPr wrap="square">
+          <a:bodyPr wrap="none">
             <a:spAutoFit/>
           </a:bodyPr>
           <a:lstStyle/>
           <a:p>
             <a:pPr>
-              <a:spcAft>
-                <a:spcPts val="800"/>
-              </a:spcAft>
-              <a:defRPr sz="3200" b="1">
-                <a:latin typeface="Arial"/>
-              </a:defRPr>
-            </a:pPr>
-            <a:r>
-              <a:rPr>
-                <a:latin typeface="Arial"/>
-              </a:rPr>
-              <a:t>Dataset i espai (log₁₀ρ, α)</a:t>
+              <a:defRPr sz="1050" b="1">
+                <a:solidFill>
+                  <a:srgbClr val="000000"/>
+                </a:solidFill>
+                <a:latin typeface="Arial"/>
+              </a:defRPr>
+            </a:pPr>
+            <a:r>
+              <a:rPr>
+                <a:latin typeface="Arial"/>
+              </a:rPr>
+              <a:t>CPIA · APRENENTATGE NO SUPERVISAT</a:t>
             </a:r>
           </a:p>
         </p:txBody>
@@ -4417,8 +4920,8 @@
         </p:nvSpPr>
         <p:spPr>
           <a:xfrm>
-            <a:off x="548640" y="1371600"/>
-            <a:ext cx="4754880" cy="4572000"/>
+            <a:off x="731520" y="685800"/>
+            <a:ext cx="10698480" cy="640080"/>
           </a:xfrm>
           <a:prstGeom prst="rect">
             <a:avLst/>
@@ -4426,79 +4929,119 @@
           <a:noFill/>
         </p:spPr>
         <p:txBody>
-          <a:bodyPr wrap="square">
+          <a:bodyPr wrap="none">
             <a:spAutoFit/>
           </a:bodyPr>
           <a:lstStyle/>
           <a:p>
             <a:pPr>
-              <a:spcAft>
-                <a:spcPts val="800"/>
-              </a:spcAft>
-              <a:defRPr sz="2000" b="0">
-                <a:latin typeface="Arial"/>
-              </a:defRPr>
-            </a:pPr>
-            <a:r>
-              <a:rPr>
-                <a:latin typeface="Arial"/>
-              </a:rPr>
-              <a:t>• 57 materials reals recopilats experimentalment</a:t>
-            </a:r>
-          </a:p>
-          <a:p>
-            <a:pPr>
-              <a:spcAft>
-                <a:spcPts val="800"/>
-              </a:spcAft>
-              <a:defRPr sz="2000" b="0">
-                <a:latin typeface="Arial"/>
-              </a:defRPr>
-            </a:pPr>
-            <a:r>
-              <a:rPr>
-                <a:latin typeface="Arial"/>
-              </a:rPr>
-              <a:t>• 30 ordres de magnitud en resistivitat (10⁻⁸ a 10²² Ω·m)</a:t>
-            </a:r>
-          </a:p>
-          <a:p>
-            <a:pPr>
-              <a:spcAft>
-                <a:spcPts val="800"/>
-              </a:spcAft>
-              <a:defRPr sz="2000" b="0">
-                <a:latin typeface="Arial"/>
-              </a:defRPr>
-            </a:pPr>
-            <a:r>
-              <a:rPr>
-                <a:latin typeface="Arial"/>
-              </a:rPr>
-              <a:t>• Escala lineal col·lapsa a l'origen; log₁₀(ρ) separa les fases</a:t>
-            </a:r>
-          </a:p>
-          <a:p>
-            <a:pPr>
-              <a:spcAft>
-                <a:spcPts val="800"/>
-              </a:spcAft>
-              <a:defRPr sz="2000" b="0">
-                <a:latin typeface="Arial"/>
-              </a:defRPr>
-            </a:pPr>
-            <a:r>
-              <a:rPr>
-                <a:latin typeface="Arial"/>
-              </a:rPr>
-              <a:t>• Clustering no supervisat: descobrir les classes sense etiquetes</a:t>
+              <a:defRPr sz="2300" b="1">
+                <a:solidFill>
+                  <a:srgbClr val="000000"/>
+                </a:solidFill>
+                <a:latin typeface="Arial"/>
+              </a:defRPr>
+            </a:pPr>
+            <a:r>
+              <a:rPr>
+                <a:latin typeface="Arial"/>
+              </a:rPr>
+              <a:t>El Problema Físic: Estructura de Bandes i Signatures Tèrmiques</a:t>
+            </a:r>
+          </a:p>
+        </p:txBody>
+      </p:sp>
+      <p:sp>
+        <p:nvSpPr>
+          <p:cNvPr id="4" name="Rounded Rectangle 3"/>
+          <p:cNvSpPr/>
+          <p:nvPr/>
+        </p:nvSpPr>
+        <p:spPr>
+          <a:xfrm>
+            <a:off x="731520" y="1325880"/>
+            <a:ext cx="10728655" cy="1143000"/>
+          </a:xfrm>
+          <a:prstGeom prst="roundRect">
+            <a:avLst/>
+          </a:prstGeom>
+          <a:solidFill>
+            <a:srgbClr val="FFFFFF"/>
+          </a:solidFill>
+          <a:ln w="19050">
+            <a:solidFill>
+              <a:srgbClr val="000000"/>
+            </a:solidFill>
+          </a:ln>
+        </p:spPr>
+        <p:style>
+          <a:lnRef idx="1">
+            <a:schemeClr val="accent1"/>
+          </a:lnRef>
+          <a:fillRef idx="3">
+            <a:schemeClr val="accent1"/>
+          </a:fillRef>
+          <a:effectRef idx="2">
+            <a:schemeClr val="accent1"/>
+          </a:effectRef>
+          <a:fontRef idx="minor">
+            <a:schemeClr val="lt1"/>
+          </a:fontRef>
+        </p:style>
+        <p:txBody>
+          <a:bodyPr rtlCol="0" anchor="ctr"/>
+          <a:lstStyle/>
+          <a:p>
+            <a:pPr algn="ctr">
+              <a:defRPr>
+                <a:latin typeface="Arial"/>
+              </a:defRPr>
+            </a:pPr>
+          </a:p>
+        </p:txBody>
+      </p:sp>
+      <p:sp>
+        <p:nvSpPr>
+          <p:cNvPr id="5" name="TextBox 4"/>
+          <p:cNvSpPr txBox="1"/>
+          <p:nvPr/>
+        </p:nvSpPr>
+        <p:spPr>
+          <a:xfrm>
+            <a:off x="914400" y="1371600"/>
+            <a:ext cx="10332720" cy="274320"/>
+          </a:xfrm>
+          <a:prstGeom prst="rect">
+            <a:avLst/>
+          </a:prstGeom>
+          <a:noFill/>
+        </p:spPr>
+        <p:txBody>
+          <a:bodyPr wrap="none">
+            <a:spAutoFit/>
+          </a:bodyPr>
+          <a:lstStyle/>
+          <a:p>
+            <a:pPr>
+              <a:defRPr sz="1150" b="1">
+                <a:solidFill>
+                  <a:srgbClr val="000000"/>
+                </a:solidFill>
+                <a:latin typeface="Arial"/>
+              </a:defRPr>
+            </a:pPr>
+            <a:r>
+              <a:rPr>
+                <a:latin typeface="Arial"/>
+              </a:rPr>
+              <a:t>Equacions Macroscòpiques de Transport Elèctric:</a:t>
             </a:r>
           </a:p>
         </p:txBody>
       </p:sp>
       <p:pic>
         <p:nvPicPr>
-          <p:cNvPr id="4" name="Picture 3" descr="materiales_antes_clustering.png"/>
+          <p:cNvPr id="6" name="Picture 5" descr="formula_transporte.png"/>
           <p:cNvPicPr>
             <a:picLocks noChangeAspect="1"/>
           </p:cNvPicPr>
@@ -4512,8 +5055,32 @@
         </p:blipFill>
         <p:spPr>
           <a:xfrm>
-            <a:off x="5394960" y="1371600"/>
-            <a:ext cx="6583680" cy="4279392"/>
+            <a:off x="2194560" y="1664208"/>
+            <a:ext cx="7772400" cy="1248039"/>
+          </a:xfrm>
+          <a:prstGeom prst="rect">
+            <a:avLst/>
+          </a:prstGeom>
+        </p:spPr>
+      </p:pic>
+      <p:pic>
+        <p:nvPicPr>
+          <p:cNvPr id="7" name="Picture 6" descr="esquema_bandas_materiales.png"/>
+          <p:cNvPicPr>
+            <a:picLocks noChangeAspect="1"/>
+          </p:cNvPicPr>
+          <p:nvPr/>
+        </p:nvPicPr>
+        <p:blipFill>
+          <a:blip r:embed="rId3"/>
+          <a:stretch>
+            <a:fillRect/>
+          </a:stretch>
+        </p:blipFill>
+        <p:spPr>
+          <a:xfrm>
+            <a:off x="731520" y="2606040"/>
+            <a:ext cx="10728655" cy="3800847"/>
           </a:xfrm>
           <a:prstGeom prst="rect">
             <a:avLst/>
@@ -4546,8 +5113,135 @@
         </p:nvSpPr>
         <p:spPr>
           <a:xfrm>
-            <a:off x="548640" y="320040"/>
-            <a:ext cx="10972800" cy="914400"/>
+            <a:off x="731520" y="365760"/>
+            <a:ext cx="10698480" cy="320040"/>
+          </a:xfrm>
+          <a:prstGeom prst="rect">
+            <a:avLst/>
+          </a:prstGeom>
+          <a:noFill/>
+        </p:spPr>
+        <p:txBody>
+          <a:bodyPr wrap="none">
+            <a:spAutoFit/>
+          </a:bodyPr>
+          <a:lstStyle/>
+          <a:p>
+            <a:pPr>
+              <a:defRPr sz="1050" b="1">
+                <a:solidFill>
+                  <a:srgbClr val="000000"/>
+                </a:solidFill>
+                <a:latin typeface="Arial"/>
+              </a:defRPr>
+            </a:pPr>
+            <a:r>
+              <a:rPr>
+                <a:latin typeface="Arial"/>
+              </a:rPr>
+              <a:t>CPIA · APRENENTATGE NO SUPERVISAT</a:t>
+            </a:r>
+          </a:p>
+        </p:txBody>
+      </p:sp>
+      <p:sp>
+        <p:nvSpPr>
+          <p:cNvPr id="3" name="TextBox 2"/>
+          <p:cNvSpPr txBox="1"/>
+          <p:nvPr/>
+        </p:nvSpPr>
+        <p:spPr>
+          <a:xfrm>
+            <a:off x="731520" y="685800"/>
+            <a:ext cx="10698480" cy="640080"/>
+          </a:xfrm>
+          <a:prstGeom prst="rect">
+            <a:avLst/>
+          </a:prstGeom>
+          <a:noFill/>
+        </p:spPr>
+        <p:txBody>
+          <a:bodyPr wrap="none">
+            <a:spAutoFit/>
+          </a:bodyPr>
+          <a:lstStyle/>
+          <a:p>
+            <a:pPr>
+              <a:defRPr sz="2300" b="1">
+                <a:solidFill>
+                  <a:srgbClr val="000000"/>
+                </a:solidFill>
+                <a:latin typeface="Arial"/>
+              </a:defRPr>
+            </a:pPr>
+            <a:r>
+              <a:rPr>
+                <a:latin typeface="Arial"/>
+              </a:rPr>
+              <a:t>Dataset Experimental i Espai de Treball (log₁₀ρ, α)</a:t>
+            </a:r>
+          </a:p>
+        </p:txBody>
+      </p:sp>
+      <p:sp>
+        <p:nvSpPr>
+          <p:cNvPr id="4" name="Rounded Rectangle 3"/>
+          <p:cNvSpPr/>
+          <p:nvPr/>
+        </p:nvSpPr>
+        <p:spPr>
+          <a:xfrm>
+            <a:off x="731520" y="1463040"/>
+            <a:ext cx="4206240" cy="4846320"/>
+          </a:xfrm>
+          <a:prstGeom prst="roundRect">
+            <a:avLst/>
+          </a:prstGeom>
+          <a:solidFill>
+            <a:srgbClr val="FFFFFF"/>
+          </a:solidFill>
+          <a:ln w="19050">
+            <a:solidFill>
+              <a:srgbClr val="000000"/>
+            </a:solidFill>
+          </a:ln>
+        </p:spPr>
+        <p:style>
+          <a:lnRef idx="1">
+            <a:schemeClr val="accent1"/>
+          </a:lnRef>
+          <a:fillRef idx="3">
+            <a:schemeClr val="accent1"/>
+          </a:fillRef>
+          <a:effectRef idx="2">
+            <a:schemeClr val="accent1"/>
+          </a:effectRef>
+          <a:fontRef idx="minor">
+            <a:schemeClr val="lt1"/>
+          </a:fontRef>
+        </p:style>
+        <p:txBody>
+          <a:bodyPr rtlCol="0" anchor="ctr"/>
+          <a:lstStyle/>
+          <a:p>
+            <a:pPr algn="ctr">
+              <a:defRPr>
+                <a:latin typeface="Arial"/>
+              </a:defRPr>
+            </a:pPr>
+          </a:p>
+        </p:txBody>
+      </p:sp>
+      <p:sp>
+        <p:nvSpPr>
+          <p:cNvPr id="5" name="TextBox 4"/>
+          <p:cNvSpPr txBox="1"/>
+          <p:nvPr/>
+        </p:nvSpPr>
+        <p:spPr>
+          <a:xfrm>
+            <a:off x="914400" y="1600200"/>
+            <a:ext cx="3840480" cy="4572000"/>
           </a:xfrm>
           <a:prstGeom prst="rect">
             <a:avLst/>
@@ -4561,112 +5255,25 @@
           <a:lstStyle/>
           <a:p>
             <a:pPr>
-              <a:spcAft>
-                <a:spcPts val="800"/>
-              </a:spcAft>
-              <a:defRPr sz="3200" b="1">
-                <a:latin typeface="Arial"/>
-              </a:defRPr>
-            </a:pPr>
-            <a:r>
-              <a:rPr>
-                <a:latin typeface="Arial"/>
-              </a:rPr>
-              <a:t>DBSCAN vs. K-Means?</a:t>
-            </a:r>
-          </a:p>
-        </p:txBody>
-      </p:sp>
-      <p:sp>
-        <p:nvSpPr>
-          <p:cNvPr id="3" name="TextBox 2"/>
-          <p:cNvSpPr txBox="1"/>
-          <p:nvPr/>
-        </p:nvSpPr>
-        <p:spPr>
-          <a:xfrm>
-            <a:off x="548640" y="1371600"/>
-            <a:ext cx="4754880" cy="4572000"/>
-          </a:xfrm>
-          <a:prstGeom prst="rect">
-            <a:avLst/>
-          </a:prstGeom>
-          <a:noFill/>
-        </p:spPr>
-        <p:txBody>
-          <a:bodyPr wrap="square">
-            <a:spAutoFit/>
-          </a:bodyPr>
-          <a:lstStyle/>
-          <a:p>
-            <a:pPr>
-              <a:spcAft>
-                <a:spcPts val="800"/>
-              </a:spcAft>
-              <a:defRPr sz="2000" b="0">
-                <a:latin typeface="Arial"/>
-              </a:defRPr>
-            </a:pPr>
-            <a:r>
-              <a:rPr>
-                <a:latin typeface="Arial"/>
-              </a:rPr>
-              <a:t>• ✖ K-Means: assumeix esfericitat, fractura aïllants i no aïlla soroll</a:t>
-            </a:r>
-          </a:p>
-          <a:p>
-            <a:pPr>
-              <a:spcAft>
-                <a:spcPts val="800"/>
-              </a:spcAft>
-              <a:defRPr sz="2000" b="0">
-                <a:latin typeface="Arial"/>
-              </a:defRPr>
-            </a:pPr>
-            <a:r>
-              <a:rPr>
-                <a:latin typeface="Arial"/>
-              </a:rPr>
-              <a:t>• ✔ DBSCAN: connecta per densitat local i tolera densitats desiguals</a:t>
-            </a:r>
-          </a:p>
-          <a:p>
-            <a:pPr>
-              <a:spcAft>
-                <a:spcPts val="800"/>
-              </a:spcAft>
-              <a:defRPr sz="2000" b="0">
-                <a:latin typeface="Arial"/>
-              </a:defRPr>
-            </a:pPr>
-            <a:r>
-              <a:rPr>
-                <a:latin typeface="Arial"/>
-              </a:rPr>
-              <a:t>• Metalls hiperdensos vs aïllants estesos en 12 ordres</a:t>
-            </a:r>
-          </a:p>
-          <a:p>
-            <a:pPr>
-              <a:spcAft>
-                <a:spcPts val="800"/>
-              </a:spcAft>
-              <a:defRPr sz="2000" b="0">
-                <a:latin typeface="Arial"/>
-              </a:defRPr>
-            </a:pPr>
-            <a:r>
-              <a:rPr>
-                <a:latin typeface="Arial"/>
-              </a:rPr>
-              <a:t>• DBSCAN detecta anomalies de manera nativa (etiqueta -1)</a:t>
+              <a:defRPr sz="1700" b="1">
+                <a:solidFill>
+                  <a:srgbClr val="000000"/>
+                </a:solidFill>
+                <a:latin typeface="Arial"/>
+              </a:defRPr>
+            </a:pPr>
+            <a:r>
+              <a:rPr>
+                <a:latin typeface="Arial"/>
+              </a:rPr>
+              <a:t>Com classificar sense etiquetes?</a:t>
             </a:r>
           </a:p>
         </p:txBody>
       </p:sp>
       <p:pic>
         <p:nvPicPr>
-          <p:cNvPr id="4" name="Picture 3" descr="comparativa_kmeans_dbscan.png"/>
+          <p:cNvPr id="6" name="Picture 5" descr="formula_coordenadas.png"/>
           <p:cNvPicPr>
             <a:picLocks noChangeAspect="1"/>
           </p:cNvPicPr>
@@ -4680,8 +5287,150 @@
         </p:blipFill>
         <p:spPr>
           <a:xfrm>
-            <a:off x="5394960" y="1371600"/>
-            <a:ext cx="6583680" cy="2726575"/>
+            <a:off x="914400" y="2103120"/>
+            <a:ext cx="3749039" cy="670931"/>
+          </a:xfrm>
+          <a:prstGeom prst="rect">
+            <a:avLst/>
+          </a:prstGeom>
+        </p:spPr>
+      </p:pic>
+      <p:sp>
+        <p:nvSpPr>
+          <p:cNvPr id="7" name="TextBox 6"/>
+          <p:cNvSpPr txBox="1"/>
+          <p:nvPr/>
+        </p:nvSpPr>
+        <p:spPr>
+          <a:xfrm>
+            <a:off x="914400" y="2834640"/>
+            <a:ext cx="3840480" cy="3383280"/>
+          </a:xfrm>
+          <a:prstGeom prst="rect">
+            <a:avLst/>
+          </a:prstGeom>
+          <a:noFill/>
+        </p:spPr>
+        <p:txBody>
+          <a:bodyPr wrap="square">
+            <a:spAutoFit/>
+          </a:bodyPr>
+          <a:lstStyle/>
+          <a:p>
+            <a:pPr>
+              <a:spcAft>
+                <a:spcPts val="700"/>
+              </a:spcAft>
+              <a:defRPr sz="1150">
+                <a:solidFill>
+                  <a:srgbClr val="000000"/>
+                </a:solidFill>
+                <a:latin typeface="Arial"/>
+              </a:defRPr>
+            </a:pPr>
+            <a:r>
+              <a:rPr>
+                <a:latin typeface="Arial"/>
+              </a:rPr>
+              <a:t>• 57 Materials reals: Metalls purs, aliatges, semiconductors i dielèctrics.</a:t>
+            </a:r>
+          </a:p>
+          <a:p>
+            <a:pPr>
+              <a:spcAft>
+                <a:spcPts val="700"/>
+              </a:spcAft>
+              <a:defRPr sz="1150">
+                <a:solidFill>
+                  <a:srgbClr val="000000"/>
+                </a:solidFill>
+                <a:latin typeface="Arial"/>
+              </a:defRPr>
+            </a:pPr>
+            <a:r>
+              <a:rPr>
+                <a:latin typeface="Arial"/>
+              </a:rPr>
+              <a:t>• 30 ordres de magnitud: De conductors (~10⁻⁸ Ω·m) a tefló (&gt; 10²² Ω·m).</a:t>
+            </a:r>
+          </a:p>
+          <a:p>
+            <a:pPr>
+              <a:spcAft>
+                <a:spcPts val="700"/>
+              </a:spcAft>
+              <a:defRPr sz="1150">
+                <a:solidFill>
+                  <a:srgbClr val="000000"/>
+                </a:solidFill>
+                <a:latin typeface="Arial"/>
+              </a:defRPr>
+            </a:pPr>
+            <a:r>
+              <a:rPr>
+                <a:latin typeface="Arial"/>
+              </a:rPr>
+              <a:t>• Compressió logarítmica: Evita el col·lapse numèric a l'origen.</a:t>
+            </a:r>
+          </a:p>
+          <a:p>
+            <a:pPr>
+              <a:spcAft>
+                <a:spcPts val="700"/>
+              </a:spcAft>
+              <a:defRPr sz="1150">
+                <a:solidFill>
+                  <a:srgbClr val="000000"/>
+                </a:solidFill>
+                <a:latin typeface="Arial"/>
+              </a:defRPr>
+            </a:pPr>
+            <a:r>
+              <a:rPr>
+                <a:latin typeface="Arial"/>
+              </a:rPr>
+              <a:t>• Signatura quàntica: α indica l'origen microscòpic del transport.</a:t>
+            </a:r>
+          </a:p>
+          <a:p>
+            <a:pPr>
+              <a:spcAft>
+                <a:spcPts val="700"/>
+              </a:spcAft>
+              <a:defRPr sz="1150">
+                <a:solidFill>
+                  <a:srgbClr val="000000"/>
+                </a:solidFill>
+                <a:latin typeface="Arial"/>
+              </a:defRPr>
+            </a:pPr>
+            <a:r>
+              <a:rPr>
+                <a:latin typeface="Arial"/>
+              </a:rPr>
+              <a:t>• Dades sense etiquetar: L'algorisme ha de descobrir l'estructura sol.</a:t>
+            </a:r>
+          </a:p>
+        </p:txBody>
+      </p:sp>
+      <p:pic>
+        <p:nvPicPr>
+          <p:cNvPr id="8" name="Picture 7" descr="materiales_antes_clustering.png"/>
+          <p:cNvPicPr>
+            <a:picLocks noChangeAspect="1"/>
+          </p:cNvPicPr>
+          <p:nvPr/>
+        </p:nvPicPr>
+        <p:blipFill>
+          <a:blip r:embed="rId3"/>
+          <a:stretch>
+            <a:fillRect/>
+          </a:stretch>
+        </p:blipFill>
+        <p:spPr>
+          <a:xfrm>
+            <a:off x="5120640" y="1463040"/>
+            <a:ext cx="6309360" cy="4101084"/>
           </a:xfrm>
           <a:prstGeom prst="rect">
             <a:avLst/>
@@ -4714,8 +5463,135 @@
         </p:nvSpPr>
         <p:spPr>
           <a:xfrm>
-            <a:off x="548640" y="320040"/>
-            <a:ext cx="10972800" cy="914400"/>
+            <a:off x="731520" y="365760"/>
+            <a:ext cx="10698480" cy="320040"/>
+          </a:xfrm>
+          <a:prstGeom prst="rect">
+            <a:avLst/>
+          </a:prstGeom>
+          <a:noFill/>
+        </p:spPr>
+        <p:txBody>
+          <a:bodyPr wrap="none">
+            <a:spAutoFit/>
+          </a:bodyPr>
+          <a:lstStyle/>
+          <a:p>
+            <a:pPr>
+              <a:defRPr sz="1050" b="1">
+                <a:solidFill>
+                  <a:srgbClr val="000000"/>
+                </a:solidFill>
+                <a:latin typeface="Arial"/>
+              </a:defRPr>
+            </a:pPr>
+            <a:r>
+              <a:rPr>
+                <a:latin typeface="Arial"/>
+              </a:rPr>
+              <a:t>CPIA · APRENENTATGE NO SUPERVISAT</a:t>
+            </a:r>
+          </a:p>
+        </p:txBody>
+      </p:sp>
+      <p:sp>
+        <p:nvSpPr>
+          <p:cNvPr id="3" name="TextBox 2"/>
+          <p:cNvSpPr txBox="1"/>
+          <p:nvPr/>
+        </p:nvSpPr>
+        <p:spPr>
+          <a:xfrm>
+            <a:off x="731520" y="685800"/>
+            <a:ext cx="10698480" cy="640080"/>
+          </a:xfrm>
+          <a:prstGeom prst="rect">
+            <a:avLst/>
+          </a:prstGeom>
+          <a:noFill/>
+        </p:spPr>
+        <p:txBody>
+          <a:bodyPr wrap="none">
+            <a:spAutoFit/>
+          </a:bodyPr>
+          <a:lstStyle/>
+          <a:p>
+            <a:pPr>
+              <a:defRPr sz="2300" b="1">
+                <a:solidFill>
+                  <a:srgbClr val="000000"/>
+                </a:solidFill>
+                <a:latin typeface="Arial"/>
+              </a:defRPr>
+            </a:pPr>
+            <a:r>
+              <a:rPr>
+                <a:latin typeface="Arial"/>
+              </a:rPr>
+              <a:t>DBSCAN vs. K-Means?</a:t>
+            </a:r>
+          </a:p>
+        </p:txBody>
+      </p:sp>
+      <p:sp>
+        <p:nvSpPr>
+          <p:cNvPr id="4" name="Rounded Rectangle 3"/>
+          <p:cNvSpPr/>
+          <p:nvPr/>
+        </p:nvSpPr>
+        <p:spPr>
+          <a:xfrm>
+            <a:off x="731520" y="1463040"/>
+            <a:ext cx="4389120" cy="4846320"/>
+          </a:xfrm>
+          <a:prstGeom prst="roundRect">
+            <a:avLst/>
+          </a:prstGeom>
+          <a:solidFill>
+            <a:srgbClr val="FFFFFF"/>
+          </a:solidFill>
+          <a:ln w="19050">
+            <a:solidFill>
+              <a:srgbClr val="000000"/>
+            </a:solidFill>
+          </a:ln>
+        </p:spPr>
+        <p:style>
+          <a:lnRef idx="1">
+            <a:schemeClr val="accent1"/>
+          </a:lnRef>
+          <a:fillRef idx="3">
+            <a:schemeClr val="accent1"/>
+          </a:fillRef>
+          <a:effectRef idx="2">
+            <a:schemeClr val="accent1"/>
+          </a:effectRef>
+          <a:fontRef idx="minor">
+            <a:schemeClr val="lt1"/>
+          </a:fontRef>
+        </p:style>
+        <p:txBody>
+          <a:bodyPr rtlCol="0" anchor="ctr"/>
+          <a:lstStyle/>
+          <a:p>
+            <a:pPr algn="ctr">
+              <a:defRPr>
+                <a:latin typeface="Arial"/>
+              </a:defRPr>
+            </a:pPr>
+          </a:p>
+        </p:txBody>
+      </p:sp>
+      <p:sp>
+        <p:nvSpPr>
+          <p:cNvPr id="5" name="TextBox 4"/>
+          <p:cNvSpPr txBox="1"/>
+          <p:nvPr/>
+        </p:nvSpPr>
+        <p:spPr>
+          <a:xfrm>
+            <a:off x="914400" y="1600200"/>
+            <a:ext cx="4023360" cy="4572000"/>
           </a:xfrm>
           <a:prstGeom prst="rect">
             <a:avLst/>
@@ -4729,109 +5605,215 @@
           <a:lstStyle/>
           <a:p>
             <a:pPr>
+              <a:defRPr sz="1500" b="1">
+                <a:solidFill>
+                  <a:srgbClr val="000000"/>
+                </a:solidFill>
+                <a:latin typeface="Arial"/>
+              </a:defRPr>
+            </a:pPr>
+            <a:r>
+              <a:rPr>
+                <a:latin typeface="Arial"/>
+              </a:rPr>
+              <a:t>K-Means (Inadequat en aquest domini)</a:t>
+            </a:r>
+          </a:p>
+          <a:p>
+            <a:pPr>
               <a:spcAft>
-                <a:spcPts val="800"/>
+                <a:spcPts val="400"/>
               </a:spcAft>
-              <a:defRPr sz="3200" b="1">
-                <a:latin typeface="Arial"/>
-              </a:defRPr>
-            </a:pPr>
-            <a:r>
-              <a:rPr>
-                <a:latin typeface="Arial"/>
-              </a:rPr>
-              <a:t>Metodologia: Fórmules i paràmetres</a:t>
-            </a:r>
-          </a:p>
-        </p:txBody>
-      </p:sp>
-      <p:sp>
-        <p:nvSpPr>
-          <p:cNvPr id="3" name="TextBox 2"/>
-          <p:cNvSpPr txBox="1"/>
+              <a:defRPr sz="1100">
+                <a:solidFill>
+                  <a:srgbClr val="000000"/>
+                </a:solidFill>
+                <a:latin typeface="Arial"/>
+              </a:defRPr>
+            </a:pPr>
+            <a:r>
+              <a:rPr>
+                <a:latin typeface="Arial"/>
+              </a:rPr>
+              <a:t>✖  Assumeix grups esfèrics i isodensos (igual variància).</a:t>
+            </a:r>
+          </a:p>
+          <a:p>
+            <a:pPr>
+              <a:spcAft>
+                <a:spcPts val="400"/>
+              </a:spcAft>
+              <a:defRPr sz="1100">
+                <a:solidFill>
+                  <a:srgbClr val="000000"/>
+                </a:solidFill>
+                <a:latin typeface="Arial"/>
+              </a:defRPr>
+            </a:pPr>
+            <a:r>
+              <a:rPr>
+                <a:latin typeface="Arial"/>
+              </a:rPr>
+              <a:t>✖  Fractura el grup dispers d'aïllants.</a:t>
+            </a:r>
+          </a:p>
+          <a:p>
+            <a:pPr>
+              <a:spcAft>
+                <a:spcPts val="400"/>
+              </a:spcAft>
+              <a:defRPr sz="1100">
+                <a:solidFill>
+                  <a:srgbClr val="000000"/>
+                </a:solidFill>
+                <a:latin typeface="Arial"/>
+              </a:defRPr>
+            </a:pPr>
+            <a:r>
+              <a:rPr>
+                <a:latin typeface="Arial"/>
+              </a:rPr>
+              <a:t>✖  Exigeix prefixar 'k' a priori de forma arbitrària.</a:t>
+            </a:r>
+          </a:p>
+          <a:p>
+            <a:pPr>
+              <a:spcAft>
+                <a:spcPts val="400"/>
+              </a:spcAft>
+              <a:defRPr sz="1100">
+                <a:solidFill>
+                  <a:srgbClr val="000000"/>
+                </a:solidFill>
+                <a:latin typeface="Arial"/>
+              </a:defRPr>
+            </a:pPr>
+            <a:r>
+              <a:rPr>
+                <a:latin typeface="Arial"/>
+              </a:rPr>
+              <a:t>✖  No detecta soroll: força anomalies a tenir clúster.</a:t>
+            </a:r>
+          </a:p>
+          <a:p>
+            <a:br/>
+            <a:pPr>
+              <a:defRPr sz="1500" b="1">
+                <a:solidFill>
+                  <a:srgbClr val="000000"/>
+                </a:solidFill>
+                <a:latin typeface="Arial"/>
+              </a:defRPr>
+            </a:pPr>
+            <a:r>
+              <a:rPr>
+                <a:latin typeface="Arial"/>
+              </a:rPr>
+              <a:t>DBSCAN (Elecció Òptima)</a:t>
+            </a:r>
+          </a:p>
+          <a:p>
+            <a:pPr>
+              <a:spcAft>
+                <a:spcPts val="400"/>
+              </a:spcAft>
+              <a:defRPr sz="1100">
+                <a:solidFill>
+                  <a:srgbClr val="000000"/>
+                </a:solidFill>
+                <a:latin typeface="Arial"/>
+              </a:defRPr>
+            </a:pPr>
+            <a:r>
+              <a:rPr>
+                <a:latin typeface="Arial"/>
+              </a:rPr>
+              <a:t>✔  Connecta per densitat local de qualsevol forma.</a:t>
+            </a:r>
+          </a:p>
+          <a:p>
+            <a:pPr>
+              <a:spcAft>
+                <a:spcPts val="400"/>
+              </a:spcAft>
+              <a:defRPr sz="1100">
+                <a:solidFill>
+                  <a:srgbClr val="000000"/>
+                </a:solidFill>
+                <a:latin typeface="Arial"/>
+              </a:defRPr>
+            </a:pPr>
+            <a:r>
+              <a:rPr>
+                <a:latin typeface="Arial"/>
+              </a:rPr>
+              <a:t>✔  Tolera metalls hiperdensos i aïllants laxos.</a:t>
+            </a:r>
+          </a:p>
+          <a:p>
+            <a:pPr>
+              <a:spcAft>
+                <a:spcPts val="400"/>
+              </a:spcAft>
+              <a:defRPr sz="1100">
+                <a:solidFill>
+                  <a:srgbClr val="000000"/>
+                </a:solidFill>
+                <a:latin typeface="Arial"/>
+              </a:defRPr>
+            </a:pPr>
+            <a:r>
+              <a:rPr>
+                <a:latin typeface="Arial"/>
+              </a:rPr>
+              <a:t>✔  Descobreix el nombre de clústers sense prefixar k.</a:t>
+            </a:r>
+          </a:p>
+          <a:p>
+            <a:pPr>
+              <a:spcAft>
+                <a:spcPts val="400"/>
+              </a:spcAft>
+              <a:defRPr sz="1100">
+                <a:solidFill>
+                  <a:srgbClr val="000000"/>
+                </a:solidFill>
+                <a:latin typeface="Arial"/>
+              </a:defRPr>
+            </a:pPr>
+            <a:r>
+              <a:rPr>
+                <a:latin typeface="Arial"/>
+              </a:rPr>
+              <a:t>✔  Etiqueta soroll i anomalies de forma nativa (-1).</a:t>
+            </a:r>
+          </a:p>
+        </p:txBody>
+      </p:sp>
+      <p:pic>
+        <p:nvPicPr>
+          <p:cNvPr id="6" name="Picture 5" descr="comparativa_kmeans_dbscan.png"/>
+          <p:cNvPicPr>
+            <a:picLocks noChangeAspect="1"/>
+          </p:cNvPicPr>
           <p:nvPr/>
-        </p:nvSpPr>
-        <p:spPr>
-          <a:xfrm>
-            <a:off x="548640" y="1371600"/>
-            <a:ext cx="10972800" cy="4572000"/>
+        </p:nvPicPr>
+        <p:blipFill>
+          <a:blip r:embed="rId2"/>
+          <a:stretch>
+            <a:fillRect/>
+          </a:stretch>
+        </p:blipFill>
+        <p:spPr>
+          <a:xfrm>
+            <a:off x="5303520" y="1645920"/>
+            <a:ext cx="6126480" cy="2537229"/>
           </a:xfrm>
           <a:prstGeom prst="rect">
             <a:avLst/>
           </a:prstGeom>
-          <a:noFill/>
-        </p:spPr>
-        <p:txBody>
-          <a:bodyPr wrap="square">
-            <a:spAutoFit/>
-          </a:bodyPr>
-          <a:lstStyle/>
-          <a:p>
-            <a:pPr>
-              <a:spcAft>
-                <a:spcPts val="800"/>
-              </a:spcAft>
-              <a:defRPr sz="2000" b="0">
-                <a:latin typeface="Arial"/>
-              </a:defRPr>
-            </a:pPr>
-            <a:r>
-              <a:rPr>
-                <a:latin typeface="Arial"/>
-              </a:rPr>
-              <a:t>• Estandardització manual Z-Score amb NumPy: Z = (X - μ) / σ</a:t>
-            </a:r>
-          </a:p>
-          <a:p>
-            <a:pPr>
-              <a:spcAft>
-                <a:spcPts val="800"/>
-              </a:spcAft>
-              <a:defRPr sz="2000" b="0">
-                <a:latin typeface="Arial"/>
-              </a:defRPr>
-            </a:pPr>
-            <a:r>
-              <a:rPr>
-                <a:latin typeface="Arial"/>
-              </a:rPr>
-              <a:t>• Veïnat: N_ε(p) = { q | d(p, q) ≤ ε }</a:t>
-            </a:r>
-          </a:p>
-          <a:p>
-            <a:pPr>
-              <a:spcAft>
-                <a:spcPts val="800"/>
-              </a:spcAft>
-              <a:defRPr sz="2000" b="0">
-                <a:latin typeface="Arial"/>
-              </a:defRPr>
-            </a:pPr>
-            <a:r>
-              <a:rPr>
-                <a:latin typeface="Arial"/>
-              </a:rPr>
-              <a:t>• Nucli (Core Point): |N_ε(p)| ≥ min_samples</a:t>
-            </a:r>
-          </a:p>
-          <a:p>
-            <a:pPr>
-              <a:spcAft>
-                <a:spcPts val="800"/>
-              </a:spcAft>
-              <a:defRPr sz="2000" b="0">
-                <a:latin typeface="Arial"/>
-              </a:defRPr>
-            </a:pPr>
-            <a:r>
-              <a:rPr>
-                <a:latin typeface="Arial"/>
-              </a:rPr>
-              <a:t>• Paràmetres fixats: ε = 0,65 (colze k-NN) i min_samples = 3 (d = 2)</a:t>
-            </a:r>
-          </a:p>
-        </p:txBody>
-      </p:sp>
+        </p:spPr>
+      </p:pic>
     </p:spTree>
   </p:cSld>
   <p:clrMapOvr>
@@ -4858,8 +5840,8 @@
         </p:nvSpPr>
         <p:spPr>
           <a:xfrm>
-            <a:off x="548640" y="320040"/>
-            <a:ext cx="10972800" cy="914400"/>
+            <a:off x="731520" y="365760"/>
+            <a:ext cx="10698480" cy="320040"/>
           </a:xfrm>
           <a:prstGeom prst="rect">
             <a:avLst/>
@@ -4867,24 +5849,24 @@
           <a:noFill/>
         </p:spPr>
         <p:txBody>
-          <a:bodyPr wrap="square">
+          <a:bodyPr wrap="none">
             <a:spAutoFit/>
           </a:bodyPr>
           <a:lstStyle/>
           <a:p>
             <a:pPr>
-              <a:spcAft>
-                <a:spcPts val="800"/>
-              </a:spcAft>
-              <a:defRPr sz="3200" b="1">
-                <a:latin typeface="Arial"/>
-              </a:defRPr>
-            </a:pPr>
-            <a:r>
-              <a:rPr>
-                <a:latin typeface="Arial"/>
-              </a:rPr>
-              <a:t>Resultat: DBSCAN en 57 materials</a:t>
+              <a:defRPr sz="1050" b="1">
+                <a:solidFill>
+                  <a:srgbClr val="000000"/>
+                </a:solidFill>
+                <a:latin typeface="Arial"/>
+              </a:defRPr>
+            </a:pPr>
+            <a:r>
+              <a:rPr>
+                <a:latin typeface="Arial"/>
+              </a:rPr>
+              <a:t>CPIA · APRENENTATGE NO SUPERVISAT</a:t>
             </a:r>
           </a:p>
         </p:txBody>
@@ -4897,8 +5879,8 @@
         </p:nvSpPr>
         <p:spPr>
           <a:xfrm>
-            <a:off x="548640" y="1371600"/>
-            <a:ext cx="4754880" cy="4572000"/>
+            <a:off x="731520" y="685800"/>
+            <a:ext cx="10698480" cy="640080"/>
           </a:xfrm>
           <a:prstGeom prst="rect">
             <a:avLst/>
@@ -4906,95 +5888,126 @@
           <a:noFill/>
         </p:spPr>
         <p:txBody>
-          <a:bodyPr wrap="square">
+          <a:bodyPr wrap="none">
             <a:spAutoFit/>
           </a:bodyPr>
           <a:lstStyle/>
           <a:p>
             <a:pPr>
-              <a:spcAft>
-                <a:spcPts val="800"/>
-              </a:spcAft>
-              <a:defRPr sz="2000" b="0">
-                <a:latin typeface="Arial"/>
-              </a:defRPr>
-            </a:pPr>
-            <a:r>
-              <a:rPr>
-                <a:latin typeface="Arial"/>
-              </a:rPr>
-              <a:t>• 3 clústers purs descoberts per densitat: 0 soroll</a:t>
-            </a:r>
-          </a:p>
-          <a:p>
-            <a:pPr>
-              <a:spcAft>
-                <a:spcPts val="800"/>
-              </a:spcAft>
-              <a:defRPr sz="2000" b="0">
-                <a:latin typeface="Arial"/>
-              </a:defRPr>
-            </a:pPr>
-            <a:r>
-              <a:rPr>
-                <a:latin typeface="Arial"/>
-              </a:rPr>
-              <a:t>• Clúster 0 (ambre): 35 metalls conductors (Cu, Ag, Au...)</a:t>
-            </a:r>
-          </a:p>
-          <a:p>
-            <a:pPr>
-              <a:spcAft>
-                <a:spcPts val="800"/>
-              </a:spcAft>
-              <a:defRPr sz="2000" b="0">
-                <a:latin typeface="Arial"/>
-              </a:defRPr>
-            </a:pPr>
-            <a:r>
-              <a:rPr>
-                <a:latin typeface="Arial"/>
-              </a:rPr>
-              <a:t>• Clúster 1 (blau): 10 aïllants dielèctrics (vidre, tefló...)</a:t>
-            </a:r>
-          </a:p>
-          <a:p>
-            <a:pPr>
-              <a:spcAft>
-                <a:spcPts val="800"/>
-              </a:spcAft>
-              <a:defRPr sz="2000" b="0">
-                <a:latin typeface="Arial"/>
-              </a:defRPr>
-            </a:pPr>
-            <a:r>
-              <a:rPr>
-                <a:latin typeface="Arial"/>
-              </a:rPr>
-              <a:t>• Clúster 2 (verd): 10 semiconductors (Si, Ge, GaAs...)</a:t>
-            </a:r>
-          </a:p>
-          <a:p>
-            <a:pPr>
-              <a:spcAft>
-                <a:spcPts val="800"/>
-              </a:spcAft>
-              <a:defRPr sz="2000" b="0">
-                <a:latin typeface="Arial"/>
-              </a:defRPr>
-            </a:pPr>
-            <a:r>
-              <a:rPr>
-                <a:latin typeface="Arial"/>
-              </a:rPr>
-              <a:t>• Frontera α = 0: fonons vs activació tèrmica</a:t>
+              <a:defRPr sz="2300" b="1">
+                <a:solidFill>
+                  <a:srgbClr val="000000"/>
+                </a:solidFill>
+                <a:latin typeface="Arial"/>
+              </a:defRPr>
+            </a:pPr>
+            <a:r>
+              <a:rPr>
+                <a:latin typeface="Arial"/>
+              </a:rPr>
+              <a:t>Metodologia Matemàtica: Fórmules i Paràmetres</a:t>
+            </a:r>
+          </a:p>
+        </p:txBody>
+      </p:sp>
+      <p:sp>
+        <p:nvSpPr>
+          <p:cNvPr id="4" name="Rounded Rectangle 3"/>
+          <p:cNvSpPr/>
+          <p:nvPr/>
+        </p:nvSpPr>
+        <p:spPr>
+          <a:xfrm>
+            <a:off x="731520" y="1463040"/>
+            <a:ext cx="3337560" cy="4754880"/>
+          </a:xfrm>
+          <a:prstGeom prst="roundRect">
+            <a:avLst/>
+          </a:prstGeom>
+          <a:solidFill>
+            <a:srgbClr val="FFFFFF"/>
+          </a:solidFill>
+          <a:ln w="19050">
+            <a:solidFill>
+              <a:srgbClr val="000000"/>
+            </a:solidFill>
+          </a:ln>
+        </p:spPr>
+        <p:style>
+          <a:lnRef idx="1">
+            <a:schemeClr val="accent1"/>
+          </a:lnRef>
+          <a:fillRef idx="3">
+            <a:schemeClr val="accent1"/>
+          </a:fillRef>
+          <a:effectRef idx="2">
+            <a:schemeClr val="accent1"/>
+          </a:effectRef>
+          <a:fontRef idx="minor">
+            <a:schemeClr val="lt1"/>
+          </a:fontRef>
+        </p:style>
+        <p:txBody>
+          <a:bodyPr rtlCol="0" anchor="ctr"/>
+          <a:lstStyle/>
+          <a:p>
+            <a:pPr algn="ctr">
+              <a:defRPr>
+                <a:latin typeface="Arial"/>
+              </a:defRPr>
+            </a:pPr>
+          </a:p>
+        </p:txBody>
+      </p:sp>
+      <p:sp>
+        <p:nvSpPr>
+          <p:cNvPr id="5" name="TextBox 4"/>
+          <p:cNvSpPr txBox="1"/>
+          <p:nvPr/>
+        </p:nvSpPr>
+        <p:spPr>
+          <a:xfrm>
+            <a:off x="914400" y="1600200"/>
+            <a:ext cx="2971800" cy="914400"/>
+          </a:xfrm>
+          <a:prstGeom prst="rect">
+            <a:avLst/>
+          </a:prstGeom>
+          <a:noFill/>
+        </p:spPr>
+        <p:txBody>
+          <a:bodyPr wrap="none">
+            <a:spAutoFit/>
+          </a:bodyPr>
+          <a:lstStyle/>
+          <a:p>
+            <a:pPr>
+              <a:defRPr sz="1500" b="1">
+                <a:solidFill>
+                  <a:srgbClr val="000000"/>
+                </a:solidFill>
+                <a:latin typeface="Arial"/>
+              </a:defRPr>
+            </a:pPr>
+            <a:r>
+              <a:rPr>
+                <a:latin typeface="Arial"/>
+              </a:rPr>
+              <a:t>1. Estandardització Z-Score</a:t>
+            </a:r>
+            <a:br/>
+            <a:r>
+              <a:rPr>
+                <a:latin typeface="Arial"/>
+              </a:rPr>
+              <a:t>(Implementada amb NumPy)</a:t>
             </a:r>
           </a:p>
         </p:txBody>
       </p:sp>
       <p:pic>
         <p:nvPicPr>
-          <p:cNvPr id="4" name="Picture 3" descr="comparativa_abans_despres_dbscan.png"/>
+          <p:cNvPr id="6" name="Picture 5" descr="formula_zscore.png"/>
           <p:cNvPicPr>
             <a:picLocks noChangeAspect="1"/>
           </p:cNvPicPr>
@@ -5008,14 +6021,644 @@
         </p:blipFill>
         <p:spPr>
           <a:xfrm>
-            <a:off x="5394960" y="1371600"/>
-            <a:ext cx="6583680" cy="2551176"/>
+            <a:off x="868680" y="2331720"/>
+            <a:ext cx="3063240" cy="555864"/>
           </a:xfrm>
           <a:prstGeom prst="rect">
             <a:avLst/>
           </a:prstGeom>
         </p:spPr>
       </p:pic>
+      <p:sp>
+        <p:nvSpPr>
+          <p:cNvPr id="7" name="TextBox 6"/>
+          <p:cNvSpPr txBox="1"/>
+          <p:nvPr/>
+        </p:nvSpPr>
+        <p:spPr>
+          <a:xfrm>
+            <a:off x="914400" y="3703320"/>
+            <a:ext cx="2971800" cy="2468880"/>
+          </a:xfrm>
+          <a:prstGeom prst="rect">
+            <a:avLst/>
+          </a:prstGeom>
+          <a:noFill/>
+        </p:spPr>
+        <p:txBody>
+          <a:bodyPr wrap="square">
+            <a:spAutoFit/>
+          </a:bodyPr>
+          <a:lstStyle/>
+          <a:p>
+            <a:pPr>
+              <a:spcAft>
+                <a:spcPts val="500"/>
+              </a:spcAft>
+              <a:defRPr sz="1100">
+                <a:solidFill>
+                  <a:srgbClr val="000000"/>
+                </a:solidFill>
+                <a:latin typeface="Arial"/>
+              </a:defRPr>
+            </a:pPr>
+            <a:r>
+              <a:rPr>
+                <a:latin typeface="Arial"/>
+              </a:rPr>
+              <a:t>• μ = Mitjana mostral per columna</a:t>
+            </a:r>
+          </a:p>
+          <a:p>
+            <a:pPr>
+              <a:spcAft>
+                <a:spcPts val="500"/>
+              </a:spcAft>
+              <a:defRPr sz="1100">
+                <a:solidFill>
+                  <a:srgbClr val="000000"/>
+                </a:solidFill>
+                <a:latin typeface="Arial"/>
+              </a:defRPr>
+            </a:pPr>
+            <a:r>
+              <a:rPr>
+                <a:latin typeface="Arial"/>
+              </a:rPr>
+              <a:t>• σ = Desviació estàndard típica</a:t>
+            </a:r>
+          </a:p>
+          <a:p>
+            <a:pPr>
+              <a:spcAft>
+                <a:spcPts val="500"/>
+              </a:spcAft>
+              <a:defRPr sz="1100">
+                <a:solidFill>
+                  <a:srgbClr val="000000"/>
+                </a:solidFill>
+                <a:latin typeface="Arial"/>
+              </a:defRPr>
+            </a:pPr>
+            <a:r>
+              <a:rPr>
+                <a:latin typeface="Arial"/>
+              </a:rPr>
+              <a:t>• Resultat: Mitjana = 0, Variància = 1</a:t>
+            </a:r>
+          </a:p>
+          <a:p>
+            <a:pPr>
+              <a:spcAft>
+                <a:spcPts val="500"/>
+              </a:spcAft>
+              <a:defRPr sz="1100">
+                <a:solidFill>
+                  <a:srgbClr val="000000"/>
+                </a:solidFill>
+                <a:latin typeface="Arial"/>
+              </a:defRPr>
+            </a:pPr>
+            <a:r>
+              <a:rPr>
+                <a:latin typeface="Arial"/>
+              </a:rPr>
+              <a:t>• Imprescindible: equipara el rang de log₁₀ρ (~31) amb el d'α (~0.08) per a la distància euclidiana.</a:t>
+            </a:r>
+          </a:p>
+        </p:txBody>
+      </p:sp>
+      <p:sp>
+        <p:nvSpPr>
+          <p:cNvPr id="8" name="Rounded Rectangle 7"/>
+          <p:cNvSpPr/>
+          <p:nvPr/>
+        </p:nvSpPr>
+        <p:spPr>
+          <a:xfrm>
+            <a:off x="4434840" y="1463040"/>
+            <a:ext cx="3337560" cy="4754880"/>
+          </a:xfrm>
+          <a:prstGeom prst="roundRect">
+            <a:avLst/>
+          </a:prstGeom>
+          <a:solidFill>
+            <a:srgbClr val="FFFFFF"/>
+          </a:solidFill>
+          <a:ln w="19050">
+            <a:solidFill>
+              <a:srgbClr val="000000"/>
+            </a:solidFill>
+          </a:ln>
+        </p:spPr>
+        <p:style>
+          <a:lnRef idx="1">
+            <a:schemeClr val="accent1"/>
+          </a:lnRef>
+          <a:fillRef idx="3">
+            <a:schemeClr val="accent1"/>
+          </a:fillRef>
+          <a:effectRef idx="2">
+            <a:schemeClr val="accent1"/>
+          </a:effectRef>
+          <a:fontRef idx="minor">
+            <a:schemeClr val="lt1"/>
+          </a:fontRef>
+        </p:style>
+        <p:txBody>
+          <a:bodyPr rtlCol="0" anchor="ctr"/>
+          <a:lstStyle/>
+          <a:p>
+            <a:pPr algn="ctr">
+              <a:defRPr>
+                <a:latin typeface="Arial"/>
+              </a:defRPr>
+            </a:pPr>
+          </a:p>
+        </p:txBody>
+      </p:sp>
+      <p:sp>
+        <p:nvSpPr>
+          <p:cNvPr id="9" name="TextBox 8"/>
+          <p:cNvSpPr txBox="1"/>
+          <p:nvPr/>
+        </p:nvSpPr>
+        <p:spPr>
+          <a:xfrm>
+            <a:off x="4617720" y="1600200"/>
+            <a:ext cx="2971800" cy="914400"/>
+          </a:xfrm>
+          <a:prstGeom prst="rect">
+            <a:avLst/>
+          </a:prstGeom>
+          <a:noFill/>
+        </p:spPr>
+        <p:txBody>
+          <a:bodyPr wrap="none">
+            <a:spAutoFit/>
+          </a:bodyPr>
+          <a:lstStyle/>
+          <a:p>
+            <a:pPr>
+              <a:defRPr sz="1500" b="1">
+                <a:solidFill>
+                  <a:srgbClr val="000000"/>
+                </a:solidFill>
+                <a:latin typeface="Arial"/>
+              </a:defRPr>
+            </a:pPr>
+            <a:r>
+              <a:rPr>
+                <a:latin typeface="Arial"/>
+              </a:rPr>
+              <a:t>2. Criteri de Nucli</a:t>
+            </a:r>
+            <a:br/>
+            <a:r>
+              <a:rPr>
+                <a:latin typeface="Arial"/>
+              </a:rPr>
+              <a:t>(DBSCAN Espacial)</a:t>
+            </a:r>
+          </a:p>
+        </p:txBody>
+      </p:sp>
+      <p:pic>
+        <p:nvPicPr>
+          <p:cNvPr id="10" name="Picture 9" descr="formula_nucleo.png"/>
+          <p:cNvPicPr>
+            <a:picLocks noChangeAspect="1"/>
+          </p:cNvPicPr>
+          <p:nvPr/>
+        </p:nvPicPr>
+        <p:blipFill>
+          <a:blip r:embed="rId3"/>
+          <a:stretch>
+            <a:fillRect/>
+          </a:stretch>
+        </p:blipFill>
+        <p:spPr>
+          <a:xfrm>
+            <a:off x="4572000" y="2331720"/>
+            <a:ext cx="3063240" cy="555864"/>
+          </a:xfrm>
+          <a:prstGeom prst="rect">
+            <a:avLst/>
+          </a:prstGeom>
+        </p:spPr>
+      </p:pic>
+      <p:sp>
+        <p:nvSpPr>
+          <p:cNvPr id="11" name="TextBox 10"/>
+          <p:cNvSpPr txBox="1"/>
+          <p:nvPr/>
+        </p:nvSpPr>
+        <p:spPr>
+          <a:xfrm>
+            <a:off x="4617720" y="3703320"/>
+            <a:ext cx="2971800" cy="2468880"/>
+          </a:xfrm>
+          <a:prstGeom prst="rect">
+            <a:avLst/>
+          </a:prstGeom>
+          <a:noFill/>
+        </p:spPr>
+        <p:txBody>
+          <a:bodyPr wrap="square">
+            <a:spAutoFit/>
+          </a:bodyPr>
+          <a:lstStyle/>
+          <a:p>
+            <a:pPr>
+              <a:spcAft>
+                <a:spcPts val="400"/>
+              </a:spcAft>
+              <a:defRPr sz="1100">
+                <a:solidFill>
+                  <a:srgbClr val="000000"/>
+                </a:solidFill>
+                <a:latin typeface="Arial"/>
+              </a:defRPr>
+            </a:pPr>
+            <a:r>
+              <a:rPr>
+                <a:latin typeface="Arial"/>
+              </a:rPr>
+              <a:t>• d(p, q) = Distància Euclidiana en 2D</a:t>
+            </a:r>
+          </a:p>
+          <a:p>
+            <a:pPr>
+              <a:spcAft>
+                <a:spcPts val="400"/>
+              </a:spcAft>
+              <a:defRPr sz="1100">
+                <a:solidFill>
+                  <a:srgbClr val="000000"/>
+                </a:solidFill>
+                <a:latin typeface="Arial"/>
+              </a:defRPr>
+            </a:pPr>
+            <a:r>
+              <a:rPr>
+                <a:latin typeface="Arial"/>
+              </a:rPr>
+              <a:t>• Punt Nucli (Core Point):</a:t>
+            </a:r>
+          </a:p>
+          <a:p>
+            <a:pPr>
+              <a:spcAft>
+                <a:spcPts val="400"/>
+              </a:spcAft>
+              <a:defRPr sz="1100">
+                <a:solidFill>
+                  <a:srgbClr val="000000"/>
+                </a:solidFill>
+                <a:latin typeface="Arial"/>
+              </a:defRPr>
+            </a:pPr>
+            <a:r>
+              <a:rPr>
+                <a:latin typeface="Arial"/>
+              </a:rPr>
+              <a:t>•    |N_ε(p)| ≥ min_samples</a:t>
+            </a:r>
+          </a:p>
+          <a:p>
+            <a:pPr>
+              <a:spcAft>
+                <a:spcPts val="400"/>
+              </a:spcAft>
+              <a:defRPr sz="1100">
+                <a:solidFill>
+                  <a:srgbClr val="000000"/>
+                </a:solidFill>
+                <a:latin typeface="Arial"/>
+              </a:defRPr>
+            </a:pPr>
+            <a:r>
+              <a:rPr>
+                <a:latin typeface="Arial"/>
+              </a:rPr>
+              <a:t>• Punt Frontera (Border):</a:t>
+            </a:r>
+          </a:p>
+          <a:p>
+            <a:pPr>
+              <a:spcAft>
+                <a:spcPts val="400"/>
+              </a:spcAft>
+              <a:defRPr sz="1100">
+                <a:solidFill>
+                  <a:srgbClr val="000000"/>
+                </a:solidFill>
+                <a:latin typeface="Arial"/>
+              </a:defRPr>
+            </a:pPr>
+            <a:r>
+              <a:rPr>
+                <a:latin typeface="Arial"/>
+              </a:rPr>
+              <a:t>•    Assolible des d'un nucli</a:t>
+            </a:r>
+          </a:p>
+          <a:p>
+            <a:pPr>
+              <a:spcAft>
+                <a:spcPts val="400"/>
+              </a:spcAft>
+              <a:defRPr sz="1100">
+                <a:solidFill>
+                  <a:srgbClr val="000000"/>
+                </a:solidFill>
+                <a:latin typeface="Arial"/>
+              </a:defRPr>
+            </a:pPr>
+            <a:r>
+              <a:rPr>
+                <a:latin typeface="Arial"/>
+              </a:rPr>
+              <a:t>• Soroll (Noise):</a:t>
+            </a:r>
+          </a:p>
+          <a:p>
+            <a:pPr>
+              <a:spcAft>
+                <a:spcPts val="400"/>
+              </a:spcAft>
+              <a:defRPr sz="1100">
+                <a:solidFill>
+                  <a:srgbClr val="000000"/>
+                </a:solidFill>
+                <a:latin typeface="Arial"/>
+              </a:defRPr>
+            </a:pPr>
+            <a:r>
+              <a:rPr>
+                <a:latin typeface="Arial"/>
+              </a:rPr>
+              <a:t>•    No assolible (|N_ε| &lt; min_samples)</a:t>
+            </a:r>
+          </a:p>
+        </p:txBody>
+      </p:sp>
+      <p:sp>
+        <p:nvSpPr>
+          <p:cNvPr id="12" name="Rounded Rectangle 11"/>
+          <p:cNvSpPr/>
+          <p:nvPr/>
+        </p:nvSpPr>
+        <p:spPr>
+          <a:xfrm>
+            <a:off x="8138160" y="1463040"/>
+            <a:ext cx="3337560" cy="4754880"/>
+          </a:xfrm>
+          <a:prstGeom prst="roundRect">
+            <a:avLst/>
+          </a:prstGeom>
+          <a:solidFill>
+            <a:srgbClr val="FFFFFF"/>
+          </a:solidFill>
+          <a:ln w="19050">
+            <a:solidFill>
+              <a:srgbClr val="000000"/>
+            </a:solidFill>
+          </a:ln>
+        </p:spPr>
+        <p:style>
+          <a:lnRef idx="1">
+            <a:schemeClr val="accent1"/>
+          </a:lnRef>
+          <a:fillRef idx="3">
+            <a:schemeClr val="accent1"/>
+          </a:fillRef>
+          <a:effectRef idx="2">
+            <a:schemeClr val="accent1"/>
+          </a:effectRef>
+          <a:fontRef idx="minor">
+            <a:schemeClr val="lt1"/>
+          </a:fontRef>
+        </p:style>
+        <p:txBody>
+          <a:bodyPr rtlCol="0" anchor="ctr"/>
+          <a:lstStyle/>
+          <a:p>
+            <a:pPr algn="ctr">
+              <a:defRPr>
+                <a:latin typeface="Arial"/>
+              </a:defRPr>
+            </a:pPr>
+          </a:p>
+        </p:txBody>
+      </p:sp>
+      <p:sp>
+        <p:nvSpPr>
+          <p:cNvPr id="13" name="TextBox 12"/>
+          <p:cNvSpPr txBox="1"/>
+          <p:nvPr/>
+        </p:nvSpPr>
+        <p:spPr>
+          <a:xfrm>
+            <a:off x="8321040" y="1600200"/>
+            <a:ext cx="2971800" cy="914400"/>
+          </a:xfrm>
+          <a:prstGeom prst="rect">
+            <a:avLst/>
+          </a:prstGeom>
+          <a:noFill/>
+        </p:spPr>
+        <p:txBody>
+          <a:bodyPr wrap="none">
+            <a:spAutoFit/>
+          </a:bodyPr>
+          <a:lstStyle/>
+          <a:p>
+            <a:pPr>
+              <a:defRPr sz="1500" b="1">
+                <a:solidFill>
+                  <a:srgbClr val="000000"/>
+                </a:solidFill>
+                <a:latin typeface="Arial"/>
+              </a:defRPr>
+            </a:pPr>
+            <a:r>
+              <a:rPr>
+                <a:latin typeface="Arial"/>
+              </a:rPr>
+              <a:t>3. Paràmetres Fixats</a:t>
+            </a:r>
+            <a:br/>
+            <a:r>
+              <a:rPr>
+                <a:latin typeface="Arial"/>
+              </a:rPr>
+              <a:t>(Criteri Objectiu)</a:t>
+            </a:r>
+          </a:p>
+        </p:txBody>
+      </p:sp>
+      <p:pic>
+        <p:nvPicPr>
+          <p:cNvPr id="14" name="Picture 13" descr="formula_parametros.png"/>
+          <p:cNvPicPr>
+            <a:picLocks noChangeAspect="1"/>
+          </p:cNvPicPr>
+          <p:nvPr/>
+        </p:nvPicPr>
+        <p:blipFill>
+          <a:blip r:embed="rId4"/>
+          <a:stretch>
+            <a:fillRect/>
+          </a:stretch>
+        </p:blipFill>
+        <p:spPr>
+          <a:xfrm>
+            <a:off x="8275320" y="2331720"/>
+            <a:ext cx="3063240" cy="521778"/>
+          </a:xfrm>
+          <a:prstGeom prst="rect">
+            <a:avLst/>
+          </a:prstGeom>
+        </p:spPr>
+      </p:pic>
+      <p:sp>
+        <p:nvSpPr>
+          <p:cNvPr id="15" name="TextBox 14"/>
+          <p:cNvSpPr txBox="1"/>
+          <p:nvPr/>
+        </p:nvSpPr>
+        <p:spPr>
+          <a:xfrm>
+            <a:off x="8321040" y="3703320"/>
+            <a:ext cx="2971800" cy="2468880"/>
+          </a:xfrm>
+          <a:prstGeom prst="rect">
+            <a:avLst/>
+          </a:prstGeom>
+          <a:noFill/>
+        </p:spPr>
+        <p:txBody>
+          <a:bodyPr wrap="square">
+            <a:spAutoFit/>
+          </a:bodyPr>
+          <a:lstStyle/>
+          <a:p>
+            <a:pPr>
+              <a:spcAft>
+                <a:spcPts val="500"/>
+              </a:spcAft>
+              <a:defRPr sz="1100">
+                <a:solidFill>
+                  <a:srgbClr val="000000"/>
+                </a:solidFill>
+                <a:latin typeface="Arial"/>
+              </a:defRPr>
+            </a:pPr>
+            <a:r>
+              <a:rPr>
+                <a:latin typeface="Arial"/>
+              </a:rPr>
+              <a:t>• min_samples = 3:</a:t>
+            </a:r>
+          </a:p>
+          <a:p>
+            <a:pPr>
+              <a:spcAft>
+                <a:spcPts val="500"/>
+              </a:spcAft>
+              <a:defRPr sz="1100">
+                <a:solidFill>
+                  <a:srgbClr val="000000"/>
+                </a:solidFill>
+                <a:latin typeface="Arial"/>
+              </a:defRPr>
+            </a:pPr>
+            <a:r>
+              <a:rPr>
+                <a:latin typeface="Arial"/>
+              </a:rPr>
+              <a:t>•    Regla canònica k ≥ d + 1 (dimensió d = 2).</a:t>
+            </a:r>
+          </a:p>
+          <a:p>
+            <a:pPr>
+              <a:spcAft>
+                <a:spcPts val="500"/>
+              </a:spcAft>
+              <a:defRPr sz="1100">
+                <a:solidFill>
+                  <a:srgbClr val="000000"/>
+                </a:solidFill>
+                <a:latin typeface="Arial"/>
+              </a:defRPr>
+            </a:pPr>
+            <a:r>
+              <a:rPr>
+                <a:latin typeface="Arial"/>
+              </a:rPr>
+              <a:t>• ε = 0.65:</a:t>
+            </a:r>
+          </a:p>
+          <a:p>
+            <a:pPr>
+              <a:spcAft>
+                <a:spcPts val="500"/>
+              </a:spcAft>
+              <a:defRPr sz="1100">
+                <a:solidFill>
+                  <a:srgbClr val="000000"/>
+                </a:solidFill>
+                <a:latin typeface="Arial"/>
+              </a:defRPr>
+            </a:pPr>
+            <a:r>
+              <a:rPr>
+                <a:latin typeface="Arial"/>
+              </a:rPr>
+              <a:t>•    Determinat mitjançant gràfic k-NN (colze).</a:t>
+            </a:r>
+          </a:p>
+          <a:p>
+            <a:pPr>
+              <a:spcAft>
+                <a:spcPts val="500"/>
+              </a:spcAft>
+              <a:defRPr sz="1100">
+                <a:solidFill>
+                  <a:srgbClr val="000000"/>
+                </a:solidFill>
+                <a:latin typeface="Arial"/>
+              </a:defRPr>
+            </a:pPr>
+            <a:r>
+              <a:rPr>
+                <a:latin typeface="Arial"/>
+              </a:rPr>
+              <a:t>•    Finestra òptima que aïlla aïllants sense fusionar metalls.</a:t>
+            </a:r>
+          </a:p>
+          <a:p>
+            <a:pPr>
+              <a:spcAft>
+                <a:spcPts val="500"/>
+              </a:spcAft>
+              <a:defRPr sz="1100">
+                <a:solidFill>
+                  <a:srgbClr val="000000"/>
+                </a:solidFill>
+                <a:latin typeface="Arial"/>
+              </a:defRPr>
+            </a:pPr>
+            <a:r>
+              <a:rPr>
+                <a:latin typeface="Arial"/>
+              </a:rPr>
+              <a:t>• Execució: scikit-learn DBSCAN</a:t>
+            </a:r>
+          </a:p>
+        </p:txBody>
+      </p:sp>
     </p:spTree>
   </p:cSld>
   <p:clrMapOvr>
@@ -5042,8 +6685,8 @@
         </p:nvSpPr>
         <p:spPr>
           <a:xfrm>
-            <a:off x="548640" y="320040"/>
-            <a:ext cx="10972800" cy="914400"/>
+            <a:off x="731520" y="228600"/>
+            <a:ext cx="10698480" cy="548640"/>
           </a:xfrm>
           <a:prstGeom prst="rect">
             <a:avLst/>
@@ -5051,115 +6694,68 @@
           <a:noFill/>
         </p:spPr>
         <p:txBody>
-          <a:bodyPr wrap="square">
+          <a:bodyPr wrap="none">
             <a:spAutoFit/>
           </a:bodyPr>
           <a:lstStyle/>
           <a:p>
             <a:pPr>
-              <a:spcAft>
-                <a:spcPts val="800"/>
-              </a:spcAft>
-              <a:defRPr sz="3200" b="1">
-                <a:latin typeface="Arial"/>
-              </a:defRPr>
-            </a:pPr>
-            <a:r>
-              <a:rPr>
-                <a:latin typeface="Arial"/>
-              </a:rPr>
-              <a:t>Validació física: Matriu de contingència</a:t>
-            </a:r>
-          </a:p>
-        </p:txBody>
-      </p:sp>
-      <p:sp>
-        <p:nvSpPr>
-          <p:cNvPr id="3" name="TextBox 2"/>
-          <p:cNvSpPr txBox="1"/>
+              <a:defRPr sz="2200" b="1">
+                <a:solidFill>
+                  <a:srgbClr val="000000"/>
+                </a:solidFill>
+                <a:latin typeface="Arial"/>
+              </a:defRPr>
+            </a:pPr>
+            <a:r>
+              <a:rPr>
+                <a:latin typeface="Arial"/>
+              </a:rPr>
+              <a:t>Resultat DBSCAN: Abans i Després de l'Agrupament</a:t>
+            </a:r>
+          </a:p>
+          <a:p>
+            <a:pPr>
+              <a:defRPr sz="1300">
+                <a:solidFill>
+                  <a:srgbClr val="000000"/>
+                </a:solidFill>
+                <a:latin typeface="Arial"/>
+              </a:defRPr>
+            </a:pPr>
+            <a:r>
+              <a:rPr>
+                <a:latin typeface="Arial"/>
+              </a:rPr>
+              <a:t>Dades Experimentals en Brut vs. 3 Clústers Purs Descoberts (ε = 0.65, min_samples = 3)</a:t>
+            </a:r>
+          </a:p>
+        </p:txBody>
+      </p:sp>
+      <p:pic>
+        <p:nvPicPr>
+          <p:cNvPr id="3" name="Picture 2" descr="comparativa_abans_despres_dbscan.png"/>
+          <p:cNvPicPr>
+            <a:picLocks noChangeAspect="1"/>
+          </p:cNvPicPr>
           <p:nvPr/>
-        </p:nvSpPr>
-        <p:spPr>
-          <a:xfrm>
-            <a:off x="548640" y="1371600"/>
-            <a:ext cx="10972800" cy="4572000"/>
+        </p:nvPicPr>
+        <p:blipFill>
+          <a:blip r:embed="rId2"/>
+          <a:stretch>
+            <a:fillRect/>
+          </a:stretch>
+        </p:blipFill>
+        <p:spPr>
+          <a:xfrm>
+            <a:off x="731520" y="1188720"/>
+            <a:ext cx="10728655" cy="4157354"/>
           </a:xfrm>
           <a:prstGeom prst="rect">
             <a:avLst/>
           </a:prstGeom>
-          <a:noFill/>
-        </p:spPr>
-        <p:txBody>
-          <a:bodyPr wrap="square">
-            <a:spAutoFit/>
-          </a:bodyPr>
-          <a:lstStyle/>
-          <a:p>
-            <a:pPr>
-              <a:spcAft>
-                <a:spcPts val="800"/>
-              </a:spcAft>
-              <a:defRPr sz="2000" b="0">
-                <a:latin typeface="Arial"/>
-              </a:defRPr>
-            </a:pPr>
-            <a:r>
-              <a:rPr>
-                <a:latin typeface="Arial"/>
-              </a:rPr>
-              <a:t>• Conductors: 35 de 35 (100 % puresa al Clúster 0)</a:t>
-            </a:r>
-          </a:p>
-          <a:p>
-            <a:pPr>
-              <a:spcAft>
-                <a:spcPts val="800"/>
-              </a:spcAft>
-              <a:defRPr sz="2000" b="0">
-                <a:latin typeface="Arial"/>
-              </a:defRPr>
-            </a:pPr>
-            <a:r>
-              <a:rPr>
-                <a:latin typeface="Arial"/>
-              </a:rPr>
-              <a:t>• Aïllants: 10 de 10 (100 % puresa al Clúster 1)</a:t>
-            </a:r>
-          </a:p>
-          <a:p>
-            <a:pPr>
-              <a:spcAft>
-                <a:spcPts val="800"/>
-              </a:spcAft>
-              <a:defRPr sz="2000" b="0">
-                <a:latin typeface="Arial"/>
-              </a:defRPr>
-            </a:pPr>
-            <a:r>
-              <a:rPr>
-                <a:latin typeface="Arial"/>
-              </a:rPr>
-              <a:t>• Semiconductors: 10 de 12 (83,3 % puresa al Clúster 2; 2 semimetalls al clúster 0)</a:t>
-            </a:r>
-          </a:p>
-          <a:p>
-            <a:pPr>
-              <a:spcAft>
-                <a:spcPts val="800"/>
-              </a:spcAft>
-              <a:defRPr sz="2000" b="0">
-                <a:latin typeface="Arial"/>
-              </a:defRPr>
-            </a:pPr>
-            <a:r>
-              <a:rPr>
-                <a:latin typeface="Arial"/>
-              </a:rPr>
-              <a:t>• Silhouette Score complementari: 0,7858 (alta cohesió interna)</a:t>
-            </a:r>
-          </a:p>
-        </p:txBody>
-      </p:sp>
+        </p:spPr>
+      </p:pic>
     </p:spTree>
   </p:cSld>
   <p:clrMapOvr>
@@ -5186,8 +6782,135 @@
         </p:nvSpPr>
         <p:spPr>
           <a:xfrm>
-            <a:off x="548640" y="320040"/>
-            <a:ext cx="10972800" cy="914400"/>
+            <a:off x="731520" y="365760"/>
+            <a:ext cx="10698480" cy="320040"/>
+          </a:xfrm>
+          <a:prstGeom prst="rect">
+            <a:avLst/>
+          </a:prstGeom>
+          <a:noFill/>
+        </p:spPr>
+        <p:txBody>
+          <a:bodyPr wrap="none">
+            <a:spAutoFit/>
+          </a:bodyPr>
+          <a:lstStyle/>
+          <a:p>
+            <a:pPr>
+              <a:defRPr sz="1050" b="1">
+                <a:solidFill>
+                  <a:srgbClr val="000000"/>
+                </a:solidFill>
+                <a:latin typeface="Arial"/>
+              </a:defRPr>
+            </a:pPr>
+            <a:r>
+              <a:rPr>
+                <a:latin typeface="Arial"/>
+              </a:rPr>
+              <a:t>CPIA · APRENENTATGE NO SUPERVISAT</a:t>
+            </a:r>
+          </a:p>
+        </p:txBody>
+      </p:sp>
+      <p:sp>
+        <p:nvSpPr>
+          <p:cNvPr id="3" name="TextBox 2"/>
+          <p:cNvSpPr txBox="1"/>
+          <p:nvPr/>
+        </p:nvSpPr>
+        <p:spPr>
+          <a:xfrm>
+            <a:off x="731520" y="685800"/>
+            <a:ext cx="10698480" cy="640080"/>
+          </a:xfrm>
+          <a:prstGeom prst="rect">
+            <a:avLst/>
+          </a:prstGeom>
+          <a:noFill/>
+        </p:spPr>
+        <p:txBody>
+          <a:bodyPr wrap="none">
+            <a:spAutoFit/>
+          </a:bodyPr>
+          <a:lstStyle/>
+          <a:p>
+            <a:pPr>
+              <a:defRPr sz="2300" b="1">
+                <a:solidFill>
+                  <a:srgbClr val="000000"/>
+                </a:solidFill>
+                <a:latin typeface="Arial"/>
+              </a:defRPr>
+            </a:pPr>
+            <a:r>
+              <a:rPr>
+                <a:latin typeface="Arial"/>
+              </a:rPr>
+              <a:t>Validació Experimental: Matriu de Contingència Física</a:t>
+            </a:r>
+          </a:p>
+        </p:txBody>
+      </p:sp>
+      <p:sp>
+        <p:nvSpPr>
+          <p:cNvPr id="4" name="Rounded Rectangle 3"/>
+          <p:cNvSpPr/>
+          <p:nvPr/>
+        </p:nvSpPr>
+        <p:spPr>
+          <a:xfrm>
+            <a:off x="731520" y="1463040"/>
+            <a:ext cx="3337560" cy="4754880"/>
+          </a:xfrm>
+          <a:prstGeom prst="roundRect">
+            <a:avLst/>
+          </a:prstGeom>
+          <a:solidFill>
+            <a:srgbClr val="FFFFFF"/>
+          </a:solidFill>
+          <a:ln w="19050">
+            <a:solidFill>
+              <a:srgbClr val="000000"/>
+            </a:solidFill>
+          </a:ln>
+        </p:spPr>
+        <p:style>
+          <a:lnRef idx="1">
+            <a:schemeClr val="accent1"/>
+          </a:lnRef>
+          <a:fillRef idx="3">
+            <a:schemeClr val="accent1"/>
+          </a:fillRef>
+          <a:effectRef idx="2">
+            <a:schemeClr val="accent1"/>
+          </a:effectRef>
+          <a:fontRef idx="minor">
+            <a:schemeClr val="lt1"/>
+          </a:fontRef>
+        </p:style>
+        <p:txBody>
+          <a:bodyPr rtlCol="0" anchor="ctr"/>
+          <a:lstStyle/>
+          <a:p>
+            <a:pPr algn="ctr">
+              <a:defRPr>
+                <a:latin typeface="Arial"/>
+              </a:defRPr>
+            </a:pPr>
+          </a:p>
+        </p:txBody>
+      </p:sp>
+      <p:sp>
+        <p:nvSpPr>
+          <p:cNvPr id="5" name="TextBox 4"/>
+          <p:cNvSpPr txBox="1"/>
+          <p:nvPr/>
+        </p:nvSpPr>
+        <p:spPr>
+          <a:xfrm>
+            <a:off x="914400" y="1783080"/>
+            <a:ext cx="2971800" cy="4114800"/>
           </a:xfrm>
           <a:prstGeom prst="rect">
             <a:avLst/>
@@ -5201,32 +6924,130 @@
           <a:lstStyle/>
           <a:p>
             <a:pPr>
-              <a:spcAft>
-                <a:spcPts val="800"/>
-              </a:spcAft>
-              <a:defRPr sz="3200" b="1">
-                <a:latin typeface="Arial"/>
-              </a:defRPr>
-            </a:pPr>
-            <a:r>
-              <a:rPr>
-                <a:latin typeface="Arial"/>
-              </a:rPr>
-              <a:t>Conclusiones</a:t>
-            </a:r>
-          </a:p>
-        </p:txBody>
-      </p:sp>
-      <p:sp>
-        <p:nvSpPr>
-          <p:cNvPr id="3" name="TextBox 2"/>
+              <a:defRPr sz="1800" b="1">
+                <a:solidFill>
+                  <a:srgbClr val="000000"/>
+                </a:solidFill>
+                <a:latin typeface="Arial"/>
+              </a:defRPr>
+            </a:pPr>
+            <a:r>
+              <a:rPr>
+                <a:latin typeface="Arial"/>
+              </a:rPr>
+              <a:t>Conductors (Metalls)</a:t>
+            </a:r>
+          </a:p>
+          <a:p>
+            <a:pPr algn="ctr">
+              <a:defRPr sz="3600" b="1">
+                <a:solidFill>
+                  <a:srgbClr val="000000"/>
+                </a:solidFill>
+                <a:latin typeface="Arial"/>
+              </a:defRPr>
+            </a:pPr>
+            <a:r>
+              <a:rPr>
+                <a:latin typeface="Arial"/>
+              </a:rPr>
+              <a:t>35 / 35</a:t>
+            </a:r>
+          </a:p>
+          <a:p>
+            <a:pPr algn="ctr">
+              <a:defRPr sz="1800" b="1">
+                <a:solidFill>
+                  <a:srgbClr val="000000"/>
+                </a:solidFill>
+                <a:latin typeface="Arial"/>
+              </a:defRPr>
+            </a:pPr>
+            <a:r>
+              <a:rPr>
+                <a:latin typeface="Arial"/>
+              </a:rPr>
+              <a:t>100 % Puresa</a:t>
+            </a:r>
+          </a:p>
+          <a:p>
+            <a:br/>
+            <a:pPr>
+              <a:defRPr sz="1300">
+                <a:solidFill>
+                  <a:srgbClr val="000000"/>
+                </a:solidFill>
+                <a:latin typeface="Arial"/>
+              </a:defRPr>
+            </a:pPr>
+            <a:r>
+              <a:rPr>
+                <a:latin typeface="Arial"/>
+              </a:rPr>
+              <a:t>Assignats íntegrament al Clúster 0. Zero falsos negatius.</a:t>
+            </a:r>
+          </a:p>
+        </p:txBody>
+      </p:sp>
+      <p:sp>
+        <p:nvSpPr>
+          <p:cNvPr id="6" name="Rounded Rectangle 5"/>
+          <p:cNvSpPr/>
+          <p:nvPr/>
+        </p:nvSpPr>
+        <p:spPr>
+          <a:xfrm>
+            <a:off x="4434840" y="1463040"/>
+            <a:ext cx="3337560" cy="4754880"/>
+          </a:xfrm>
+          <a:prstGeom prst="roundRect">
+            <a:avLst/>
+          </a:prstGeom>
+          <a:solidFill>
+            <a:srgbClr val="FFFFFF"/>
+          </a:solidFill>
+          <a:ln w="19050">
+            <a:solidFill>
+              <a:srgbClr val="000000"/>
+            </a:solidFill>
+          </a:ln>
+        </p:spPr>
+        <p:style>
+          <a:lnRef idx="1">
+            <a:schemeClr val="accent1"/>
+          </a:lnRef>
+          <a:fillRef idx="3">
+            <a:schemeClr val="accent1"/>
+          </a:fillRef>
+          <a:effectRef idx="2">
+            <a:schemeClr val="accent1"/>
+          </a:effectRef>
+          <a:fontRef idx="minor">
+            <a:schemeClr val="lt1"/>
+          </a:fontRef>
+        </p:style>
+        <p:txBody>
+          <a:bodyPr rtlCol="0" anchor="ctr"/>
+          <a:lstStyle/>
+          <a:p>
+            <a:pPr algn="ctr">
+              <a:defRPr>
+                <a:latin typeface="Arial"/>
+              </a:defRPr>
+            </a:pPr>
+          </a:p>
+        </p:txBody>
+      </p:sp>
+      <p:sp>
+        <p:nvSpPr>
+          <p:cNvPr id="7" name="TextBox 6"/>
           <p:cNvSpPr txBox="1"/>
           <p:nvPr/>
         </p:nvSpPr>
         <p:spPr>
           <a:xfrm>
-            <a:off x="548640" y="1371600"/>
-            <a:ext cx="10972800" cy="4572000"/>
+            <a:off x="4617720" y="1783080"/>
+            <a:ext cx="2971800" cy="4114800"/>
           </a:xfrm>
           <a:prstGeom prst="rect">
             <a:avLst/>
@@ -5240,6 +7061,113 @@
           <a:lstStyle/>
           <a:p>
             <a:pPr>
+              <a:defRPr sz="1800" b="1">
+                <a:solidFill>
+                  <a:srgbClr val="000000"/>
+                </a:solidFill>
+                <a:latin typeface="Arial"/>
+              </a:defRPr>
+            </a:pPr>
+            <a:r>
+              <a:rPr>
+                <a:latin typeface="Arial"/>
+              </a:rPr>
+              <a:t>Aïllants (Dielèctrics)</a:t>
+            </a:r>
+          </a:p>
+          <a:p>
+            <a:pPr algn="ctr">
+              <a:defRPr sz="3600" b="1">
+                <a:solidFill>
+                  <a:srgbClr val="000000"/>
+                </a:solidFill>
+                <a:latin typeface="Arial"/>
+              </a:defRPr>
+            </a:pPr>
+            <a:r>
+              <a:rPr>
+                <a:latin typeface="Arial"/>
+              </a:rPr>
+              <a:t>10 / 10</a:t>
+            </a:r>
+          </a:p>
+          <a:p>
+            <a:pPr algn="ctr">
+              <a:defRPr sz="1800" b="1">
+                <a:solidFill>
+                  <a:srgbClr val="000000"/>
+                </a:solidFill>
+                <a:latin typeface="Arial"/>
+              </a:defRPr>
+            </a:pPr>
+            <a:r>
+              <a:rPr>
+                <a:latin typeface="Arial"/>
+              </a:rPr>
+              <a:t>100 % Puresa</a:t>
+            </a:r>
+          </a:p>
+          <a:p>
+            <a:br/>
+            <a:pPr>
+              <a:defRPr sz="1300">
+                <a:solidFill>
+                  <a:srgbClr val="000000"/>
+                </a:solidFill>
+                <a:latin typeface="Arial"/>
+              </a:defRPr>
+            </a:pPr>
+            <a:r>
+              <a:rPr>
+                <a:latin typeface="Arial"/>
+              </a:rPr>
+              <a:t>Assignats íntegrament al Clúster 1. Coincidència total amb la física.</a:t>
+            </a:r>
+          </a:p>
+        </p:txBody>
+      </p:sp>
+      <p:sp>
+        <p:nvSpPr>
+          <p:cNvPr id="8" name="Rounded Rectangle 7"/>
+          <p:cNvSpPr/>
+          <p:nvPr/>
+        </p:nvSpPr>
+        <p:spPr>
+          <a:xfrm>
+            <a:off x="8138160" y="1463040"/>
+            <a:ext cx="3337560" cy="4754880"/>
+          </a:xfrm>
+          <a:prstGeom prst="roundRect">
+            <a:avLst/>
+          </a:prstGeom>
+          <a:solidFill>
+            <a:srgbClr val="FFFFFF"/>
+          </a:solidFill>
+          <a:ln w="19050">
+            <a:solidFill>
+              <a:srgbClr val="000000"/>
+            </a:solidFill>
+          </a:ln>
+        </p:spPr>
+        <p:style>
+          <a:lnRef idx="1">
+            <a:schemeClr val="accent1"/>
+          </a:lnRef>
+          <a:fillRef idx="3">
+            <a:schemeClr val="accent1"/>
+          </a:fillRef>
+          <a:effectRef idx="2">
+            <a:schemeClr val="accent1"/>
+          </a:effectRef>
+          <a:fontRef idx="minor">
+            <a:schemeClr val="lt1"/>
+          </a:fontRef>
+        </p:style>
+        <p:txBody>
+          <a:bodyPr rtlCol="0" anchor="ctr"/>
+          <a:lstStyle/>
+          <a:p>
+            <a:pPr algn="ctr">
               <a:defRPr>
                 <a:latin typeface="Arial"/>
               </a:defRPr>
@@ -5249,14 +7177,14 @@
       </p:sp>
       <p:sp>
         <p:nvSpPr>
-          <p:cNvPr id="4" name="TextBox 3"/>
+          <p:cNvPr id="9" name="TextBox 8"/>
           <p:cNvSpPr txBox="1"/>
           <p:nvPr/>
         </p:nvSpPr>
         <p:spPr>
           <a:xfrm>
-            <a:off x="548640" y="5852160"/>
-            <a:ext cx="10972800" cy="731520"/>
+            <a:off x="8321040" y="1783080"/>
+            <a:ext cx="2971800" cy="4114800"/>
           </a:xfrm>
           <a:prstGeom prst="rect">
             <a:avLst/>
@@ -5270,21 +7198,67 @@
           <a:lstStyle/>
           <a:p>
             <a:pPr>
-              <a:spcAft>
-                <a:spcPts val="800"/>
-              </a:spcAft>
               <a:defRPr sz="1800" b="1">
                 <a:solidFill>
-                  <a:srgbClr val="B03030"/>
-                </a:solidFill>
-                <a:latin typeface="Arial"/>
-              </a:defRPr>
-            </a:pPr>
-            <a:r>
-              <a:rPr>
-                <a:latin typeface="Arial"/>
-              </a:rPr>
-              <a:t>[PENDIENTE: comparativa del equipo: qué algoritmo funcionó mejor y por qué]</a:t>
+                  <a:srgbClr val="000000"/>
+                </a:solidFill>
+                <a:latin typeface="Arial"/>
+              </a:defRPr>
+            </a:pPr>
+            <a:r>
+              <a:rPr>
+                <a:latin typeface="Arial"/>
+              </a:rPr>
+              <a:t>Semiconductors</a:t>
+            </a:r>
+          </a:p>
+          <a:p>
+            <a:pPr algn="ctr">
+              <a:defRPr sz="3600" b="1">
+                <a:solidFill>
+                  <a:srgbClr val="000000"/>
+                </a:solidFill>
+                <a:latin typeface="Arial"/>
+              </a:defRPr>
+            </a:pPr>
+            <a:r>
+              <a:rPr>
+                <a:latin typeface="Arial"/>
+              </a:rPr>
+              <a:t>10 / 12</a:t>
+            </a:r>
+          </a:p>
+          <a:p>
+            <a:pPr algn="ctr">
+              <a:defRPr sz="1800" b="1">
+                <a:solidFill>
+                  <a:srgbClr val="000000"/>
+                </a:solidFill>
+                <a:latin typeface="Arial"/>
+              </a:defRPr>
+            </a:pPr>
+            <a:r>
+              <a:rPr>
+                <a:latin typeface="Arial"/>
+              </a:rPr>
+              <a:t>83.3 % Puresa</a:t>
+            </a:r>
+          </a:p>
+          <a:p>
+            <a:br/>
+            <a:pPr>
+              <a:defRPr sz="1200">
+                <a:solidFill>
+                  <a:srgbClr val="000000"/>
+                </a:solidFill>
+                <a:latin typeface="Arial"/>
+              </a:defRPr>
+            </a:pPr>
+            <a:r>
+              <a:rPr>
+                <a:latin typeface="Arial"/>
+              </a:rPr>
+              <a:t>10 al Clúster 2. 2 semimetalls classificats al clúster 0 per conducció cuasimetàl·lica.</a:t>
             </a:r>
           </a:p>
         </p:txBody>
@@ -5315,8 +7289,135 @@
         </p:nvSpPr>
         <p:spPr>
           <a:xfrm>
-            <a:off x="548640" y="320040"/>
-            <a:ext cx="10972800" cy="914400"/>
+            <a:off x="731520" y="365760"/>
+            <a:ext cx="10698480" cy="320040"/>
+          </a:xfrm>
+          <a:prstGeom prst="rect">
+            <a:avLst/>
+          </a:prstGeom>
+          <a:noFill/>
+        </p:spPr>
+        <p:txBody>
+          <a:bodyPr wrap="none">
+            <a:spAutoFit/>
+          </a:bodyPr>
+          <a:lstStyle/>
+          <a:p>
+            <a:pPr>
+              <a:defRPr sz="1050" b="1">
+                <a:solidFill>
+                  <a:srgbClr val="000000"/>
+                </a:solidFill>
+                <a:latin typeface="Arial"/>
+              </a:defRPr>
+            </a:pPr>
+            <a:r>
+              <a:rPr>
+                <a:latin typeface="Arial"/>
+              </a:rPr>
+              <a:t>CPIA · APRENENTATGE NO SUPERVISAT</a:t>
+            </a:r>
+          </a:p>
+        </p:txBody>
+      </p:sp>
+      <p:sp>
+        <p:nvSpPr>
+          <p:cNvPr id="3" name="TextBox 2"/>
+          <p:cNvSpPr txBox="1"/>
+          <p:nvPr/>
+        </p:nvSpPr>
+        <p:spPr>
+          <a:xfrm>
+            <a:off x="731520" y="685800"/>
+            <a:ext cx="10698480" cy="640080"/>
+          </a:xfrm>
+          <a:prstGeom prst="rect">
+            <a:avLst/>
+          </a:prstGeom>
+          <a:noFill/>
+        </p:spPr>
+        <p:txBody>
+          <a:bodyPr wrap="none">
+            <a:spAutoFit/>
+          </a:bodyPr>
+          <a:lstStyle/>
+          <a:p>
+            <a:pPr>
+              <a:defRPr sz="2300" b="1">
+                <a:solidFill>
+                  <a:srgbClr val="000000"/>
+                </a:solidFill>
+                <a:latin typeface="Arial"/>
+              </a:defRPr>
+            </a:pPr>
+            <a:r>
+              <a:rPr>
+                <a:latin typeface="Arial"/>
+              </a:rPr>
+              <a:t>Conclusions</a:t>
+            </a:r>
+          </a:p>
+        </p:txBody>
+      </p:sp>
+      <p:sp>
+        <p:nvSpPr>
+          <p:cNvPr id="4" name="Rounded Rectangle 3"/>
+          <p:cNvSpPr/>
+          <p:nvPr/>
+        </p:nvSpPr>
+        <p:spPr>
+          <a:xfrm>
+            <a:off x="1097280" y="1554480"/>
+            <a:ext cx="9997135" cy="4572000"/>
+          </a:xfrm>
+          <a:prstGeom prst="roundRect">
+            <a:avLst/>
+          </a:prstGeom>
+          <a:solidFill>
+            <a:srgbClr val="FFFFFF"/>
+          </a:solidFill>
+          <a:ln w="19050">
+            <a:solidFill>
+              <a:srgbClr val="000000"/>
+            </a:solidFill>
+          </a:ln>
+        </p:spPr>
+        <p:style>
+          <a:lnRef idx="1">
+            <a:schemeClr val="accent1"/>
+          </a:lnRef>
+          <a:fillRef idx="3">
+            <a:schemeClr val="accent1"/>
+          </a:fillRef>
+          <a:effectRef idx="2">
+            <a:schemeClr val="accent1"/>
+          </a:effectRef>
+          <a:fontRef idx="minor">
+            <a:schemeClr val="lt1"/>
+          </a:fontRef>
+        </p:style>
+        <p:txBody>
+          <a:bodyPr rtlCol="0" anchor="ctr"/>
+          <a:lstStyle/>
+          <a:p>
+            <a:pPr algn="ctr">
+              <a:defRPr>
+                <a:latin typeface="Arial"/>
+              </a:defRPr>
+            </a:pPr>
+          </a:p>
+        </p:txBody>
+      </p:sp>
+      <p:sp>
+        <p:nvSpPr>
+          <p:cNvPr id="5" name="TextBox 4"/>
+          <p:cNvSpPr txBox="1"/>
+          <p:nvPr/>
+        </p:nvSpPr>
+        <p:spPr>
+          <a:xfrm>
+            <a:off x="1463040" y="1828800"/>
+            <a:ext cx="9235440" cy="4023360"/>
           </a:xfrm>
           <a:prstGeom prst="rect">
             <a:avLst/>
@@ -5331,56 +7432,96 @@
           <a:p>
             <a:pPr>
               <a:spcAft>
-                <a:spcPts val="800"/>
+                <a:spcPts val="1400"/>
               </a:spcAft>
-              <a:defRPr sz="3200" b="1">
-                <a:latin typeface="Arial"/>
-              </a:defRPr>
-            </a:pPr>
-            <a:r>
-              <a:rPr>
-                <a:latin typeface="Arial"/>
-              </a:rPr>
-              <a:t>Preguntas</a:t>
-            </a:r>
-          </a:p>
-        </p:txBody>
-      </p:sp>
-      <p:sp>
-        <p:nvSpPr>
-          <p:cNvPr id="3" name="TextBox 2"/>
-          <p:cNvSpPr txBox="1"/>
-          <p:nvPr/>
-        </p:nvSpPr>
-        <p:spPr>
-          <a:xfrm>
-            <a:off x="548640" y="1371600"/>
-            <a:ext cx="10972800" cy="4572000"/>
-          </a:xfrm>
-          <a:prstGeom prst="rect">
-            <a:avLst/>
-          </a:prstGeom>
-          <a:noFill/>
-        </p:spPr>
-        <p:txBody>
-          <a:bodyPr wrap="square">
-            <a:spAutoFit/>
-          </a:bodyPr>
-          <a:lstStyle/>
+              <a:defRPr sz="2000" b="1">
+                <a:solidFill>
+                  <a:srgbClr val="000000"/>
+                </a:solidFill>
+                <a:latin typeface="Arial"/>
+              </a:defRPr>
+            </a:pPr>
+            <a:r>
+              <a:rPr>
+                <a:latin typeface="Arial"/>
+              </a:rPr>
+              <a:t>Punts Clau del Projecte</a:t>
+            </a:r>
+          </a:p>
           <a:p>
             <a:pPr>
               <a:spcAft>
-                <a:spcPts val="800"/>
+                <a:spcPts val="1200"/>
               </a:spcAft>
-              <a:defRPr sz="2000" b="0">
-                <a:latin typeface="Arial"/>
-              </a:defRPr>
-            </a:pPr>
-            <a:r>
-              <a:rPr>
-                <a:latin typeface="Arial"/>
-              </a:rPr>
-              <a:t>• Código y documento de descripción entregados en Atenea</a:t>
+              <a:defRPr sz="1400">
+                <a:solidFill>
+                  <a:srgbClr val="000000"/>
+                </a:solidFill>
+                <a:latin typeface="Arial"/>
+              </a:defRPr>
+            </a:pPr>
+            <a:r>
+              <a:rPr>
+                <a:latin typeface="Arial"/>
+              </a:rPr>
+              <a:t>✔  Física de bandes sense supervisió:  DBSCAN descobreix de manera autònoma les 3 fases de conducció (conductors, aïllants i semiconductors) a partir de propietats macroscòpiques.</a:t>
+            </a:r>
+          </a:p>
+          <a:p>
+            <a:pPr>
+              <a:spcAft>
+                <a:spcPts val="1200"/>
+              </a:spcAft>
+              <a:defRPr sz="1400">
+                <a:solidFill>
+                  <a:srgbClr val="000000"/>
+                </a:solidFill>
+                <a:latin typeface="Arial"/>
+              </a:defRPr>
+            </a:pPr>
+            <a:r>
+              <a:rPr>
+                <a:latin typeface="Arial"/>
+              </a:rPr>
+              <a:t>✔  Immune a densitats dispars:  Supera K-Means agrupant simultàniament la ultradensitat dels metalls i la dispersió de 12 ordres de magnitud dels aïllants.</a:t>
+            </a:r>
+          </a:p>
+          <a:p>
+            <a:pPr>
+              <a:spcAft>
+                <a:spcPts val="1200"/>
+              </a:spcAft>
+              <a:defRPr sz="1400">
+                <a:solidFill>
+                  <a:srgbClr val="000000"/>
+                </a:solidFill>
+                <a:latin typeface="Arial"/>
+              </a:defRPr>
+            </a:pPr>
+            <a:r>
+              <a:rPr>
+                <a:latin typeface="Arial"/>
+              </a:rPr>
+              <a:t>✔  Variables òptimes:  L'escala logarítmica log₁₀(ρ) i el coeficient tèrmic quàntic α són suficients per separar completament els règims de transport.</a:t>
+            </a:r>
+          </a:p>
+          <a:p>
+            <a:pPr>
+              <a:spcAft>
+                <a:spcPts val="1200"/>
+              </a:spcAft>
+              <a:defRPr sz="1400">
+                <a:solidFill>
+                  <a:srgbClr val="000000"/>
+                </a:solidFill>
+                <a:latin typeface="Arial"/>
+              </a:defRPr>
+            </a:pPr>
+            <a:r>
+              <a:rPr>
+                <a:latin typeface="Arial"/>
+              </a:rPr>
+              <a:t>✔  Validació rotunda:  100% de puresa en conductors i aïllants amb Silhouette Score = 0.7858.</a:t>
             </a:r>
           </a:p>
         </p:txBody>
@@ -5567,6 +7708,231 @@
                 <a:latin typeface="Arial"/>
               </a:rPr>
               <a:t>[PENDIENTE: el equipo reparte quién explica la teoría de cada algoritmo]</a:t>
+            </a:r>
+          </a:p>
+        </p:txBody>
+      </p:sp>
+    </p:spTree>
+  </p:cSld>
+  <p:clrMapOvr>
+    <a:masterClrMapping/>
+  </p:clrMapOvr>
+</p:sld>
+</file>
+
+<file path=ppt/slides/slide20.xml><?xml version="1.0" encoding="utf-8"?>
+<p:sld xmlns:a="http://schemas.openxmlformats.org/drawingml/2006/main" xmlns:p="http://schemas.openxmlformats.org/presentationml/2006/main" xmlns:r="http://schemas.openxmlformats.org/officeDocument/2006/relationships">
+  <p:cSld>
+    <p:spTree>
+      <p:nvGrpSpPr>
+        <p:cNvPr id="1" name=""/>
+        <p:cNvGrpSpPr/>
+        <p:nvPr/>
+      </p:nvGrpSpPr>
+      <p:grpSpPr/>
+      <p:sp>
+        <p:nvSpPr>
+          <p:cNvPr id="2" name="TextBox 1"/>
+          <p:cNvSpPr txBox="1"/>
+          <p:nvPr/>
+        </p:nvSpPr>
+        <p:spPr>
+          <a:xfrm>
+            <a:off x="548640" y="320040"/>
+            <a:ext cx="10972800" cy="914400"/>
+          </a:xfrm>
+          <a:prstGeom prst="rect">
+            <a:avLst/>
+          </a:prstGeom>
+          <a:noFill/>
+        </p:spPr>
+        <p:txBody>
+          <a:bodyPr wrap="square">
+            <a:spAutoFit/>
+          </a:bodyPr>
+          <a:lstStyle/>
+          <a:p>
+            <a:pPr>
+              <a:spcAft>
+                <a:spcPts val="800"/>
+              </a:spcAft>
+              <a:defRPr sz="3200" b="1">
+                <a:latin typeface="Arial"/>
+              </a:defRPr>
+            </a:pPr>
+            <a:r>
+              <a:rPr>
+                <a:latin typeface="Arial"/>
+              </a:rPr>
+              <a:t>Conclusiones</a:t>
+            </a:r>
+          </a:p>
+        </p:txBody>
+      </p:sp>
+      <p:sp>
+        <p:nvSpPr>
+          <p:cNvPr id="3" name="TextBox 2"/>
+          <p:cNvSpPr txBox="1"/>
+          <p:nvPr/>
+        </p:nvSpPr>
+        <p:spPr>
+          <a:xfrm>
+            <a:off x="548640" y="1371600"/>
+            <a:ext cx="10972800" cy="4572000"/>
+          </a:xfrm>
+          <a:prstGeom prst="rect">
+            <a:avLst/>
+          </a:prstGeom>
+          <a:noFill/>
+        </p:spPr>
+        <p:txBody>
+          <a:bodyPr wrap="square">
+            <a:spAutoFit/>
+          </a:bodyPr>
+          <a:lstStyle/>
+          <a:p>
+            <a:pPr>
+              <a:defRPr>
+                <a:latin typeface="Arial"/>
+              </a:defRPr>
+            </a:pPr>
+          </a:p>
+        </p:txBody>
+      </p:sp>
+      <p:sp>
+        <p:nvSpPr>
+          <p:cNvPr id="4" name="TextBox 3"/>
+          <p:cNvSpPr txBox="1"/>
+          <p:nvPr/>
+        </p:nvSpPr>
+        <p:spPr>
+          <a:xfrm>
+            <a:off x="548640" y="5852160"/>
+            <a:ext cx="10972800" cy="731520"/>
+          </a:xfrm>
+          <a:prstGeom prst="rect">
+            <a:avLst/>
+          </a:prstGeom>
+          <a:noFill/>
+        </p:spPr>
+        <p:txBody>
+          <a:bodyPr wrap="square">
+            <a:spAutoFit/>
+          </a:bodyPr>
+          <a:lstStyle/>
+          <a:p>
+            <a:pPr>
+              <a:spcAft>
+                <a:spcPts val="800"/>
+              </a:spcAft>
+              <a:defRPr sz="1800" b="1">
+                <a:solidFill>
+                  <a:srgbClr val="B03030"/>
+                </a:solidFill>
+                <a:latin typeface="Arial"/>
+              </a:defRPr>
+            </a:pPr>
+            <a:r>
+              <a:rPr>
+                <a:latin typeface="Arial"/>
+              </a:rPr>
+              <a:t>[PENDIENTE: comparativa del equipo: qué algoritmo funcionó mejor y por qué]</a:t>
+            </a:r>
+          </a:p>
+        </p:txBody>
+      </p:sp>
+    </p:spTree>
+  </p:cSld>
+  <p:clrMapOvr>
+    <a:masterClrMapping/>
+  </p:clrMapOvr>
+</p:sld>
+</file>
+
+<file path=ppt/slides/slide21.xml><?xml version="1.0" encoding="utf-8"?>
+<p:sld xmlns:a="http://schemas.openxmlformats.org/drawingml/2006/main" xmlns:p="http://schemas.openxmlformats.org/presentationml/2006/main" xmlns:r="http://schemas.openxmlformats.org/officeDocument/2006/relationships">
+  <p:cSld>
+    <p:spTree>
+      <p:nvGrpSpPr>
+        <p:cNvPr id="1" name=""/>
+        <p:cNvGrpSpPr/>
+        <p:nvPr/>
+      </p:nvGrpSpPr>
+      <p:grpSpPr/>
+      <p:sp>
+        <p:nvSpPr>
+          <p:cNvPr id="2" name="TextBox 1"/>
+          <p:cNvSpPr txBox="1"/>
+          <p:nvPr/>
+        </p:nvSpPr>
+        <p:spPr>
+          <a:xfrm>
+            <a:off x="548640" y="320040"/>
+            <a:ext cx="10972800" cy="914400"/>
+          </a:xfrm>
+          <a:prstGeom prst="rect">
+            <a:avLst/>
+          </a:prstGeom>
+          <a:noFill/>
+        </p:spPr>
+        <p:txBody>
+          <a:bodyPr wrap="square">
+            <a:spAutoFit/>
+          </a:bodyPr>
+          <a:lstStyle/>
+          <a:p>
+            <a:pPr>
+              <a:spcAft>
+                <a:spcPts val="800"/>
+              </a:spcAft>
+              <a:defRPr sz="3200" b="1">
+                <a:latin typeface="Arial"/>
+              </a:defRPr>
+            </a:pPr>
+            <a:r>
+              <a:rPr>
+                <a:latin typeface="Arial"/>
+              </a:rPr>
+              <a:t>Preguntas</a:t>
+            </a:r>
+          </a:p>
+        </p:txBody>
+      </p:sp>
+      <p:sp>
+        <p:nvSpPr>
+          <p:cNvPr id="3" name="TextBox 2"/>
+          <p:cNvSpPr txBox="1"/>
+          <p:nvPr/>
+        </p:nvSpPr>
+        <p:spPr>
+          <a:xfrm>
+            <a:off x="548640" y="1371600"/>
+            <a:ext cx="10972800" cy="4572000"/>
+          </a:xfrm>
+          <a:prstGeom prst="rect">
+            <a:avLst/>
+          </a:prstGeom>
+          <a:noFill/>
+        </p:spPr>
+        <p:txBody>
+          <a:bodyPr wrap="square">
+            <a:spAutoFit/>
+          </a:bodyPr>
+          <a:lstStyle/>
+          <a:p>
+            <a:pPr>
+              <a:spcAft>
+                <a:spcPts val="800"/>
+              </a:spcAft>
+              <a:defRPr sz="2000" b="0">
+                <a:latin typeface="Arial"/>
+              </a:defRPr>
+            </a:pPr>
+            <a:r>
+              <a:rPr>
+                <a:latin typeface="Arial"/>
+              </a:rPr>
+              <a:t>• Código y documento de descripción entregados en Atenea</a:t>
             </a:r>
           </a:p>
         </p:txBody>
@@ -6381,7 +8747,7 @@
         <p:spPr>
           <a:xfrm>
             <a:off x="5394960" y="1371600"/>
-            <a:ext cx="6583680" cy="1786999"/>
+            <a:ext cx="6583680" cy="4189615"/>
           </a:xfrm>
           <a:prstGeom prst="rect">
             <a:avLst/>

</xml_diff>

<commit_message>
docs(slides): actualitzar conclusions eliminant la mencio al silhouette score
</commit_message>
<xml_diff>
--- a/presentacion/expo_cpia.pptx
+++ b/presentacion/expo_cpia.pptx
@@ -7416,8 +7416,8 @@
         </p:nvSpPr>
         <p:spPr>
           <a:xfrm>
-            <a:off x="1463040" y="1828800"/>
-            <a:ext cx="9235440" cy="4023360"/>
+            <a:off x="1463040" y="1920240"/>
+            <a:ext cx="9235440" cy="3931920"/>
           </a:xfrm>
           <a:prstGeom prst="rect">
             <a:avLst/>
@@ -7432,9 +7432,9 @@
           <a:p>
             <a:pPr>
               <a:spcAft>
-                <a:spcPts val="1400"/>
+                <a:spcPts val="1600"/>
               </a:spcAft>
-              <a:defRPr sz="2000" b="1">
+              <a:defRPr sz="1500">
                 <a:solidFill>
                   <a:srgbClr val="000000"/>
                 </a:solidFill>
@@ -7445,15 +7445,15 @@
               <a:rPr>
                 <a:latin typeface="Arial"/>
               </a:rPr>
-              <a:t>Punts Clau del Projecte</a:t>
+              <a:t>✔  Física de bandes sense supervisió:  DBSCAN descobreix de manera autònoma les 3 fases de conducció (conductors, aïllants i semiconductors) a partir de propietats macroscòpiques.</a:t>
             </a:r>
           </a:p>
           <a:p>
             <a:pPr>
               <a:spcAft>
-                <a:spcPts val="1200"/>
+                <a:spcPts val="1600"/>
               </a:spcAft>
-              <a:defRPr sz="1400">
+              <a:defRPr sz="1500">
                 <a:solidFill>
                   <a:srgbClr val="000000"/>
                 </a:solidFill>
@@ -7464,15 +7464,15 @@
               <a:rPr>
                 <a:latin typeface="Arial"/>
               </a:rPr>
-              <a:t>✔  Física de bandes sense supervisió:  DBSCAN descobreix de manera autònoma les 3 fases de conducció (conductors, aïllants i semiconductors) a partir de propietats macroscòpiques.</a:t>
+              <a:t>✔  Immune a densitats dispars:  Supera K-Means agrupant simultàniament la ultradensitat dels metalls i la dispersió de 12 ordres de magnitud dels aïllants.</a:t>
             </a:r>
           </a:p>
           <a:p>
             <a:pPr>
               <a:spcAft>
-                <a:spcPts val="1200"/>
+                <a:spcPts val="1600"/>
               </a:spcAft>
-              <a:defRPr sz="1400">
+              <a:defRPr sz="1500">
                 <a:solidFill>
                   <a:srgbClr val="000000"/>
                 </a:solidFill>
@@ -7483,15 +7483,15 @@
               <a:rPr>
                 <a:latin typeface="Arial"/>
               </a:rPr>
-              <a:t>✔  Immune a densitats dispars:  Supera K-Means agrupant simultàniament la ultradensitat dels metalls i la dispersió de 12 ordres de magnitud dels aïllants.</a:t>
+              <a:t>✔  Variables òptimes:  L'escala logarítmica log₁₀(ρ) i el coeficient tèrmic quàntic α són suficients per separar completament els règims de transport.</a:t>
             </a:r>
           </a:p>
           <a:p>
             <a:pPr>
               <a:spcAft>
-                <a:spcPts val="1200"/>
+                <a:spcPts val="1600"/>
               </a:spcAft>
-              <a:defRPr sz="1400">
+              <a:defRPr sz="1500">
                 <a:solidFill>
                   <a:srgbClr val="000000"/>
                 </a:solidFill>
@@ -7502,26 +7502,7 @@
               <a:rPr>
                 <a:latin typeface="Arial"/>
               </a:rPr>
-              <a:t>✔  Variables òptimes:  L'escala logarítmica log₁₀(ρ) i el coeficient tèrmic quàntic α són suficients per separar completament els règims de transport.</a:t>
-            </a:r>
-          </a:p>
-          <a:p>
-            <a:pPr>
-              <a:spcAft>
-                <a:spcPts val="1200"/>
-              </a:spcAft>
-              <a:defRPr sz="1400">
-                <a:solidFill>
-                  <a:srgbClr val="000000"/>
-                </a:solidFill>
-                <a:latin typeface="Arial"/>
-              </a:defRPr>
-            </a:pPr>
-            <a:r>
-              <a:rPr>
-                <a:latin typeface="Arial"/>
-              </a:rPr>
-              <a:t>✔  Validació rotunda:  100% de puresa en conductors i aïllants amb Silhouette Score = 0.7858.</a:t>
+              <a:t>✔  Validació rotunda:  100% de puresa en conductors i aïllants</a:t>
             </a:r>
           </a:p>
         </p:txBody>

</xml_diff>